<commit_message>
Finalize Week 01 package and audit evidence
</commit_message>
<xml_diff>
--- a/.agent/lecture-slide-system/masters/PHY4605_Editable_Slide_Master.pptx
+++ b/.agent/lecture-slide-system/masters/PHY4605_Editable_Slide_Master.pptx
@@ -2,22 +2,22 @@
 <file path=ppt/presentation.xml><?xml version="1.0" encoding="utf-8"?>
 <p:presentation xmlns:p="http://schemas.openxmlformats.org/presentationml/2006/main">
   <p:sldMasterIdLst>
-    <p:sldMasterId xmlns:r="http://schemas.openxmlformats.org/officeDocument/2006/relationships" id="2147483648" r:id="Rb25793db681c42c8"/>
-    <p:sldMasterId xmlns:r="http://schemas.openxmlformats.org/officeDocument/2006/relationships" id="2147483650" r:id="R5639f0578fe54361"/>
+    <p:sldMasterId xmlns:r="http://schemas.openxmlformats.org/officeDocument/2006/relationships" id="2147483648" r:id="R5503cc249f1f4ce3"/>
+    <p:sldMasterId xmlns:r="http://schemas.openxmlformats.org/officeDocument/2006/relationships" id="2147483650" r:id="R3fb1e6e557114417"/>
   </p:sldMasterIdLst>
   <p:notesMasterIdLst>
-    <p:notesMasterId xmlns:r="http://schemas.openxmlformats.org/officeDocument/2006/relationships" r:id="R171cc1f3564248af"/>
+    <p:notesMasterId xmlns:r="http://schemas.openxmlformats.org/officeDocument/2006/relationships" r:id="R069110e5dbdb4326"/>
   </p:notesMasterIdLst>
   <p:sldIdLst>
-    <p:sldId xmlns:r="http://schemas.openxmlformats.org/officeDocument/2006/relationships" id="256" r:id="R9f1a724024c04f60"/>
-    <p:sldId xmlns:r="http://schemas.openxmlformats.org/officeDocument/2006/relationships" id="257" r:id="R14635daf0a304fb8"/>
-    <p:sldId xmlns:r="http://schemas.openxmlformats.org/officeDocument/2006/relationships" id="258" r:id="R106aec5db09d4b65"/>
-    <p:sldId xmlns:r="http://schemas.openxmlformats.org/officeDocument/2006/relationships" id="259" r:id="R407935f467654be9"/>
-    <p:sldId xmlns:r="http://schemas.openxmlformats.org/officeDocument/2006/relationships" id="260" r:id="Ra1379fa6671e4b37"/>
-    <p:sldId xmlns:r="http://schemas.openxmlformats.org/officeDocument/2006/relationships" id="261" r:id="Rb94c507458d3432d"/>
-    <p:sldId xmlns:r="http://schemas.openxmlformats.org/officeDocument/2006/relationships" id="262" r:id="R2074f99f852640e5"/>
-    <p:sldId xmlns:r="http://schemas.openxmlformats.org/officeDocument/2006/relationships" id="263" r:id="Rd2888fe3689d41f2"/>
-    <p:sldId xmlns:r="http://schemas.openxmlformats.org/officeDocument/2006/relationships" id="264" r:id="R57ba494c791541e0"/>
+    <p:sldId xmlns:r="http://schemas.openxmlformats.org/officeDocument/2006/relationships" id="256" r:id="R2699b5370d9e4616"/>
+    <p:sldId xmlns:r="http://schemas.openxmlformats.org/officeDocument/2006/relationships" id="257" r:id="R3fae09ef5d1a41d4"/>
+    <p:sldId xmlns:r="http://schemas.openxmlformats.org/officeDocument/2006/relationships" id="258" r:id="R38e87e3dc4514fb0"/>
+    <p:sldId xmlns:r="http://schemas.openxmlformats.org/officeDocument/2006/relationships" id="259" r:id="R976f6b9f08a74e6b"/>
+    <p:sldId xmlns:r="http://schemas.openxmlformats.org/officeDocument/2006/relationships" id="260" r:id="Rde9b865789b34dda"/>
+    <p:sldId xmlns:r="http://schemas.openxmlformats.org/officeDocument/2006/relationships" id="261" r:id="R67acc7f4e96d4b0b"/>
+    <p:sldId xmlns:r="http://schemas.openxmlformats.org/officeDocument/2006/relationships" id="262" r:id="R4917208f561a440e"/>
+    <p:sldId xmlns:r="http://schemas.openxmlformats.org/officeDocument/2006/relationships" id="263" r:id="R6210700d02b446d3"/>
+    <p:sldId xmlns:r="http://schemas.openxmlformats.org/officeDocument/2006/relationships" id="264" r:id="R4b041e11ae8f41a4"/>
   </p:sldIdLst>
   <p:sldSz cx="18288000" cy="10287000"/>
   <p:notesSz cx="6858000" cy="9144000"/>
@@ -936,7 +936,7 @@
           </a:p>
           <a:p xmlns:a="http://schemas.openxmlformats.org/drawingml/2006/main">
             <a:r>
-              <a:t>- symbolG: TeX `g`; SVG `.agent/lecture-slide-system/assets/equations/symbol-g.svg`; PNG `.agent/lecture-slide-system/assets/equations/symbol-g.png`; foreground `#6F4B9B`; target `110 × 48 px`; fit/crop `contain`; alt `LaTeX-rendered symbol g`; QA `render-equations-diagrams, PNG scale 6, retained TeX/SVG`</a:t>
+              <a:t>- symbolG: TeX `g`; SVG `.agent/lecture-slide-system/assets/equations/symbol-g.svg`; PNG `.agent/lecture-slide-system/assets/equations/symbol-g.png`; foreground `#C98A16`; target `110 × 48 px`; fit/crop `contain`; alt `LaTeX-rendered symbol g`; QA `render-equations-diagrams, PNG scale 6, retained TeX/SVG`</a:t>
             </a:r>
           </a:p>
           <a:p xmlns:a="http://schemas.openxmlformats.org/drawingml/2006/main">
@@ -2318,7 +2318,7 @@
   </p:cSld>
   <p:clrMap bg1="lt1" tx1="dk1" bg2="lt2" tx2="dk2" accent1="accent1" accent2="accent2" accent3="accent3" accent4="accent4" accent5="accent5" accent6="accent6" hlink="hlink" folHlink="folHlink"/>
   <p:sldLayoutIdLst>
-    <p:sldLayoutId xmlns:r="http://schemas.openxmlformats.org/officeDocument/2006/relationships" id="2147483649" r:id="R144cbd86bf4e4fa4"/>
+    <p:sldLayoutId xmlns:r="http://schemas.openxmlformats.org/officeDocument/2006/relationships" id="2147483649" r:id="Rb8ee8e6a99594e8c"/>
   </p:sldLayoutIdLst>
   <p:txStyles>
     <p:titleStyle>
@@ -2757,10 +2757,10 @@
   </p:cSld>
   <p:clrMap bg1="lt1" tx1="dk1" bg2="lt2" tx2="dk2" accent1="accent1" accent2="accent2" accent3="accent3" accent4="accent4" accent5="accent5" accent6="accent6" hlink="hlink" folHlink="folHlink"/>
   <p:sldLayoutIdLst>
-    <p:sldLayoutId xmlns:r="http://schemas.openxmlformats.org/officeDocument/2006/relationships" id="2147483651" r:id="Rb387210603ea415f"/>
-    <p:sldLayoutId xmlns:r="http://schemas.openxmlformats.org/officeDocument/2006/relationships" id="2147483652" r:id="R7d08c8750ee244c7"/>
-    <p:sldLayoutId xmlns:r="http://schemas.openxmlformats.org/officeDocument/2006/relationships" id="2147483653" r:id="R1311270d782b48c3"/>
-    <p:sldLayoutId xmlns:r="http://schemas.openxmlformats.org/officeDocument/2006/relationships" id="2147483654" r:id="R7917041c06be47cc"/>
+    <p:sldLayoutId xmlns:r="http://schemas.openxmlformats.org/officeDocument/2006/relationships" id="2147483651" r:id="Rdf0cbb7456c84f9b"/>
+    <p:sldLayoutId xmlns:r="http://schemas.openxmlformats.org/officeDocument/2006/relationships" id="2147483652" r:id="R65074857acbc4845"/>
+    <p:sldLayoutId xmlns:r="http://schemas.openxmlformats.org/officeDocument/2006/relationships" id="2147483653" r:id="R0775d1706fa94cbc"/>
+    <p:sldLayoutId xmlns:r="http://schemas.openxmlformats.org/officeDocument/2006/relationships" id="2147483654" r:id="Rd07d706a6c154865"/>
   </p:sldLayoutIdLst>
 </p:sldMaster>
 </file>
@@ -3279,7 +3279,7 @@
           <p:cNvPr id="18" name="course-tag">
             <a:extLst xmlns:a="http://schemas.openxmlformats.org/drawingml/2006/main">
               <a:ext uri="{FF2B5EF4-FFF2-40B4-BE49-F238E27FC236}">
-                <a16:creationId xmlns:a16="http://schemas.microsoft.com/office/drawing/2014/main" id="{F6DEE757-0BCB-4DDC-A149-3DF07AE0FFA4}"/>
+                <a16:creationId xmlns:a16="http://schemas.microsoft.com/office/drawing/2014/main" id="{CE6400EB-6D84-4ACA-88E5-6A8FD4818B4D}"/>
               </a:ext>
             </a:extLst>
           </p:cNvPr>
@@ -3337,7 +3337,7 @@
           <p:cNvPr id="2" name="opening-title">
             <a:extLst xmlns:a="http://schemas.openxmlformats.org/drawingml/2006/main">
               <a:ext uri="{FF2B5EF4-FFF2-40B4-BE49-F238E27FC236}">
-                <a16:creationId xmlns:a16="http://schemas.microsoft.com/office/drawing/2014/main" id="{97C39C58-07E7-44C3-A883-76F2F4809114}"/>
+                <a16:creationId xmlns:a16="http://schemas.microsoft.com/office/drawing/2014/main" id="{F52E7AD9-F9AA-4EEB-9723-3B92262DEA56}"/>
               </a:ext>
             </a:extLst>
           </p:cNvPr>
@@ -3399,7 +3399,7 @@
           <p:cNvPr id="3" name="opening-subtitle">
             <a:extLst xmlns:a="http://schemas.openxmlformats.org/drawingml/2006/main">
               <a:ext uri="{FF2B5EF4-FFF2-40B4-BE49-F238E27FC236}">
-                <a16:creationId xmlns:a16="http://schemas.microsoft.com/office/drawing/2014/main" id="{D05C0FEF-0090-401E-9062-2A107DD4C9E8}"/>
+                <a16:creationId xmlns:a16="http://schemas.microsoft.com/office/drawing/2014/main" id="{18A01F8F-BE0E-415B-9D55-7CFC6DF2196E}"/>
               </a:ext>
             </a:extLst>
           </p:cNvPr>
@@ -3461,7 +3461,7 @@
           <p:nvPr/>
         </p:nvPicPr>
         <p:blipFill>
-          <a:blip xmlns:r="http://schemas.openxmlformats.org/officeDocument/2006/relationships" xmlns:a="http://schemas.openxmlformats.org/drawingml/2006/main" r:embed="Rc5056658848f4414"/>
+          <a:blip xmlns:r="http://schemas.openxmlformats.org/officeDocument/2006/relationships" xmlns:a="http://schemas.openxmlformats.org/drawingml/2006/main" r:embed="R2164c454efae4fae"/>
           <a:stretch xmlns:a="http://schemas.openxmlformats.org/drawingml/2006/main"/>
         </p:blipFill>
         <p:spPr>
@@ -3479,7 +3479,7 @@
           <p:cNvPr id="5" name="">
             <a:extLst xmlns:a="http://schemas.openxmlformats.org/drawingml/2006/main">
               <a:ext uri="{FF2B5EF4-FFF2-40B4-BE49-F238E27FC236}">
-                <a16:creationId xmlns:a16="http://schemas.microsoft.com/office/drawing/2014/main" id="{D8379047-42E6-44D1-B70B-EE90586C27B1}"/>
+                <a16:creationId xmlns:a16="http://schemas.microsoft.com/office/drawing/2014/main" id="{C13C9355-D5C6-40D4-A775-668446B05313}"/>
               </a:ext>
             </a:extLst>
           </p:cNvPr>
@@ -3537,7 +3537,7 @@
           <p:cNvPr id="6" name="">
             <a:extLst xmlns:a="http://schemas.openxmlformats.org/drawingml/2006/main">
               <a:ext uri="{FF2B5EF4-FFF2-40B4-BE49-F238E27FC236}">
-                <a16:creationId xmlns:a16="http://schemas.microsoft.com/office/drawing/2014/main" id="{8D0994E9-5EFD-4AE4-902C-2837CF4C569B}"/>
+                <a16:creationId xmlns:a16="http://schemas.microsoft.com/office/drawing/2014/main" id="{A0B6CEFB-C3EA-435D-BE74-D71F792281A4}"/>
               </a:ext>
             </a:extLst>
           </p:cNvPr>
@@ -3595,7 +3595,7 @@
           <p:cNvPr id="7" name="">
             <a:extLst xmlns:a="http://schemas.openxmlformats.org/drawingml/2006/main">
               <a:ext uri="{FF2B5EF4-FFF2-40B4-BE49-F238E27FC236}">
-                <a16:creationId xmlns:a16="http://schemas.microsoft.com/office/drawing/2014/main" id="{8EA77797-5AFC-4B56-9380-7C078BCE9E32}"/>
+                <a16:creationId xmlns:a16="http://schemas.microsoft.com/office/drawing/2014/main" id="{9F702463-DCF5-4469-8DDA-6B7F8BC3BDF3}"/>
               </a:ext>
             </a:extLst>
           </p:cNvPr>
@@ -3653,7 +3653,7 @@
           <p:cNvPr id="8" name="">
             <a:extLst xmlns:a="http://schemas.openxmlformats.org/drawingml/2006/main">
               <a:ext uri="{FF2B5EF4-FFF2-40B4-BE49-F238E27FC236}">
-                <a16:creationId xmlns:a16="http://schemas.microsoft.com/office/drawing/2014/main" id="{BAD2D9A4-7761-428D-B1AB-D31F77122A11}"/>
+                <a16:creationId xmlns:a16="http://schemas.microsoft.com/office/drawing/2014/main" id="{05040E2B-E407-4E21-AC30-27CBAF3B4343}"/>
               </a:ext>
             </a:extLst>
           </p:cNvPr>
@@ -3684,7 +3684,7 @@
           <p:cNvPr id="9" name="">
             <a:extLst xmlns:a="http://schemas.openxmlformats.org/drawingml/2006/main">
               <a:ext uri="{FF2B5EF4-FFF2-40B4-BE49-F238E27FC236}">
-                <a16:creationId xmlns:a16="http://schemas.microsoft.com/office/drawing/2014/main" id="{79233D84-61FC-4D6D-BFE5-E1685B636116}"/>
+                <a16:creationId xmlns:a16="http://schemas.microsoft.com/office/drawing/2014/main" id="{AAB5C17C-D3D5-40D0-A781-56911BAAC7CF}"/>
               </a:ext>
             </a:extLst>
           </p:cNvPr>
@@ -3742,7 +3742,7 @@
           <p:cNvPr id="10" name="">
             <a:extLst xmlns:a="http://schemas.openxmlformats.org/drawingml/2006/main">
               <a:ext uri="{FF2B5EF4-FFF2-40B4-BE49-F238E27FC236}">
-                <a16:creationId xmlns:a16="http://schemas.microsoft.com/office/drawing/2014/main" id="{DFC4593B-613C-4E8D-BD6D-C2A846F6350C}"/>
+                <a16:creationId xmlns:a16="http://schemas.microsoft.com/office/drawing/2014/main" id="{C18B756C-0B34-4A58-A6CF-E2F57514C919}"/>
               </a:ext>
             </a:extLst>
           </p:cNvPr>
@@ -3804,7 +3804,7 @@
           <p:cNvPr id="11" name="">
             <a:extLst xmlns:a="http://schemas.openxmlformats.org/drawingml/2006/main">
               <a:ext uri="{FF2B5EF4-FFF2-40B4-BE49-F238E27FC236}">
-                <a16:creationId xmlns:a16="http://schemas.microsoft.com/office/drawing/2014/main" id="{C0695021-5DDC-4E3B-B9BD-A382924F0E46}"/>
+                <a16:creationId xmlns:a16="http://schemas.microsoft.com/office/drawing/2014/main" id="{033E0E6E-103C-4C89-923E-B2BB6B5B7288}"/>
               </a:ext>
             </a:extLst>
           </p:cNvPr>
@@ -3835,7 +3835,7 @@
           <p:cNvPr id="12" name="">
             <a:extLst xmlns:a="http://schemas.openxmlformats.org/drawingml/2006/main">
               <a:ext uri="{FF2B5EF4-FFF2-40B4-BE49-F238E27FC236}">
-                <a16:creationId xmlns:a16="http://schemas.microsoft.com/office/drawing/2014/main" id="{48924852-5FB0-450B-A5B3-6C3584A8DEA6}"/>
+                <a16:creationId xmlns:a16="http://schemas.microsoft.com/office/drawing/2014/main" id="{1E8AE32E-C253-4C80-9D66-8D8E27AD3B5A}"/>
               </a:ext>
             </a:extLst>
           </p:cNvPr>
@@ -3897,7 +3897,7 @@
           <p:cNvPr id="13" name="">
             <a:extLst xmlns:a="http://schemas.openxmlformats.org/drawingml/2006/main">
               <a:ext uri="{FF2B5EF4-FFF2-40B4-BE49-F238E27FC236}">
-                <a16:creationId xmlns:a16="http://schemas.microsoft.com/office/drawing/2014/main" id="{1170C20D-7A89-46C0-95F7-C020DFCC48DD}"/>
+                <a16:creationId xmlns:a16="http://schemas.microsoft.com/office/drawing/2014/main" id="{34A072E1-F07C-4679-A2E9-013AD940CF50}"/>
               </a:ext>
             </a:extLst>
           </p:cNvPr>
@@ -3928,7 +3928,7 @@
           <p:cNvPr id="14" name="">
             <a:extLst xmlns:a="http://schemas.openxmlformats.org/drawingml/2006/main">
               <a:ext uri="{FF2B5EF4-FFF2-40B4-BE49-F238E27FC236}">
-                <a16:creationId xmlns:a16="http://schemas.microsoft.com/office/drawing/2014/main" id="{4C2045D1-C586-402B-B7DF-D32A6886B5A3}"/>
+                <a16:creationId xmlns:a16="http://schemas.microsoft.com/office/drawing/2014/main" id="{644589DD-B3C1-403C-98C5-CA5B4B13CCDF}"/>
               </a:ext>
             </a:extLst>
           </p:cNvPr>
@@ -3990,7 +3990,7 @@
           <p:cNvPr id="15" name="">
             <a:extLst xmlns:a="http://schemas.openxmlformats.org/drawingml/2006/main">
               <a:ext uri="{FF2B5EF4-FFF2-40B4-BE49-F238E27FC236}">
-                <a16:creationId xmlns:a16="http://schemas.microsoft.com/office/drawing/2014/main" id="{CAD0215D-48D7-472F-80E5-3D64CEF14923}"/>
+                <a16:creationId xmlns:a16="http://schemas.microsoft.com/office/drawing/2014/main" id="{CEAEA117-6BBB-4024-96CF-D1A35807E5A0}"/>
               </a:ext>
             </a:extLst>
           </p:cNvPr>
@@ -4021,7 +4021,7 @@
           <p:cNvPr id="16" name="">
             <a:extLst xmlns:a="http://schemas.openxmlformats.org/drawingml/2006/main">
               <a:ext uri="{FF2B5EF4-FFF2-40B4-BE49-F238E27FC236}">
-                <a16:creationId xmlns:a16="http://schemas.microsoft.com/office/drawing/2014/main" id="{5A2B0ECA-21C3-44EB-B33C-360FE18DDDAC}"/>
+                <a16:creationId xmlns:a16="http://schemas.microsoft.com/office/drawing/2014/main" id="{9A297E97-BCCA-46C5-87D2-A7CCF1B3A52B}"/>
               </a:ext>
             </a:extLst>
           </p:cNvPr>
@@ -4083,7 +4083,7 @@
           <p:cNvPr id="17" name="">
             <a:extLst xmlns:a="http://schemas.openxmlformats.org/drawingml/2006/main">
               <a:ext uri="{FF2B5EF4-FFF2-40B4-BE49-F238E27FC236}">
-                <a16:creationId xmlns:a16="http://schemas.microsoft.com/office/drawing/2014/main" id="{7B00AF0B-4DFE-4169-92E8-442DA7A75C83}"/>
+                <a16:creationId xmlns:a16="http://schemas.microsoft.com/office/drawing/2014/main" id="{066D31EB-364E-42E8-975E-1B0E48293880}"/>
               </a:ext>
             </a:extLst>
           </p:cNvPr>
@@ -4139,7 +4139,7 @@
     </p:spTree>
     <p:extLst>
       <p:ext uri="{BB962C8B-B14F-4D97-AF65-F5344CB8AC3E}">
-        <p14:creationId xmlns:p14="http://schemas.microsoft.com/office/powerpoint/2010/main" val="1594995037"/>
+        <p14:creationId xmlns:p14="http://schemas.microsoft.com/office/powerpoint/2010/main" val="540047547"/>
       </p:ext>
     </p:extLst>
   </p:cSld>
@@ -4170,7 +4170,7 @@
           <p:cNvPr id="52" name="title-T1">
             <a:extLst xmlns:a="http://schemas.openxmlformats.org/drawingml/2006/main">
               <a:ext uri="{FF2B5EF4-FFF2-40B4-BE49-F238E27FC236}">
-                <a16:creationId xmlns:a16="http://schemas.microsoft.com/office/drawing/2014/main" id="{BB593B5A-0F05-4188-A590-0AD5A0C15C2E}"/>
+                <a16:creationId xmlns:a16="http://schemas.microsoft.com/office/drawing/2014/main" id="{CA975157-4D34-4BC0-B602-B4AADDA8193C}"/>
               </a:ext>
             </a:extLst>
           </p:cNvPr>
@@ -4232,7 +4232,7 @@
           <p:cNvPr id="2" name="subtitle-T1">
             <a:extLst xmlns:a="http://schemas.openxmlformats.org/drawingml/2006/main">
               <a:ext uri="{FF2B5EF4-FFF2-40B4-BE49-F238E27FC236}">
-                <a16:creationId xmlns:a16="http://schemas.microsoft.com/office/drawing/2014/main" id="{C9983D9D-7E6C-44BB-9310-7549D160557F}"/>
+                <a16:creationId xmlns:a16="http://schemas.microsoft.com/office/drawing/2014/main" id="{B78CBCFF-68D3-44BA-95DE-E5B43B5D08C0}"/>
               </a:ext>
             </a:extLst>
           </p:cNvPr>
@@ -4294,7 +4294,7 @@
           <p:nvPr/>
         </p:nvPicPr>
         <p:blipFill>
-          <a:blip xmlns:r="http://schemas.openxmlformats.org/officeDocument/2006/relationships" xmlns:a="http://schemas.openxmlformats.org/drawingml/2006/main" r:embed="R3b1568038d8a40fd"/>
+          <a:blip xmlns:r="http://schemas.openxmlformats.org/officeDocument/2006/relationships" xmlns:a="http://schemas.openxmlformats.org/drawingml/2006/main" r:embed="Rb95c309005494756"/>
           <a:stretch xmlns:a="http://schemas.openxmlformats.org/drawingml/2006/main"/>
         </p:blipFill>
         <p:spPr>
@@ -4312,7 +4312,7 @@
           <p:cNvPr id="4" name="">
             <a:extLst xmlns:a="http://schemas.openxmlformats.org/drawingml/2006/main">
               <a:ext uri="{FF2B5EF4-FFF2-40B4-BE49-F238E27FC236}">
-                <a16:creationId xmlns:a16="http://schemas.microsoft.com/office/drawing/2014/main" id="{048D43EB-01AA-4F24-94F6-D8292AE89853}"/>
+                <a16:creationId xmlns:a16="http://schemas.microsoft.com/office/drawing/2014/main" id="{9CF7D4D9-AFAF-43D0-B622-4F31BA45D5C5}"/>
               </a:ext>
             </a:extLst>
           </p:cNvPr>
@@ -4343,7 +4343,7 @@
           <p:cNvPr id="5" name="">
             <a:extLst xmlns:a="http://schemas.openxmlformats.org/drawingml/2006/main">
               <a:ext uri="{FF2B5EF4-FFF2-40B4-BE49-F238E27FC236}">
-                <a16:creationId xmlns:a16="http://schemas.microsoft.com/office/drawing/2014/main" id="{142DE747-0669-43AF-895F-1A7A2EEFC1B1}"/>
+                <a16:creationId xmlns:a16="http://schemas.microsoft.com/office/drawing/2014/main" id="{7D687010-1340-47D2-8266-539C54ACF213}"/>
               </a:ext>
             </a:extLst>
           </p:cNvPr>
@@ -4374,7 +4374,7 @@
           <p:cNvPr id="6" name="">
             <a:extLst xmlns:a="http://schemas.openxmlformats.org/drawingml/2006/main">
               <a:ext uri="{FF2B5EF4-FFF2-40B4-BE49-F238E27FC236}">
-                <a16:creationId xmlns:a16="http://schemas.microsoft.com/office/drawing/2014/main" id="{C95457D1-41F8-4AA6-973E-FEF3F059E6EB}"/>
+                <a16:creationId xmlns:a16="http://schemas.microsoft.com/office/drawing/2014/main" id="{71BC9803-B830-4F65-9C5E-65FBF88252CA}"/>
               </a:ext>
             </a:extLst>
           </p:cNvPr>
@@ -4407,7 +4407,7 @@
           <p:cNvPr id="7" name="">
             <a:extLst xmlns:a="http://schemas.openxmlformats.org/drawingml/2006/main">
               <a:ext uri="{FF2B5EF4-FFF2-40B4-BE49-F238E27FC236}">
-                <a16:creationId xmlns:a16="http://schemas.microsoft.com/office/drawing/2014/main" id="{197EC19F-1316-4BB3-990C-7FB4B43C31FB}"/>
+                <a16:creationId xmlns:a16="http://schemas.microsoft.com/office/drawing/2014/main" id="{71B77615-49E9-484D-8CCF-F130DC2D3EB0}"/>
               </a:ext>
             </a:extLst>
           </p:cNvPr>
@@ -4465,7 +4465,7 @@
           <p:cNvPr id="8" name="">
             <a:extLst xmlns:a="http://schemas.openxmlformats.org/drawingml/2006/main">
               <a:ext uri="{FF2B5EF4-FFF2-40B4-BE49-F238E27FC236}">
-                <a16:creationId xmlns:a16="http://schemas.microsoft.com/office/drawing/2014/main" id="{876CD317-C9D4-4105-A147-85A3DC5C7F76}"/>
+                <a16:creationId xmlns:a16="http://schemas.microsoft.com/office/drawing/2014/main" id="{075B2063-91A1-4E69-8592-D276D225CB19}"/>
               </a:ext>
             </a:extLst>
           </p:cNvPr>
@@ -4496,7 +4496,7 @@
           <p:cNvPr id="9" name="">
             <a:extLst xmlns:a="http://schemas.openxmlformats.org/drawingml/2006/main">
               <a:ext uri="{FF2B5EF4-FFF2-40B4-BE49-F238E27FC236}">
-                <a16:creationId xmlns:a16="http://schemas.microsoft.com/office/drawing/2014/main" id="{D94EA819-FFF2-45E7-A86A-6BA75EE3FDF7}"/>
+                <a16:creationId xmlns:a16="http://schemas.microsoft.com/office/drawing/2014/main" id="{6F112DA9-DD4F-4444-9627-C4CCC1AC331B}"/>
               </a:ext>
             </a:extLst>
           </p:cNvPr>
@@ -4529,7 +4529,7 @@
           <p:cNvPr id="10" name="">
             <a:extLst xmlns:a="http://schemas.openxmlformats.org/drawingml/2006/main">
               <a:ext uri="{FF2B5EF4-FFF2-40B4-BE49-F238E27FC236}">
-                <a16:creationId xmlns:a16="http://schemas.microsoft.com/office/drawing/2014/main" id="{B3FE04C7-8E5B-453D-90D7-483A68AA871A}"/>
+                <a16:creationId xmlns:a16="http://schemas.microsoft.com/office/drawing/2014/main" id="{1C2644D9-D567-4838-896C-B690C1FFC62D}"/>
               </a:ext>
             </a:extLst>
           </p:cNvPr>
@@ -4587,7 +4587,7 @@
           <p:cNvPr id="11" name="">
             <a:extLst xmlns:a="http://schemas.openxmlformats.org/drawingml/2006/main">
               <a:ext uri="{FF2B5EF4-FFF2-40B4-BE49-F238E27FC236}">
-                <a16:creationId xmlns:a16="http://schemas.microsoft.com/office/drawing/2014/main" id="{ED3ED37C-04B4-4941-9C82-3020724C97A7}"/>
+                <a16:creationId xmlns:a16="http://schemas.microsoft.com/office/drawing/2014/main" id="{4804DA58-D71E-49BB-8BC3-239B25F06F1D}"/>
               </a:ext>
             </a:extLst>
           </p:cNvPr>
@@ -4618,7 +4618,7 @@
           <p:cNvPr id="12" name="">
             <a:extLst xmlns:a="http://schemas.openxmlformats.org/drawingml/2006/main">
               <a:ext uri="{FF2B5EF4-FFF2-40B4-BE49-F238E27FC236}">
-                <a16:creationId xmlns:a16="http://schemas.microsoft.com/office/drawing/2014/main" id="{B8466040-6D5A-4384-B50F-32D1C2D089D0}"/>
+                <a16:creationId xmlns:a16="http://schemas.microsoft.com/office/drawing/2014/main" id="{16685913-B71D-4B48-9659-073C0B6F4865}"/>
               </a:ext>
             </a:extLst>
           </p:cNvPr>
@@ -4651,7 +4651,7 @@
           <p:cNvPr id="13" name="">
             <a:extLst xmlns:a="http://schemas.openxmlformats.org/drawingml/2006/main">
               <a:ext uri="{FF2B5EF4-FFF2-40B4-BE49-F238E27FC236}">
-                <a16:creationId xmlns:a16="http://schemas.microsoft.com/office/drawing/2014/main" id="{BFAE23CD-AB86-4D7F-A2A5-FF589E2EB5DF}"/>
+                <a16:creationId xmlns:a16="http://schemas.microsoft.com/office/drawing/2014/main" id="{7EBA3D02-E7E2-43D4-A175-F0A8AB7EB155}"/>
               </a:ext>
             </a:extLst>
           </p:cNvPr>
@@ -4709,7 +4709,7 @@
           <p:cNvPr id="14" name="">
             <a:extLst xmlns:a="http://schemas.openxmlformats.org/drawingml/2006/main">
               <a:ext uri="{FF2B5EF4-FFF2-40B4-BE49-F238E27FC236}">
-                <a16:creationId xmlns:a16="http://schemas.microsoft.com/office/drawing/2014/main" id="{6A60AC9D-A1AE-4EA5-BC76-A0ABA52A2A8B}"/>
+                <a16:creationId xmlns:a16="http://schemas.microsoft.com/office/drawing/2014/main" id="{B48B9187-A95F-49FF-8966-A57048493BFC}"/>
               </a:ext>
             </a:extLst>
           </p:cNvPr>
@@ -4740,7 +4740,7 @@
           <p:cNvPr id="15" name="">
             <a:extLst xmlns:a="http://schemas.openxmlformats.org/drawingml/2006/main">
               <a:ext uri="{FF2B5EF4-FFF2-40B4-BE49-F238E27FC236}">
-                <a16:creationId xmlns:a16="http://schemas.microsoft.com/office/drawing/2014/main" id="{7AC1AFF2-F2A2-4252-B6D2-F213F7C84FBB}"/>
+                <a16:creationId xmlns:a16="http://schemas.microsoft.com/office/drawing/2014/main" id="{EE413A3B-B201-4696-B191-55904AB557D5}"/>
               </a:ext>
             </a:extLst>
           </p:cNvPr>
@@ -4773,7 +4773,7 @@
           <p:cNvPr id="16" name="">
             <a:extLst xmlns:a="http://schemas.openxmlformats.org/drawingml/2006/main">
               <a:ext uri="{FF2B5EF4-FFF2-40B4-BE49-F238E27FC236}">
-                <a16:creationId xmlns:a16="http://schemas.microsoft.com/office/drawing/2014/main" id="{70F9D8FC-848B-47A7-BB22-E3695C90EED6}"/>
+                <a16:creationId xmlns:a16="http://schemas.microsoft.com/office/drawing/2014/main" id="{C0F3F1A0-8595-46E6-86D0-3C1B4B643C6F}"/>
               </a:ext>
             </a:extLst>
           </p:cNvPr>
@@ -4831,7 +4831,7 @@
           <p:cNvPr id="17" name="">
             <a:extLst xmlns:a="http://schemas.openxmlformats.org/drawingml/2006/main">
               <a:ext uri="{FF2B5EF4-FFF2-40B4-BE49-F238E27FC236}">
-                <a16:creationId xmlns:a16="http://schemas.microsoft.com/office/drawing/2014/main" id="{01DD0404-BADC-4C82-B3D3-DBD6038EA9B9}"/>
+                <a16:creationId xmlns:a16="http://schemas.microsoft.com/office/drawing/2014/main" id="{93DF29B3-5CE9-4C04-95D5-3D9FDB855DD3}"/>
               </a:ext>
             </a:extLst>
           </p:cNvPr>
@@ -4862,7 +4862,7 @@
           <p:cNvPr id="18" name="">
             <a:extLst xmlns:a="http://schemas.openxmlformats.org/drawingml/2006/main">
               <a:ext uri="{FF2B5EF4-FFF2-40B4-BE49-F238E27FC236}">
-                <a16:creationId xmlns:a16="http://schemas.microsoft.com/office/drawing/2014/main" id="{4D24E6E6-AE2C-43A2-913B-33643A11A234}"/>
+                <a16:creationId xmlns:a16="http://schemas.microsoft.com/office/drawing/2014/main" id="{42D6BB6D-30A7-4A74-9688-DFE905882779}"/>
               </a:ext>
             </a:extLst>
           </p:cNvPr>
@@ -4895,7 +4895,7 @@
           <p:cNvPr id="19" name="">
             <a:extLst xmlns:a="http://schemas.openxmlformats.org/drawingml/2006/main">
               <a:ext uri="{FF2B5EF4-FFF2-40B4-BE49-F238E27FC236}">
-                <a16:creationId xmlns:a16="http://schemas.microsoft.com/office/drawing/2014/main" id="{57A5ECA6-B1AA-4D25-AA4B-CC4AE97BED9C}"/>
+                <a16:creationId xmlns:a16="http://schemas.microsoft.com/office/drawing/2014/main" id="{BC66C58F-3C9A-4EC0-A66A-44F562623C58}"/>
               </a:ext>
             </a:extLst>
           </p:cNvPr>
@@ -4953,7 +4953,7 @@
           <p:cNvPr id="20" name="">
             <a:extLst xmlns:a="http://schemas.openxmlformats.org/drawingml/2006/main">
               <a:ext uri="{FF2B5EF4-FFF2-40B4-BE49-F238E27FC236}">
-                <a16:creationId xmlns:a16="http://schemas.microsoft.com/office/drawing/2014/main" id="{7811E6AF-CB3C-4952-B9B3-D428F0DAC7D6}"/>
+                <a16:creationId xmlns:a16="http://schemas.microsoft.com/office/drawing/2014/main" id="{BE8BC841-2F30-445B-B960-BCD9F7778816}"/>
               </a:ext>
             </a:extLst>
           </p:cNvPr>
@@ -4984,7 +4984,7 @@
           <p:cNvPr id="21" name="">
             <a:extLst xmlns:a="http://schemas.openxmlformats.org/drawingml/2006/main">
               <a:ext uri="{FF2B5EF4-FFF2-40B4-BE49-F238E27FC236}">
-                <a16:creationId xmlns:a16="http://schemas.microsoft.com/office/drawing/2014/main" id="{43C36A11-BB6A-4855-8908-842CDD6C2D77}"/>
+                <a16:creationId xmlns:a16="http://schemas.microsoft.com/office/drawing/2014/main" id="{1EA5628F-E983-4C41-8E03-59C7C85C9CAF}"/>
               </a:ext>
             </a:extLst>
           </p:cNvPr>
@@ -5017,7 +5017,7 @@
           <p:cNvPr id="22" name="">
             <a:extLst xmlns:a="http://schemas.openxmlformats.org/drawingml/2006/main">
               <a:ext uri="{FF2B5EF4-FFF2-40B4-BE49-F238E27FC236}">
-                <a16:creationId xmlns:a16="http://schemas.microsoft.com/office/drawing/2014/main" id="{950FA0E9-F935-41F4-BD4C-FDC9DA5F862B}"/>
+                <a16:creationId xmlns:a16="http://schemas.microsoft.com/office/drawing/2014/main" id="{00433986-F382-4F4F-9550-06757594C5EA}"/>
               </a:ext>
             </a:extLst>
           </p:cNvPr>
@@ -5075,7 +5075,7 @@
           <p:cNvPr id="23" name="">
             <a:extLst xmlns:a="http://schemas.openxmlformats.org/drawingml/2006/main">
               <a:ext uri="{FF2B5EF4-FFF2-40B4-BE49-F238E27FC236}">
-                <a16:creationId xmlns:a16="http://schemas.microsoft.com/office/drawing/2014/main" id="{C7AE96B6-A868-4003-BEC0-0C7ED6B59246}"/>
+                <a16:creationId xmlns:a16="http://schemas.microsoft.com/office/drawing/2014/main" id="{46E82074-BCB0-4EE8-84C9-0EAD00CD7730}"/>
               </a:ext>
             </a:extLst>
           </p:cNvPr>
@@ -5106,7 +5106,7 @@
           <p:cNvPr id="24" name="">
             <a:extLst xmlns:a="http://schemas.openxmlformats.org/drawingml/2006/main">
               <a:ext uri="{FF2B5EF4-FFF2-40B4-BE49-F238E27FC236}">
-                <a16:creationId xmlns:a16="http://schemas.microsoft.com/office/drawing/2014/main" id="{F0FB2A96-1D14-48BC-A057-C360A09C1C70}"/>
+                <a16:creationId xmlns:a16="http://schemas.microsoft.com/office/drawing/2014/main" id="{94B1E1C5-C703-41FC-8E88-E426BF02FEA1}"/>
               </a:ext>
             </a:extLst>
           </p:cNvPr>
@@ -5139,7 +5139,7 @@
           <p:cNvPr id="25" name="">
             <a:extLst xmlns:a="http://schemas.openxmlformats.org/drawingml/2006/main">
               <a:ext uri="{FF2B5EF4-FFF2-40B4-BE49-F238E27FC236}">
-                <a16:creationId xmlns:a16="http://schemas.microsoft.com/office/drawing/2014/main" id="{378FBA5D-682D-4C82-BAC3-9876A3091BC2}"/>
+                <a16:creationId xmlns:a16="http://schemas.microsoft.com/office/drawing/2014/main" id="{19196D5C-D928-4105-A37E-099D96667014}"/>
               </a:ext>
             </a:extLst>
           </p:cNvPr>
@@ -5197,7 +5197,7 @@
           <p:cNvPr id="26" name="">
             <a:extLst xmlns:a="http://schemas.openxmlformats.org/drawingml/2006/main">
               <a:ext uri="{FF2B5EF4-FFF2-40B4-BE49-F238E27FC236}">
-                <a16:creationId xmlns:a16="http://schemas.microsoft.com/office/drawing/2014/main" id="{99E33A42-0950-4A3F-9FE8-19A8057CF35A}"/>
+                <a16:creationId xmlns:a16="http://schemas.microsoft.com/office/drawing/2014/main" id="{04221DC2-2412-4435-9A7C-BE9CA28A65FA}"/>
               </a:ext>
             </a:extLst>
           </p:cNvPr>
@@ -5228,7 +5228,7 @@
           <p:cNvPr id="27" name="">
             <a:extLst xmlns:a="http://schemas.openxmlformats.org/drawingml/2006/main">
               <a:ext uri="{FF2B5EF4-FFF2-40B4-BE49-F238E27FC236}">
-                <a16:creationId xmlns:a16="http://schemas.microsoft.com/office/drawing/2014/main" id="{451BC53C-4BCF-4271-9958-720A95D1E4CD}"/>
+                <a16:creationId xmlns:a16="http://schemas.microsoft.com/office/drawing/2014/main" id="{CD6F3CF8-6B71-42C6-BBE1-B7957CB69E76}"/>
               </a:ext>
             </a:extLst>
           </p:cNvPr>
@@ -5261,7 +5261,7 @@
           <p:cNvPr id="28" name="">
             <a:extLst xmlns:a="http://schemas.openxmlformats.org/drawingml/2006/main">
               <a:ext uri="{FF2B5EF4-FFF2-40B4-BE49-F238E27FC236}">
-                <a16:creationId xmlns:a16="http://schemas.microsoft.com/office/drawing/2014/main" id="{BFFDF911-4DB8-4515-A5F2-15F28AE3609E}"/>
+                <a16:creationId xmlns:a16="http://schemas.microsoft.com/office/drawing/2014/main" id="{EF223D17-8574-4FFB-902F-5CC5720E1CB0}"/>
               </a:ext>
             </a:extLst>
           </p:cNvPr>
@@ -5319,7 +5319,7 @@
           <p:cNvPr id="29" name="">
             <a:extLst xmlns:a="http://schemas.openxmlformats.org/drawingml/2006/main">
               <a:ext uri="{FF2B5EF4-FFF2-40B4-BE49-F238E27FC236}">
-                <a16:creationId xmlns:a16="http://schemas.microsoft.com/office/drawing/2014/main" id="{7384CFF8-F1BA-4597-B65F-1CC68991DBFE}"/>
+                <a16:creationId xmlns:a16="http://schemas.microsoft.com/office/drawing/2014/main" id="{E40C4367-9741-4A52-9B83-86CBE2824582}"/>
               </a:ext>
             </a:extLst>
           </p:cNvPr>
@@ -5350,7 +5350,7 @@
           <p:cNvPr id="30" name="">
             <a:extLst xmlns:a="http://schemas.openxmlformats.org/drawingml/2006/main">
               <a:ext uri="{FF2B5EF4-FFF2-40B4-BE49-F238E27FC236}">
-                <a16:creationId xmlns:a16="http://schemas.microsoft.com/office/drawing/2014/main" id="{C48FCFFE-41E9-4AF8-8A19-67E694CF77E1}"/>
+                <a16:creationId xmlns:a16="http://schemas.microsoft.com/office/drawing/2014/main" id="{C223AB71-752F-407C-A4BF-DBA3A76582BF}"/>
               </a:ext>
             </a:extLst>
           </p:cNvPr>
@@ -5383,7 +5383,7 @@
           <p:cNvPr id="31" name="">
             <a:extLst xmlns:a="http://schemas.openxmlformats.org/drawingml/2006/main">
               <a:ext uri="{FF2B5EF4-FFF2-40B4-BE49-F238E27FC236}">
-                <a16:creationId xmlns:a16="http://schemas.microsoft.com/office/drawing/2014/main" id="{F9F2660E-797F-49BC-AAD0-4CF6492B94DE}"/>
+                <a16:creationId xmlns:a16="http://schemas.microsoft.com/office/drawing/2014/main" id="{F7F7962F-FCF3-45A4-B1CD-AFAAAE41987A}"/>
               </a:ext>
             </a:extLst>
           </p:cNvPr>
@@ -5441,7 +5441,7 @@
           <p:cNvPr id="32" name="">
             <a:extLst xmlns:a="http://schemas.openxmlformats.org/drawingml/2006/main">
               <a:ext uri="{FF2B5EF4-FFF2-40B4-BE49-F238E27FC236}">
-                <a16:creationId xmlns:a16="http://schemas.microsoft.com/office/drawing/2014/main" id="{650C7352-5AA7-4E2C-B8FC-BB4617EE3852}"/>
+                <a16:creationId xmlns:a16="http://schemas.microsoft.com/office/drawing/2014/main" id="{731DB297-3DEE-4483-99A9-D853B9DFD0C4}"/>
               </a:ext>
             </a:extLst>
           </p:cNvPr>
@@ -5472,7 +5472,7 @@
           <p:cNvPr id="33" name="">
             <a:extLst xmlns:a="http://schemas.openxmlformats.org/drawingml/2006/main">
               <a:ext uri="{FF2B5EF4-FFF2-40B4-BE49-F238E27FC236}">
-                <a16:creationId xmlns:a16="http://schemas.microsoft.com/office/drawing/2014/main" id="{44766686-2329-4B98-8597-7675AA083E5B}"/>
+                <a16:creationId xmlns:a16="http://schemas.microsoft.com/office/drawing/2014/main" id="{AA506D51-BC91-43A4-9290-B22176A95908}"/>
               </a:ext>
             </a:extLst>
           </p:cNvPr>
@@ -5505,7 +5505,7 @@
           <p:cNvPr id="34" name="">
             <a:extLst xmlns:a="http://schemas.openxmlformats.org/drawingml/2006/main">
               <a:ext uri="{FF2B5EF4-FFF2-40B4-BE49-F238E27FC236}">
-                <a16:creationId xmlns:a16="http://schemas.microsoft.com/office/drawing/2014/main" id="{5CA8BD6B-617C-4A52-ABEB-5C8EC26F2A11}"/>
+                <a16:creationId xmlns:a16="http://schemas.microsoft.com/office/drawing/2014/main" id="{703358F1-1838-4292-A00A-7D3A04AD23D5}"/>
               </a:ext>
             </a:extLst>
           </p:cNvPr>
@@ -5563,7 +5563,7 @@
           <p:cNvPr id="35" name="">
             <a:extLst xmlns:a="http://schemas.openxmlformats.org/drawingml/2006/main">
               <a:ext uri="{FF2B5EF4-FFF2-40B4-BE49-F238E27FC236}">
-                <a16:creationId xmlns:a16="http://schemas.microsoft.com/office/drawing/2014/main" id="{4319CCCA-08AA-46BD-9E1B-B01B532E53EB}"/>
+                <a16:creationId xmlns:a16="http://schemas.microsoft.com/office/drawing/2014/main" id="{14ADACA5-5227-4A7E-B080-288C47B772A9}"/>
               </a:ext>
             </a:extLst>
           </p:cNvPr>
@@ -5594,7 +5594,7 @@
           <p:cNvPr id="36" name="">
             <a:extLst xmlns:a="http://schemas.openxmlformats.org/drawingml/2006/main">
               <a:ext uri="{FF2B5EF4-FFF2-40B4-BE49-F238E27FC236}">
-                <a16:creationId xmlns:a16="http://schemas.microsoft.com/office/drawing/2014/main" id="{58DAF6EE-DE75-49C0-9F45-0589839B7CD4}"/>
+                <a16:creationId xmlns:a16="http://schemas.microsoft.com/office/drawing/2014/main" id="{346D0E2C-E4A3-4DB1-8754-D5F6E391A5ED}"/>
               </a:ext>
             </a:extLst>
           </p:cNvPr>
@@ -5627,7 +5627,7 @@
           <p:cNvPr id="37" name="">
             <a:extLst xmlns:a="http://schemas.openxmlformats.org/drawingml/2006/main">
               <a:ext uri="{FF2B5EF4-FFF2-40B4-BE49-F238E27FC236}">
-                <a16:creationId xmlns:a16="http://schemas.microsoft.com/office/drawing/2014/main" id="{7C8395C0-A61D-45BF-B536-A73F93619808}"/>
+                <a16:creationId xmlns:a16="http://schemas.microsoft.com/office/drawing/2014/main" id="{8ABB79F2-FAC7-4CA2-A832-332EF42A7DC5}"/>
               </a:ext>
             </a:extLst>
           </p:cNvPr>
@@ -5685,7 +5685,7 @@
           <p:cNvPr id="38" name="">
             <a:extLst xmlns:a="http://schemas.openxmlformats.org/drawingml/2006/main">
               <a:ext uri="{FF2B5EF4-FFF2-40B4-BE49-F238E27FC236}">
-                <a16:creationId xmlns:a16="http://schemas.microsoft.com/office/drawing/2014/main" id="{5CD7EF1B-1327-41EF-BD15-410DEB22D3BB}"/>
+                <a16:creationId xmlns:a16="http://schemas.microsoft.com/office/drawing/2014/main" id="{798DC0D3-FA72-432C-B9DD-AA7C3D7F72CD}"/>
               </a:ext>
             </a:extLst>
           </p:cNvPr>
@@ -5720,7 +5720,7 @@
           <p:cNvPr id="39" name="">
             <a:extLst xmlns:a="http://schemas.openxmlformats.org/drawingml/2006/main">
               <a:ext uri="{FF2B5EF4-FFF2-40B4-BE49-F238E27FC236}">
-                <a16:creationId xmlns:a16="http://schemas.microsoft.com/office/drawing/2014/main" id="{226F1CBD-CFC6-45D2-B77C-5917656D039E}"/>
+                <a16:creationId xmlns:a16="http://schemas.microsoft.com/office/drawing/2014/main" id="{9C1F6132-8975-4F1D-ADE6-E36A85ADBBE4}"/>
               </a:ext>
             </a:extLst>
           </p:cNvPr>
@@ -5782,7 +5782,7 @@
           <p:nvPr/>
         </p:nvPicPr>
         <p:blipFill>
-          <a:blip xmlns:r="http://schemas.openxmlformats.org/officeDocument/2006/relationships" xmlns:a="http://schemas.openxmlformats.org/drawingml/2006/main" r:embed="R63fb34e20ead4068"/>
+          <a:blip xmlns:r="http://schemas.openxmlformats.org/officeDocument/2006/relationships" xmlns:a="http://schemas.openxmlformats.org/drawingml/2006/main" r:embed="R49fbd20e6f544e3d"/>
           <a:stretch xmlns:a="http://schemas.openxmlformats.org/drawingml/2006/main"/>
         </p:blipFill>
         <p:spPr>
@@ -5800,7 +5800,7 @@
           <p:cNvPr id="41" name="">
             <a:extLst xmlns:a="http://schemas.openxmlformats.org/drawingml/2006/main">
               <a:ext uri="{FF2B5EF4-FFF2-40B4-BE49-F238E27FC236}">
-                <a16:creationId xmlns:a16="http://schemas.microsoft.com/office/drawing/2014/main" id="{12E6C616-E7D8-4C9C-8A18-33B6611AA863}"/>
+                <a16:creationId xmlns:a16="http://schemas.microsoft.com/office/drawing/2014/main" id="{3DC6DD88-1F57-4B5C-887E-A206EEBEC82A}"/>
               </a:ext>
             </a:extLst>
           </p:cNvPr>
@@ -5858,7 +5858,7 @@
           <p:cNvPr id="42" name="">
             <a:extLst xmlns:a="http://schemas.openxmlformats.org/drawingml/2006/main">
               <a:ext uri="{FF2B5EF4-FFF2-40B4-BE49-F238E27FC236}">
-                <a16:creationId xmlns:a16="http://schemas.microsoft.com/office/drawing/2014/main" id="{A006C5C9-8910-4F80-A429-E7CE0C798309}"/>
+                <a16:creationId xmlns:a16="http://schemas.microsoft.com/office/drawing/2014/main" id="{26CD00B7-98C7-4005-AFEB-DFC78C7F15CB}"/>
               </a:ext>
             </a:extLst>
           </p:cNvPr>
@@ -5893,7 +5893,7 @@
           <p:cNvPr id="43" name="">
             <a:extLst xmlns:a="http://schemas.openxmlformats.org/drawingml/2006/main">
               <a:ext uri="{FF2B5EF4-FFF2-40B4-BE49-F238E27FC236}">
-                <a16:creationId xmlns:a16="http://schemas.microsoft.com/office/drawing/2014/main" id="{5A810CD8-0177-457D-882F-11F00427F55D}"/>
+                <a16:creationId xmlns:a16="http://schemas.microsoft.com/office/drawing/2014/main" id="{9C42CC56-E5D4-41F9-8CD6-75D1AD67E6A1}"/>
               </a:ext>
             </a:extLst>
           </p:cNvPr>
@@ -5955,7 +5955,7 @@
           <p:nvPr/>
         </p:nvPicPr>
         <p:blipFill>
-          <a:blip xmlns:r="http://schemas.openxmlformats.org/officeDocument/2006/relationships" xmlns:a="http://schemas.openxmlformats.org/drawingml/2006/main" r:embed="R012b4033ffc44518"/>
+          <a:blip xmlns:r="http://schemas.openxmlformats.org/officeDocument/2006/relationships" xmlns:a="http://schemas.openxmlformats.org/drawingml/2006/main" r:embed="R612650c231764ab0"/>
           <a:stretch xmlns:a="http://schemas.openxmlformats.org/drawingml/2006/main"/>
         </p:blipFill>
         <p:spPr>
@@ -5973,7 +5973,7 @@
           <p:cNvPr id="45" name="">
             <a:extLst xmlns:a="http://schemas.openxmlformats.org/drawingml/2006/main">
               <a:ext uri="{FF2B5EF4-FFF2-40B4-BE49-F238E27FC236}">
-                <a16:creationId xmlns:a16="http://schemas.microsoft.com/office/drawing/2014/main" id="{642980F8-8523-41E2-857C-2FC2BD9E58CD}"/>
+                <a16:creationId xmlns:a16="http://schemas.microsoft.com/office/drawing/2014/main" id="{CF3C11B9-6AEC-4743-9894-2D4F1C5B1EFC}"/>
               </a:ext>
             </a:extLst>
           </p:cNvPr>
@@ -6031,7 +6031,7 @@
           <p:cNvPr id="46" name="">
             <a:extLst xmlns:a="http://schemas.openxmlformats.org/drawingml/2006/main">
               <a:ext uri="{FF2B5EF4-FFF2-40B4-BE49-F238E27FC236}">
-                <a16:creationId xmlns:a16="http://schemas.microsoft.com/office/drawing/2014/main" id="{11B6F3DE-FB92-42E6-AA0F-866C28B951C7}"/>
+                <a16:creationId xmlns:a16="http://schemas.microsoft.com/office/drawing/2014/main" id="{766B3966-088C-47F6-8BCE-20195160D66F}"/>
               </a:ext>
             </a:extLst>
           </p:cNvPr>
@@ -6066,7 +6066,7 @@
           <p:cNvPr id="47" name="">
             <a:extLst xmlns:a="http://schemas.openxmlformats.org/drawingml/2006/main">
               <a:ext uri="{FF2B5EF4-FFF2-40B4-BE49-F238E27FC236}">
-                <a16:creationId xmlns:a16="http://schemas.microsoft.com/office/drawing/2014/main" id="{75870DB9-C351-4370-A374-1B2C8796C879}"/>
+                <a16:creationId xmlns:a16="http://schemas.microsoft.com/office/drawing/2014/main" id="{31EF1B92-8F02-4703-B3BF-3AFAA00B0DEB}"/>
               </a:ext>
             </a:extLst>
           </p:cNvPr>
@@ -6128,7 +6128,7 @@
           <p:nvPr/>
         </p:nvPicPr>
         <p:blipFill>
-          <a:blip xmlns:r="http://schemas.openxmlformats.org/officeDocument/2006/relationships" xmlns:a="http://schemas.openxmlformats.org/drawingml/2006/main" r:embed="Rf88b60d6db4d4ee6"/>
+          <a:blip xmlns:r="http://schemas.openxmlformats.org/officeDocument/2006/relationships" xmlns:a="http://schemas.openxmlformats.org/drawingml/2006/main" r:embed="Rb8c9c9d76805474c"/>
           <a:stretch xmlns:a="http://schemas.openxmlformats.org/drawingml/2006/main"/>
         </p:blipFill>
         <p:spPr>
@@ -6146,7 +6146,7 @@
           <p:cNvPr id="49" name="">
             <a:extLst xmlns:a="http://schemas.openxmlformats.org/drawingml/2006/main">
               <a:ext uri="{FF2B5EF4-FFF2-40B4-BE49-F238E27FC236}">
-                <a16:creationId xmlns:a16="http://schemas.microsoft.com/office/drawing/2014/main" id="{FC000621-1AB5-425C-AC36-97F6E2442646}"/>
+                <a16:creationId xmlns:a16="http://schemas.microsoft.com/office/drawing/2014/main" id="{BE3834B9-0CCF-4664-A255-201532513A0B}"/>
               </a:ext>
             </a:extLst>
           </p:cNvPr>
@@ -6204,7 +6204,7 @@
           <p:cNvPr id="50" name="">
             <a:extLst xmlns:a="http://schemas.openxmlformats.org/drawingml/2006/main">
               <a:ext uri="{FF2B5EF4-FFF2-40B4-BE49-F238E27FC236}">
-                <a16:creationId xmlns:a16="http://schemas.microsoft.com/office/drawing/2014/main" id="{0EFE54BD-1401-4DF8-957D-B6E4712B5E58}"/>
+                <a16:creationId xmlns:a16="http://schemas.microsoft.com/office/drawing/2014/main" id="{CB7F945C-4070-40B8-813C-2A9E91229175}"/>
               </a:ext>
             </a:extLst>
           </p:cNvPr>
@@ -6262,7 +6262,7 @@
           <p:cNvPr id="51" name="slide-number-2">
             <a:extLst xmlns:a="http://schemas.openxmlformats.org/drawingml/2006/main">
               <a:ext uri="{FF2B5EF4-FFF2-40B4-BE49-F238E27FC236}">
-                <a16:creationId xmlns:a16="http://schemas.microsoft.com/office/drawing/2014/main" id="{FDA11671-9C8E-401D-86B9-37422B89668D}"/>
+                <a16:creationId xmlns:a16="http://schemas.microsoft.com/office/drawing/2014/main" id="{FFA22432-6DEC-49B6-8E73-7629A7BD1277}"/>
               </a:ext>
             </a:extLst>
           </p:cNvPr>
@@ -6318,7 +6318,7 @@
     </p:spTree>
     <p:extLst>
       <p:ext uri="{BB962C8B-B14F-4D97-AF65-F5344CB8AC3E}">
-        <p14:creationId xmlns:p14="http://schemas.microsoft.com/office/powerpoint/2010/main" val="29980604"/>
+        <p14:creationId xmlns:p14="http://schemas.microsoft.com/office/powerpoint/2010/main" val="669557018"/>
       </p:ext>
     </p:extLst>
   </p:cSld>
@@ -6349,7 +6349,7 @@
           <p:cNvPr id="15" name="title-T2">
             <a:extLst xmlns:a="http://schemas.openxmlformats.org/drawingml/2006/main">
               <a:ext uri="{FF2B5EF4-FFF2-40B4-BE49-F238E27FC236}">
-                <a16:creationId xmlns:a16="http://schemas.microsoft.com/office/drawing/2014/main" id="{1E6F3FFC-3BB1-4B19-9449-BB398594DCE5}"/>
+                <a16:creationId xmlns:a16="http://schemas.microsoft.com/office/drawing/2014/main" id="{8C0DF0C3-9B54-41C4-8151-E664591D4A44}"/>
               </a:ext>
             </a:extLst>
           </p:cNvPr>
@@ -6411,7 +6411,7 @@
           <p:cNvPr id="2" name="subtitle-T2">
             <a:extLst xmlns:a="http://schemas.openxmlformats.org/drawingml/2006/main">
               <a:ext uri="{FF2B5EF4-FFF2-40B4-BE49-F238E27FC236}">
-                <a16:creationId xmlns:a16="http://schemas.microsoft.com/office/drawing/2014/main" id="{D618E7E2-4E45-47EB-A3BA-00CD4F031D22}"/>
+                <a16:creationId xmlns:a16="http://schemas.microsoft.com/office/drawing/2014/main" id="{376D9BD3-AF88-46A4-BCAA-0D31F7604161}"/>
               </a:ext>
             </a:extLst>
           </p:cNvPr>
@@ -6469,7 +6469,7 @@
           <p:cNvPr id="3" name="">
             <a:extLst xmlns:a="http://schemas.openxmlformats.org/drawingml/2006/main">
               <a:ext uri="{FF2B5EF4-FFF2-40B4-BE49-F238E27FC236}">
-                <a16:creationId xmlns:a16="http://schemas.microsoft.com/office/drawing/2014/main" id="{E226DA71-4C9F-4507-B05F-3E944E06466C}"/>
+                <a16:creationId xmlns:a16="http://schemas.microsoft.com/office/drawing/2014/main" id="{EAE8FDDF-BC46-4115-A444-20DF56B56136}"/>
               </a:ext>
             </a:extLst>
           </p:cNvPr>
@@ -6504,7 +6504,7 @@
           <p:cNvPr id="4" name="">
             <a:extLst xmlns:a="http://schemas.openxmlformats.org/drawingml/2006/main">
               <a:ext uri="{FF2B5EF4-FFF2-40B4-BE49-F238E27FC236}">
-                <a16:creationId xmlns:a16="http://schemas.microsoft.com/office/drawing/2014/main" id="{BAFBCF20-887B-40A8-8F6B-B1007CC937F7}"/>
+                <a16:creationId xmlns:a16="http://schemas.microsoft.com/office/drawing/2014/main" id="{63B566CE-03DD-464E-8BE7-9E60D4A4DB52}"/>
               </a:ext>
             </a:extLst>
           </p:cNvPr>
@@ -6562,7 +6562,7 @@
           <p:cNvPr id="5" name="">
             <a:extLst xmlns:a="http://schemas.openxmlformats.org/drawingml/2006/main">
               <a:ext uri="{FF2B5EF4-FFF2-40B4-BE49-F238E27FC236}">
-                <a16:creationId xmlns:a16="http://schemas.microsoft.com/office/drawing/2014/main" id="{1A9D741B-6682-4D1A-9C65-97B29A1BFECB}"/>
+                <a16:creationId xmlns:a16="http://schemas.microsoft.com/office/drawing/2014/main" id="{BCBD4FF3-2C57-4454-A2EF-8AD27A88E185}"/>
               </a:ext>
             </a:extLst>
           </p:cNvPr>
@@ -6624,7 +6624,7 @@
           <p:nvPr/>
         </p:nvPicPr>
         <p:blipFill>
-          <a:blip xmlns:r="http://schemas.openxmlformats.org/officeDocument/2006/relationships" xmlns:a="http://schemas.openxmlformats.org/drawingml/2006/main" r:embed="Rb97d6dd8ede44d98"/>
+          <a:blip xmlns:r="http://schemas.openxmlformats.org/officeDocument/2006/relationships" xmlns:a="http://schemas.openxmlformats.org/drawingml/2006/main" r:embed="R6af40ee71bcc40bd"/>
           <a:stretch xmlns:a="http://schemas.openxmlformats.org/drawingml/2006/main"/>
         </p:blipFill>
         <p:spPr>
@@ -6642,7 +6642,7 @@
           <p:cNvPr id="7" name="">
             <a:extLst xmlns:a="http://schemas.openxmlformats.org/drawingml/2006/main">
               <a:ext uri="{FF2B5EF4-FFF2-40B4-BE49-F238E27FC236}">
-                <a16:creationId xmlns:a16="http://schemas.microsoft.com/office/drawing/2014/main" id="{6932A8CB-472F-4A14-B2FE-5AA7D801C5F7}"/>
+                <a16:creationId xmlns:a16="http://schemas.microsoft.com/office/drawing/2014/main" id="{4689109E-AB98-4BFC-8C18-9E9A92C35CA3}"/>
               </a:ext>
             </a:extLst>
           </p:cNvPr>
@@ -6700,7 +6700,7 @@
           <p:cNvPr id="8" name="">
             <a:extLst xmlns:a="http://schemas.openxmlformats.org/drawingml/2006/main">
               <a:ext uri="{FF2B5EF4-FFF2-40B4-BE49-F238E27FC236}">
-                <a16:creationId xmlns:a16="http://schemas.microsoft.com/office/drawing/2014/main" id="{30213A9F-7EB6-419D-9E39-74F11AE7A465}"/>
+                <a16:creationId xmlns:a16="http://schemas.microsoft.com/office/drawing/2014/main" id="{A4642906-20AC-437E-8086-EB5802B395E7}"/>
               </a:ext>
             </a:extLst>
           </p:cNvPr>
@@ -6758,7 +6758,7 @@
           <p:cNvPr id="9" name="">
             <a:extLst xmlns:a="http://schemas.openxmlformats.org/drawingml/2006/main">
               <a:ext uri="{FF2B5EF4-FFF2-40B4-BE49-F238E27FC236}">
-                <a16:creationId xmlns:a16="http://schemas.microsoft.com/office/drawing/2014/main" id="{952F3D1B-4077-4B31-907A-893122498287}"/>
+                <a16:creationId xmlns:a16="http://schemas.microsoft.com/office/drawing/2014/main" id="{58BD4D0F-E1F9-4868-AA46-66D2A7FF9989}"/>
               </a:ext>
             </a:extLst>
           </p:cNvPr>
@@ -6820,7 +6820,7 @@
           <p:nvPr/>
         </p:nvPicPr>
         <p:blipFill>
-          <a:blip xmlns:r="http://schemas.openxmlformats.org/officeDocument/2006/relationships" xmlns:a="http://schemas.openxmlformats.org/drawingml/2006/main" r:embed="Rbb3a12eb46db4136"/>
+          <a:blip xmlns:r="http://schemas.openxmlformats.org/officeDocument/2006/relationships" xmlns:a="http://schemas.openxmlformats.org/drawingml/2006/main" r:embed="R362a4f14649f447e"/>
           <a:stretch xmlns:a="http://schemas.openxmlformats.org/drawingml/2006/main"/>
         </p:blipFill>
         <p:spPr>
@@ -6838,7 +6838,7 @@
           <p:cNvPr id="11" name="">
             <a:extLst xmlns:a="http://schemas.openxmlformats.org/drawingml/2006/main">
               <a:ext uri="{FF2B5EF4-FFF2-40B4-BE49-F238E27FC236}">
-                <a16:creationId xmlns:a16="http://schemas.microsoft.com/office/drawing/2014/main" id="{58027D01-CA9F-4284-B7E3-8817D59E85C0}"/>
+                <a16:creationId xmlns:a16="http://schemas.microsoft.com/office/drawing/2014/main" id="{1291E696-C2BD-4991-BEB5-E5A1BF157445}"/>
               </a:ext>
             </a:extLst>
           </p:cNvPr>
@@ -6904,7 +6904,7 @@
           <p:nvPr/>
         </p:nvPicPr>
         <p:blipFill>
-          <a:blip xmlns:r="http://schemas.openxmlformats.org/officeDocument/2006/relationships" xmlns:a="http://schemas.openxmlformats.org/drawingml/2006/main" r:embed="Rf80205d1853148d7"/>
+          <a:blip xmlns:r="http://schemas.openxmlformats.org/officeDocument/2006/relationships" xmlns:a="http://schemas.openxmlformats.org/drawingml/2006/main" r:embed="R9a93962bbe2d423e"/>
           <a:stretch xmlns:a="http://schemas.openxmlformats.org/drawingml/2006/main"/>
         </p:blipFill>
         <p:spPr>
@@ -6922,7 +6922,7 @@
           <p:cNvPr id="13" name="">
             <a:extLst xmlns:a="http://schemas.openxmlformats.org/drawingml/2006/main">
               <a:ext uri="{FF2B5EF4-FFF2-40B4-BE49-F238E27FC236}">
-                <a16:creationId xmlns:a16="http://schemas.microsoft.com/office/drawing/2014/main" id="{CC0CDB1B-B810-47A9-83D9-0CC0D73E4BAD}"/>
+                <a16:creationId xmlns:a16="http://schemas.microsoft.com/office/drawing/2014/main" id="{39423741-4562-4401-9F1E-FBEDCC859711}"/>
               </a:ext>
             </a:extLst>
           </p:cNvPr>
@@ -6980,7 +6980,7 @@
           <p:cNvPr id="14" name="slide-number-3">
             <a:extLst xmlns:a="http://schemas.openxmlformats.org/drawingml/2006/main">
               <a:ext uri="{FF2B5EF4-FFF2-40B4-BE49-F238E27FC236}">
-                <a16:creationId xmlns:a16="http://schemas.microsoft.com/office/drawing/2014/main" id="{1A75AF0E-228A-4296-8AAD-BC2C4DEF42A1}"/>
+                <a16:creationId xmlns:a16="http://schemas.microsoft.com/office/drawing/2014/main" id="{735A5AC4-4ACB-4FD8-8E83-890307F832DC}"/>
               </a:ext>
             </a:extLst>
           </p:cNvPr>
@@ -7036,7 +7036,7 @@
     </p:spTree>
     <p:extLst>
       <p:ext uri="{BB962C8B-B14F-4D97-AF65-F5344CB8AC3E}">
-        <p14:creationId xmlns:p14="http://schemas.microsoft.com/office/powerpoint/2010/main" val="1577626368"/>
+        <p14:creationId xmlns:p14="http://schemas.microsoft.com/office/powerpoint/2010/main" val="791925073"/>
       </p:ext>
     </p:extLst>
   </p:cSld>
@@ -7067,7 +7067,7 @@
           <p:cNvPr id="18" name="title-T3">
             <a:extLst xmlns:a="http://schemas.openxmlformats.org/drawingml/2006/main">
               <a:ext uri="{FF2B5EF4-FFF2-40B4-BE49-F238E27FC236}">
-                <a16:creationId xmlns:a16="http://schemas.microsoft.com/office/drawing/2014/main" id="{626D4692-587E-46D7-A738-BAC0EDDA2871}"/>
+                <a16:creationId xmlns:a16="http://schemas.microsoft.com/office/drawing/2014/main" id="{FCFE3C73-35F2-436E-B6BD-EE8BEF47E966}"/>
               </a:ext>
             </a:extLst>
           </p:cNvPr>
@@ -7156,7 +7156,7 @@
           <p:cNvPr id="2" name="subtitle-T3">
             <a:extLst xmlns:a="http://schemas.openxmlformats.org/drawingml/2006/main">
               <a:ext uri="{FF2B5EF4-FFF2-40B4-BE49-F238E27FC236}">
-                <a16:creationId xmlns:a16="http://schemas.microsoft.com/office/drawing/2014/main" id="{A4C51AAB-71DD-4F63-9231-D4CF084591B1}"/>
+                <a16:creationId xmlns:a16="http://schemas.microsoft.com/office/drawing/2014/main" id="{F4BA773C-B81F-4215-B888-0799880B39E2}"/>
               </a:ext>
             </a:extLst>
           </p:cNvPr>
@@ -7214,7 +7214,7 @@
           <p:cNvPr id="3" name="">
             <a:extLst xmlns:a="http://schemas.openxmlformats.org/drawingml/2006/main">
               <a:ext uri="{FF2B5EF4-FFF2-40B4-BE49-F238E27FC236}">
-                <a16:creationId xmlns:a16="http://schemas.microsoft.com/office/drawing/2014/main" id="{C3130175-720F-4FF7-A398-582A1545FC62}"/>
+                <a16:creationId xmlns:a16="http://schemas.microsoft.com/office/drawing/2014/main" id="{CA170234-2869-49D8-B224-E3C6F150DB85}"/>
               </a:ext>
             </a:extLst>
           </p:cNvPr>
@@ -7276,7 +7276,7 @@
           <p:nvPr/>
         </p:nvPicPr>
         <p:blipFill>
-          <a:blip xmlns:r="http://schemas.openxmlformats.org/officeDocument/2006/relationships" xmlns:a="http://schemas.openxmlformats.org/drawingml/2006/main" r:embed="R979dc0ad5dd44d42"/>
+          <a:blip xmlns:r="http://schemas.openxmlformats.org/officeDocument/2006/relationships" xmlns:a="http://schemas.openxmlformats.org/drawingml/2006/main" r:embed="Ra0b9cd33cdc34c7a"/>
           <a:stretch xmlns:a="http://schemas.openxmlformats.org/drawingml/2006/main"/>
         </p:blipFill>
         <p:spPr>
@@ -7294,7 +7294,7 @@
           <p:cNvPr id="5" name="">
             <a:extLst xmlns:a="http://schemas.openxmlformats.org/drawingml/2006/main">
               <a:ext uri="{FF2B5EF4-FFF2-40B4-BE49-F238E27FC236}">
-                <a16:creationId xmlns:a16="http://schemas.microsoft.com/office/drawing/2014/main" id="{98A320FE-3EE3-41BC-BE8F-3900D85ED1CE}"/>
+                <a16:creationId xmlns:a16="http://schemas.microsoft.com/office/drawing/2014/main" id="{6BC41C1B-E1EE-4EEB-B45F-37612E07E382}"/>
               </a:ext>
             </a:extLst>
           </p:cNvPr>
@@ -7329,7 +7329,7 @@
           <p:cNvPr id="6" name="">
             <a:extLst xmlns:a="http://schemas.openxmlformats.org/drawingml/2006/main">
               <a:ext uri="{FF2B5EF4-FFF2-40B4-BE49-F238E27FC236}">
-                <a16:creationId xmlns:a16="http://schemas.microsoft.com/office/drawing/2014/main" id="{BB2EDE8E-1500-49D3-82EC-6D4835F80EC4}"/>
+                <a16:creationId xmlns:a16="http://schemas.microsoft.com/office/drawing/2014/main" id="{BAD96FB0-92B1-45AB-AECE-82FB01ABCF9F}"/>
               </a:ext>
             </a:extLst>
           </p:cNvPr>
@@ -7391,7 +7391,7 @@
           <p:nvPr/>
         </p:nvPicPr>
         <p:blipFill>
-          <a:blip xmlns:r="http://schemas.openxmlformats.org/officeDocument/2006/relationships" xmlns:a="http://schemas.openxmlformats.org/drawingml/2006/main" r:embed="Raf3313667eb644e0"/>
+          <a:blip xmlns:r="http://schemas.openxmlformats.org/officeDocument/2006/relationships" xmlns:a="http://schemas.openxmlformats.org/drawingml/2006/main" r:embed="R3815dabd60034339"/>
           <a:stretch xmlns:a="http://schemas.openxmlformats.org/drawingml/2006/main"/>
         </p:blipFill>
         <p:spPr>
@@ -7409,7 +7409,7 @@
           <p:cNvPr id="8" name="">
             <a:extLst xmlns:a="http://schemas.openxmlformats.org/drawingml/2006/main">
               <a:ext uri="{FF2B5EF4-FFF2-40B4-BE49-F238E27FC236}">
-                <a16:creationId xmlns:a16="http://schemas.microsoft.com/office/drawing/2014/main" id="{5DBD01C5-3553-4AA7-BFA4-04C5B3F7CA08}"/>
+                <a16:creationId xmlns:a16="http://schemas.microsoft.com/office/drawing/2014/main" id="{2731F051-7416-4B0E-B3AA-C1DDA325EB5F}"/>
               </a:ext>
             </a:extLst>
           </p:cNvPr>
@@ -7471,7 +7471,7 @@
           <p:nvPr/>
         </p:nvPicPr>
         <p:blipFill>
-          <a:blip xmlns:r="http://schemas.openxmlformats.org/officeDocument/2006/relationships" xmlns:a="http://schemas.openxmlformats.org/drawingml/2006/main" r:embed="Ra957333ef93848b8"/>
+          <a:blip xmlns:r="http://schemas.openxmlformats.org/officeDocument/2006/relationships" xmlns:a="http://schemas.openxmlformats.org/drawingml/2006/main" r:embed="R1095a38d54444802"/>
           <a:stretch xmlns:a="http://schemas.openxmlformats.org/drawingml/2006/main"/>
         </p:blipFill>
         <p:spPr>
@@ -7489,7 +7489,7 @@
           <p:cNvPr id="10" name="">
             <a:extLst xmlns:a="http://schemas.openxmlformats.org/drawingml/2006/main">
               <a:ext uri="{FF2B5EF4-FFF2-40B4-BE49-F238E27FC236}">
-                <a16:creationId xmlns:a16="http://schemas.microsoft.com/office/drawing/2014/main" id="{87FF1276-2AC0-473F-BC87-6A187431117B}"/>
+                <a16:creationId xmlns:a16="http://schemas.microsoft.com/office/drawing/2014/main" id="{A7C29626-82D6-4DF3-9195-40D0CD0C79E8}"/>
               </a:ext>
             </a:extLst>
           </p:cNvPr>
@@ -7547,7 +7547,7 @@
           <p:cNvPr id="11" name="">
             <a:extLst xmlns:a="http://schemas.openxmlformats.org/drawingml/2006/main">
               <a:ext uri="{FF2B5EF4-FFF2-40B4-BE49-F238E27FC236}">
-                <a16:creationId xmlns:a16="http://schemas.microsoft.com/office/drawing/2014/main" id="{7313BDEA-EBFB-464C-8332-38DE80210B0E}"/>
+                <a16:creationId xmlns:a16="http://schemas.microsoft.com/office/drawing/2014/main" id="{1853E5D5-5DFF-447D-BDF1-7DFF456B1FA6}"/>
               </a:ext>
             </a:extLst>
           </p:cNvPr>
@@ -7586,7 +7586,7 @@
           <p:nvPr/>
         </p:nvPicPr>
         <p:blipFill>
-          <a:blip xmlns:r="http://schemas.openxmlformats.org/officeDocument/2006/relationships" xmlns:a="http://schemas.openxmlformats.org/drawingml/2006/main" r:embed="Rd394fe7687784313"/>
+          <a:blip xmlns:r="http://schemas.openxmlformats.org/officeDocument/2006/relationships" xmlns:a="http://schemas.openxmlformats.org/drawingml/2006/main" r:embed="Rdd92143cdcec4265"/>
           <a:stretch xmlns:a="http://schemas.openxmlformats.org/drawingml/2006/main"/>
         </p:blipFill>
         <p:spPr>
@@ -7604,7 +7604,7 @@
           <p:cNvPr id="13" name="">
             <a:extLst xmlns:a="http://schemas.openxmlformats.org/drawingml/2006/main">
               <a:ext uri="{FF2B5EF4-FFF2-40B4-BE49-F238E27FC236}">
-                <a16:creationId xmlns:a16="http://schemas.microsoft.com/office/drawing/2014/main" id="{2736D82C-D7AA-4BF4-BE29-A822F3C92780}"/>
+                <a16:creationId xmlns:a16="http://schemas.microsoft.com/office/drawing/2014/main" id="{FF734DBA-32E9-4A22-BAFF-C9795AD27957}"/>
               </a:ext>
             </a:extLst>
           </p:cNvPr>
@@ -7662,7 +7662,7 @@
           <p:cNvPr id="14" name="">
             <a:extLst xmlns:a="http://schemas.openxmlformats.org/drawingml/2006/main">
               <a:ext uri="{FF2B5EF4-FFF2-40B4-BE49-F238E27FC236}">
-                <a16:creationId xmlns:a16="http://schemas.microsoft.com/office/drawing/2014/main" id="{DA17DB9A-D8DF-4FAE-9B5E-DA2BBD4F5E98}"/>
+                <a16:creationId xmlns:a16="http://schemas.microsoft.com/office/drawing/2014/main" id="{0B7074BF-B18C-46CC-9362-9B80E777AAA0}"/>
               </a:ext>
             </a:extLst>
           </p:cNvPr>
@@ -7720,7 +7720,7 @@
           <p:cNvPr id="15" name="">
             <a:extLst xmlns:a="http://schemas.openxmlformats.org/drawingml/2006/main">
               <a:ext uri="{FF2B5EF4-FFF2-40B4-BE49-F238E27FC236}">
-                <a16:creationId xmlns:a16="http://schemas.microsoft.com/office/drawing/2014/main" id="{6824BDFF-55E8-4D38-AACA-3AB23AE75674}"/>
+                <a16:creationId xmlns:a16="http://schemas.microsoft.com/office/drawing/2014/main" id="{7467A044-C5E6-469E-9F83-E64B0E8FA1B4}"/>
               </a:ext>
             </a:extLst>
           </p:cNvPr>
@@ -7755,7 +7755,7 @@
           <p:cNvPr id="16" name="">
             <a:extLst xmlns:a="http://schemas.openxmlformats.org/drawingml/2006/main">
               <a:ext uri="{FF2B5EF4-FFF2-40B4-BE49-F238E27FC236}">
-                <a16:creationId xmlns:a16="http://schemas.microsoft.com/office/drawing/2014/main" id="{77245717-616D-496D-A4AD-FA2003758250}"/>
+                <a16:creationId xmlns:a16="http://schemas.microsoft.com/office/drawing/2014/main" id="{AB8396BC-94B5-4606-A6F5-1B1911AF5B50}"/>
               </a:ext>
             </a:extLst>
           </p:cNvPr>
@@ -7813,7 +7813,7 @@
           <p:cNvPr id="17" name="slide-number-4">
             <a:extLst xmlns:a="http://schemas.openxmlformats.org/drawingml/2006/main">
               <a:ext uri="{FF2B5EF4-FFF2-40B4-BE49-F238E27FC236}">
-                <a16:creationId xmlns:a16="http://schemas.microsoft.com/office/drawing/2014/main" id="{3A132826-6039-42C7-B945-7CACC58FFF6A}"/>
+                <a16:creationId xmlns:a16="http://schemas.microsoft.com/office/drawing/2014/main" id="{7729497F-F63C-4330-B20E-36C5EEADC46B}"/>
               </a:ext>
             </a:extLst>
           </p:cNvPr>
@@ -7869,7 +7869,7 @@
     </p:spTree>
     <p:extLst>
       <p:ext uri="{BB962C8B-B14F-4D97-AF65-F5344CB8AC3E}">
-        <p14:creationId xmlns:p14="http://schemas.microsoft.com/office/powerpoint/2010/main" val="1134815800"/>
+        <p14:creationId xmlns:p14="http://schemas.microsoft.com/office/powerpoint/2010/main" val="98733338"/>
       </p:ext>
     </p:extLst>
   </p:cSld>
@@ -7900,7 +7900,7 @@
           <p:cNvPr id="29" name="title-T1">
             <a:extLst xmlns:a="http://schemas.openxmlformats.org/drawingml/2006/main">
               <a:ext uri="{FF2B5EF4-FFF2-40B4-BE49-F238E27FC236}">
-                <a16:creationId xmlns:a16="http://schemas.microsoft.com/office/drawing/2014/main" id="{E98F86A9-39B1-4A12-8F30-E3A13AB922BD}"/>
+                <a16:creationId xmlns:a16="http://schemas.microsoft.com/office/drawing/2014/main" id="{913D7782-85D1-41B0-890F-F17436CB90BD}"/>
               </a:ext>
             </a:extLst>
           </p:cNvPr>
@@ -7962,7 +7962,7 @@
           <p:cNvPr id="2" name="subtitle-T1">
             <a:extLst xmlns:a="http://schemas.openxmlformats.org/drawingml/2006/main">
               <a:ext uri="{FF2B5EF4-FFF2-40B4-BE49-F238E27FC236}">
-                <a16:creationId xmlns:a16="http://schemas.microsoft.com/office/drawing/2014/main" id="{D5E1EF17-B814-4278-946E-16EDB75DC879}"/>
+                <a16:creationId xmlns:a16="http://schemas.microsoft.com/office/drawing/2014/main" id="{BC451CB8-7EC5-4311-A1F3-5E262B6AD14D}"/>
               </a:ext>
             </a:extLst>
           </p:cNvPr>
@@ -8020,7 +8020,7 @@
           <p:cNvPr id="3" name="">
             <a:extLst xmlns:a="http://schemas.openxmlformats.org/drawingml/2006/main">
               <a:ext uri="{FF2B5EF4-FFF2-40B4-BE49-F238E27FC236}">
-                <a16:creationId xmlns:a16="http://schemas.microsoft.com/office/drawing/2014/main" id="{9FF1ADA1-C5A2-4D7A-93DB-EC1ECA81A043}"/>
+                <a16:creationId xmlns:a16="http://schemas.microsoft.com/office/drawing/2014/main" id="{86AAD2C8-898E-4F52-811C-CCA47FE4C09B}"/>
               </a:ext>
             </a:extLst>
           </p:cNvPr>
@@ -8078,7 +8078,7 @@
           <p:cNvPr id="4" name="">
             <a:extLst xmlns:a="http://schemas.openxmlformats.org/drawingml/2006/main">
               <a:ext uri="{FF2B5EF4-FFF2-40B4-BE49-F238E27FC236}">
-                <a16:creationId xmlns:a16="http://schemas.microsoft.com/office/drawing/2014/main" id="{2F58989B-D2B4-4CA8-913A-18153574E47F}"/>
+                <a16:creationId xmlns:a16="http://schemas.microsoft.com/office/drawing/2014/main" id="{DC872571-EF06-4CA7-8E5C-1C0020BE0829}"/>
               </a:ext>
             </a:extLst>
           </p:cNvPr>
@@ -8136,7 +8136,7 @@
           <p:cNvPr id="5" name="">
             <a:extLst xmlns:a="http://schemas.openxmlformats.org/drawingml/2006/main">
               <a:ext uri="{FF2B5EF4-FFF2-40B4-BE49-F238E27FC236}">
-                <a16:creationId xmlns:a16="http://schemas.microsoft.com/office/drawing/2014/main" id="{4A089432-8E1A-4597-AB07-CD64382AFBC6}"/>
+                <a16:creationId xmlns:a16="http://schemas.microsoft.com/office/drawing/2014/main" id="{A6E60D49-B926-4BBE-8D4E-5A33649A65C7}"/>
               </a:ext>
             </a:extLst>
           </p:cNvPr>
@@ -8194,7 +8194,7 @@
           <p:cNvPr id="6" name="">
             <a:extLst xmlns:a="http://schemas.openxmlformats.org/drawingml/2006/main">
               <a:ext uri="{FF2B5EF4-FFF2-40B4-BE49-F238E27FC236}">
-                <a16:creationId xmlns:a16="http://schemas.microsoft.com/office/drawing/2014/main" id="{7ACC3D8A-6BE7-48E9-BE52-7A25E462FB40}"/>
+                <a16:creationId xmlns:a16="http://schemas.microsoft.com/office/drawing/2014/main" id="{DCE9D3B5-04CD-493D-84C2-BD62E0933590}"/>
               </a:ext>
             </a:extLst>
           </p:cNvPr>
@@ -8252,7 +8252,7 @@
           <p:cNvPr id="7" name="">
             <a:extLst xmlns:a="http://schemas.openxmlformats.org/drawingml/2006/main">
               <a:ext uri="{FF2B5EF4-FFF2-40B4-BE49-F238E27FC236}">
-                <a16:creationId xmlns:a16="http://schemas.microsoft.com/office/drawing/2014/main" id="{BEFFCC6C-AEC8-4D19-9E86-79DF8BA5344F}"/>
+                <a16:creationId xmlns:a16="http://schemas.microsoft.com/office/drawing/2014/main" id="{DE9C3ACD-C00D-47BF-B8A1-515566988201}"/>
               </a:ext>
             </a:extLst>
           </p:cNvPr>
@@ -8291,7 +8291,7 @@
           <p:nvPr/>
         </p:nvPicPr>
         <p:blipFill>
-          <a:blip xmlns:r="http://schemas.openxmlformats.org/officeDocument/2006/relationships" xmlns:a="http://schemas.openxmlformats.org/drawingml/2006/main" r:embed="Rb810344c4e7e4a44"/>
+          <a:blip xmlns:r="http://schemas.openxmlformats.org/officeDocument/2006/relationships" xmlns:a="http://schemas.openxmlformats.org/drawingml/2006/main" r:embed="R4a089d3079af4728"/>
           <a:stretch xmlns:a="http://schemas.openxmlformats.org/drawingml/2006/main"/>
         </p:blipFill>
         <p:spPr>
@@ -8309,7 +8309,7 @@
           <p:cNvPr id="9" name="">
             <a:extLst xmlns:a="http://schemas.openxmlformats.org/drawingml/2006/main">
               <a:ext uri="{FF2B5EF4-FFF2-40B4-BE49-F238E27FC236}">
-                <a16:creationId xmlns:a16="http://schemas.microsoft.com/office/drawing/2014/main" id="{4BC52D3A-666E-458E-9F0F-7D03B513675E}"/>
+                <a16:creationId xmlns:a16="http://schemas.microsoft.com/office/drawing/2014/main" id="{5BD75179-89F5-4219-BAED-70385CF57C05}"/>
               </a:ext>
             </a:extLst>
           </p:cNvPr>
@@ -8367,7 +8367,7 @@
           <p:cNvPr id="10" name="">
             <a:extLst xmlns:a="http://schemas.openxmlformats.org/drawingml/2006/main">
               <a:ext uri="{FF2B5EF4-FFF2-40B4-BE49-F238E27FC236}">
-                <a16:creationId xmlns:a16="http://schemas.microsoft.com/office/drawing/2014/main" id="{3E8CB5A2-C43D-481A-BBB4-73F1E69FECB5}"/>
+                <a16:creationId xmlns:a16="http://schemas.microsoft.com/office/drawing/2014/main" id="{AFF9D611-7406-4F8E-A18B-C7499766FC98}"/>
               </a:ext>
             </a:extLst>
           </p:cNvPr>
@@ -8429,7 +8429,7 @@
           <p:nvPr/>
         </p:nvPicPr>
         <p:blipFill>
-          <a:blip xmlns:r="http://schemas.openxmlformats.org/officeDocument/2006/relationships" xmlns:a="http://schemas.openxmlformats.org/drawingml/2006/main" r:embed="R7876a0152fe948bc"/>
+          <a:blip xmlns:r="http://schemas.openxmlformats.org/officeDocument/2006/relationships" xmlns:a="http://schemas.openxmlformats.org/drawingml/2006/main" r:embed="Reeea93ebdeab4e2e"/>
           <a:stretch xmlns:a="http://schemas.openxmlformats.org/drawingml/2006/main"/>
         </p:blipFill>
         <p:spPr>
@@ -8447,7 +8447,7 @@
           <p:cNvPr id="12" name="">
             <a:extLst xmlns:a="http://schemas.openxmlformats.org/drawingml/2006/main">
               <a:ext uri="{FF2B5EF4-FFF2-40B4-BE49-F238E27FC236}">
-                <a16:creationId xmlns:a16="http://schemas.microsoft.com/office/drawing/2014/main" id="{3B6E0CE9-699F-40E3-8263-0488948893B0}"/>
+                <a16:creationId xmlns:a16="http://schemas.microsoft.com/office/drawing/2014/main" id="{3A3EB549-FEDF-4DB8-8592-7B50D0CA45BE}"/>
               </a:ext>
             </a:extLst>
           </p:cNvPr>
@@ -8486,7 +8486,7 @@
           <p:nvPr/>
         </p:nvPicPr>
         <p:blipFill>
-          <a:blip xmlns:r="http://schemas.openxmlformats.org/officeDocument/2006/relationships" xmlns:a="http://schemas.openxmlformats.org/drawingml/2006/main" r:embed="R109c588d334045ee"/>
+          <a:blip xmlns:r="http://schemas.openxmlformats.org/officeDocument/2006/relationships" xmlns:a="http://schemas.openxmlformats.org/drawingml/2006/main" r:embed="Rbc0a5ba3f8f2426a"/>
           <a:stretch xmlns:a="http://schemas.openxmlformats.org/drawingml/2006/main"/>
         </p:blipFill>
         <p:spPr>
@@ -8504,7 +8504,7 @@
           <p:cNvPr id="14" name="">
             <a:extLst xmlns:a="http://schemas.openxmlformats.org/drawingml/2006/main">
               <a:ext uri="{FF2B5EF4-FFF2-40B4-BE49-F238E27FC236}">
-                <a16:creationId xmlns:a16="http://schemas.microsoft.com/office/drawing/2014/main" id="{53578822-E5DA-4D5C-A8E1-2BDC7E3CF0C6}"/>
+                <a16:creationId xmlns:a16="http://schemas.microsoft.com/office/drawing/2014/main" id="{C5FD0152-9C9E-473C-BD2B-8166D48DE53C}"/>
               </a:ext>
             </a:extLst>
           </p:cNvPr>
@@ -8562,7 +8562,7 @@
           <p:cNvPr id="15" name="">
             <a:extLst xmlns:a="http://schemas.openxmlformats.org/drawingml/2006/main">
               <a:ext uri="{FF2B5EF4-FFF2-40B4-BE49-F238E27FC236}">
-                <a16:creationId xmlns:a16="http://schemas.microsoft.com/office/drawing/2014/main" id="{C0D38C02-072A-426F-BE97-E61F2C0AFBAD}"/>
+                <a16:creationId xmlns:a16="http://schemas.microsoft.com/office/drawing/2014/main" id="{E1DE1191-71A6-48FE-A742-2815444F199E}"/>
               </a:ext>
             </a:extLst>
           </p:cNvPr>
@@ -8624,7 +8624,7 @@
           <p:nvPr/>
         </p:nvPicPr>
         <p:blipFill>
-          <a:blip xmlns:r="http://schemas.openxmlformats.org/officeDocument/2006/relationships" xmlns:a="http://schemas.openxmlformats.org/drawingml/2006/main" r:embed="Rf2fe4153ccd9425a"/>
+          <a:blip xmlns:r="http://schemas.openxmlformats.org/officeDocument/2006/relationships" xmlns:a="http://schemas.openxmlformats.org/drawingml/2006/main" r:embed="Rb9527e82e0c54237"/>
           <a:stretch xmlns:a="http://schemas.openxmlformats.org/drawingml/2006/main"/>
         </p:blipFill>
         <p:spPr>
@@ -8642,7 +8642,7 @@
           <p:cNvPr id="17" name="">
             <a:extLst xmlns:a="http://schemas.openxmlformats.org/drawingml/2006/main">
               <a:ext uri="{FF2B5EF4-FFF2-40B4-BE49-F238E27FC236}">
-                <a16:creationId xmlns:a16="http://schemas.microsoft.com/office/drawing/2014/main" id="{066EE614-E43A-4598-AA21-BEB33E32F3CC}"/>
+                <a16:creationId xmlns:a16="http://schemas.microsoft.com/office/drawing/2014/main" id="{E8390E2C-FBDB-4521-BEA4-D4B0523F8036}"/>
               </a:ext>
             </a:extLst>
           </p:cNvPr>
@@ -8681,7 +8681,7 @@
           <p:nvPr/>
         </p:nvPicPr>
         <p:blipFill>
-          <a:blip xmlns:r="http://schemas.openxmlformats.org/officeDocument/2006/relationships" xmlns:a="http://schemas.openxmlformats.org/drawingml/2006/main" r:embed="Ra6df39aad3fe474e"/>
+          <a:blip xmlns:r="http://schemas.openxmlformats.org/officeDocument/2006/relationships" xmlns:a="http://schemas.openxmlformats.org/drawingml/2006/main" r:embed="R0de8e97d79b5404d"/>
           <a:stretch xmlns:a="http://schemas.openxmlformats.org/drawingml/2006/main"/>
         </p:blipFill>
         <p:spPr>
@@ -8699,7 +8699,7 @@
           <p:cNvPr id="19" name="">
             <a:extLst xmlns:a="http://schemas.openxmlformats.org/drawingml/2006/main">
               <a:ext uri="{FF2B5EF4-FFF2-40B4-BE49-F238E27FC236}">
-                <a16:creationId xmlns:a16="http://schemas.microsoft.com/office/drawing/2014/main" id="{7CDAA79B-C3B5-4ABA-B41B-06DFBCFCCF92}"/>
+                <a16:creationId xmlns:a16="http://schemas.microsoft.com/office/drawing/2014/main" id="{04520658-6CAB-42D4-9757-E0A65EA82C32}"/>
               </a:ext>
             </a:extLst>
           </p:cNvPr>
@@ -8757,7 +8757,7 @@
           <p:cNvPr id="20" name="">
             <a:extLst xmlns:a="http://schemas.openxmlformats.org/drawingml/2006/main">
               <a:ext uri="{FF2B5EF4-FFF2-40B4-BE49-F238E27FC236}">
-                <a16:creationId xmlns:a16="http://schemas.microsoft.com/office/drawing/2014/main" id="{8CB4A4A7-CEDD-4D65-86DC-A4158D7C9BD5}"/>
+                <a16:creationId xmlns:a16="http://schemas.microsoft.com/office/drawing/2014/main" id="{B874F767-89A2-4EAA-B3B1-ED3E42B0D5B8}"/>
               </a:ext>
             </a:extLst>
           </p:cNvPr>
@@ -8819,7 +8819,7 @@
           <p:nvPr/>
         </p:nvPicPr>
         <p:blipFill>
-          <a:blip xmlns:r="http://schemas.openxmlformats.org/officeDocument/2006/relationships" xmlns:a="http://schemas.openxmlformats.org/drawingml/2006/main" r:embed="Read0ee643d754d4b"/>
+          <a:blip xmlns:r="http://schemas.openxmlformats.org/officeDocument/2006/relationships" xmlns:a="http://schemas.openxmlformats.org/drawingml/2006/main" r:embed="Re1edf14c4dd04148"/>
           <a:stretch xmlns:a="http://schemas.openxmlformats.org/drawingml/2006/main"/>
         </p:blipFill>
         <p:spPr>
@@ -8837,7 +8837,7 @@
           <p:cNvPr id="22" name="">
             <a:extLst xmlns:a="http://schemas.openxmlformats.org/drawingml/2006/main">
               <a:ext uri="{FF2B5EF4-FFF2-40B4-BE49-F238E27FC236}">
-                <a16:creationId xmlns:a16="http://schemas.microsoft.com/office/drawing/2014/main" id="{06BC684C-1C8F-41B8-B2B2-A913ED36B8F6}"/>
+                <a16:creationId xmlns:a16="http://schemas.microsoft.com/office/drawing/2014/main" id="{5F15AA46-B5E1-47AE-9221-150F67018556}"/>
               </a:ext>
             </a:extLst>
           </p:cNvPr>
@@ -8857,11 +8857,11 @@
             </a:avLst>
           </a:prstGeom>
           <a:solidFill xmlns:a="http://schemas.openxmlformats.org/drawingml/2006/main">
-            <a:srgbClr val="F5F1FB"/>
+            <a:srgbClr val="FFF7E6"/>
           </a:solidFill>
           <a:ln xmlns:a="http://schemas.openxmlformats.org/drawingml/2006/main" w="19050">
             <a:solidFill>
-              <a:srgbClr val="6F4B9B"/>
+              <a:srgbClr val="C98A16"/>
             </a:solidFill>
             <a:prstDash val="solid"/>
           </a:ln>
@@ -8876,7 +8876,7 @@
           <p:nvPr/>
         </p:nvPicPr>
         <p:blipFill>
-          <a:blip xmlns:r="http://schemas.openxmlformats.org/officeDocument/2006/relationships" xmlns:a="http://schemas.openxmlformats.org/drawingml/2006/main" r:embed="Rc1b7cd9c1ba64243"/>
+          <a:blip xmlns:r="http://schemas.openxmlformats.org/officeDocument/2006/relationships" xmlns:a="http://schemas.openxmlformats.org/drawingml/2006/main" r:embed="R6faba367bcc44f26"/>
           <a:stretch xmlns:a="http://schemas.openxmlformats.org/drawingml/2006/main"/>
         </p:blipFill>
         <p:spPr>
@@ -8894,7 +8894,7 @@
           <p:cNvPr id="24" name="">
             <a:extLst xmlns:a="http://schemas.openxmlformats.org/drawingml/2006/main">
               <a:ext uri="{FF2B5EF4-FFF2-40B4-BE49-F238E27FC236}">
-                <a16:creationId xmlns:a16="http://schemas.microsoft.com/office/drawing/2014/main" id="{668145DB-F98D-45A2-AD82-DAFF3723DDAA}"/>
+                <a16:creationId xmlns:a16="http://schemas.microsoft.com/office/drawing/2014/main" id="{09FCD1F3-2F91-4B71-B18D-424E4042EA61}"/>
               </a:ext>
             </a:extLst>
           </p:cNvPr>
@@ -8952,7 +8952,7 @@
           <p:cNvPr id="25" name="">
             <a:extLst xmlns:a="http://schemas.openxmlformats.org/drawingml/2006/main">
               <a:ext uri="{FF2B5EF4-FFF2-40B4-BE49-F238E27FC236}">
-                <a16:creationId xmlns:a16="http://schemas.microsoft.com/office/drawing/2014/main" id="{C24FC67B-11B5-4AE8-AA6B-397D368EC6E8}"/>
+                <a16:creationId xmlns:a16="http://schemas.microsoft.com/office/drawing/2014/main" id="{DA3CC2AD-C3A4-4A16-B584-9F2B0ECA45D3}"/>
               </a:ext>
             </a:extLst>
           </p:cNvPr>
@@ -9014,7 +9014,7 @@
           <p:nvPr/>
         </p:nvPicPr>
         <p:blipFill>
-          <a:blip xmlns:r="http://schemas.openxmlformats.org/officeDocument/2006/relationships" xmlns:a="http://schemas.openxmlformats.org/drawingml/2006/main" r:embed="R381c6d8354c9444f"/>
+          <a:blip xmlns:r="http://schemas.openxmlformats.org/officeDocument/2006/relationships" xmlns:a="http://schemas.openxmlformats.org/drawingml/2006/main" r:embed="R4e6e38d0f4964b1a"/>
           <a:stretch xmlns:a="http://schemas.openxmlformats.org/drawingml/2006/main"/>
         </p:blipFill>
         <p:spPr>
@@ -9032,7 +9032,7 @@
           <p:cNvPr id="27" name="">
             <a:extLst xmlns:a="http://schemas.openxmlformats.org/drawingml/2006/main">
               <a:ext uri="{FF2B5EF4-FFF2-40B4-BE49-F238E27FC236}">
-                <a16:creationId xmlns:a16="http://schemas.microsoft.com/office/drawing/2014/main" id="{8518136D-EAD9-43D6-9418-3E7B5BF683C0}"/>
+                <a16:creationId xmlns:a16="http://schemas.microsoft.com/office/drawing/2014/main" id="{A0281425-36A1-4A2C-AFC4-3BACE3930AC1}"/>
               </a:ext>
             </a:extLst>
           </p:cNvPr>
@@ -9090,7 +9090,7 @@
           <p:cNvPr id="28" name="slide-number-5">
             <a:extLst xmlns:a="http://schemas.openxmlformats.org/drawingml/2006/main">
               <a:ext uri="{FF2B5EF4-FFF2-40B4-BE49-F238E27FC236}">
-                <a16:creationId xmlns:a16="http://schemas.microsoft.com/office/drawing/2014/main" id="{16EE2E2D-DF71-4650-9C47-47148C0F422A}"/>
+                <a16:creationId xmlns:a16="http://schemas.microsoft.com/office/drawing/2014/main" id="{CB1EEF48-844C-4702-BCE5-721B0700E818}"/>
               </a:ext>
             </a:extLst>
           </p:cNvPr>
@@ -9146,7 +9146,7 @@
     </p:spTree>
     <p:extLst>
       <p:ext uri="{BB962C8B-B14F-4D97-AF65-F5344CB8AC3E}">
-        <p14:creationId xmlns:p14="http://schemas.microsoft.com/office/powerpoint/2010/main" val="981358159"/>
+        <p14:creationId xmlns:p14="http://schemas.microsoft.com/office/powerpoint/2010/main" val="876741180"/>
       </p:ext>
     </p:extLst>
   </p:cSld>
@@ -9177,7 +9177,7 @@
           <p:cNvPr id="23" name="title-T1">
             <a:extLst xmlns:a="http://schemas.openxmlformats.org/drawingml/2006/main">
               <a:ext uri="{FF2B5EF4-FFF2-40B4-BE49-F238E27FC236}">
-                <a16:creationId xmlns:a16="http://schemas.microsoft.com/office/drawing/2014/main" id="{2087FB78-736C-4348-AC5B-F4D93351990C}"/>
+                <a16:creationId xmlns:a16="http://schemas.microsoft.com/office/drawing/2014/main" id="{9DD4F7A1-75FF-43B1-BA23-84B43B3A9DEF}"/>
               </a:ext>
             </a:extLst>
           </p:cNvPr>
@@ -9239,7 +9239,7 @@
           <p:cNvPr id="2" name="subtitle-T1-slide6">
             <a:extLst xmlns:a="http://schemas.openxmlformats.org/drawingml/2006/main">
               <a:ext uri="{FF2B5EF4-FFF2-40B4-BE49-F238E27FC236}">
-                <a16:creationId xmlns:a16="http://schemas.microsoft.com/office/drawing/2014/main" id="{01FD7C05-8F1C-4356-B191-83858483F058}"/>
+                <a16:creationId xmlns:a16="http://schemas.microsoft.com/office/drawing/2014/main" id="{3D151053-B497-41A5-B0BF-5FA282822E25}"/>
               </a:ext>
             </a:extLst>
           </p:cNvPr>
@@ -9297,7 +9297,7 @@
           <p:cNvPr id="3" name="">
             <a:extLst xmlns:a="http://schemas.openxmlformats.org/drawingml/2006/main">
               <a:ext uri="{FF2B5EF4-FFF2-40B4-BE49-F238E27FC236}">
-                <a16:creationId xmlns:a16="http://schemas.microsoft.com/office/drawing/2014/main" id="{B2A8B700-FCBE-4D7B-B193-42983B592778}"/>
+                <a16:creationId xmlns:a16="http://schemas.microsoft.com/office/drawing/2014/main" id="{1E933BE6-B850-47DC-8177-4519C59467FD}"/>
               </a:ext>
             </a:extLst>
           </p:cNvPr>
@@ -9355,7 +9355,7 @@
           <p:cNvPr id="4" name="">
             <a:extLst xmlns:a="http://schemas.openxmlformats.org/drawingml/2006/main">
               <a:ext uri="{FF2B5EF4-FFF2-40B4-BE49-F238E27FC236}">
-                <a16:creationId xmlns:a16="http://schemas.microsoft.com/office/drawing/2014/main" id="{9FA5E51F-8125-403B-88EF-90E4C438C3ED}"/>
+                <a16:creationId xmlns:a16="http://schemas.microsoft.com/office/drawing/2014/main" id="{7211F809-A4AA-4716-A33B-BE1C6F24DD9C}"/>
               </a:ext>
             </a:extLst>
           </p:cNvPr>
@@ -9417,7 +9417,7 @@
           <p:cNvPr id="5" name="">
             <a:extLst xmlns:a="http://schemas.openxmlformats.org/drawingml/2006/main">
               <a:ext uri="{FF2B5EF4-FFF2-40B4-BE49-F238E27FC236}">
-                <a16:creationId xmlns:a16="http://schemas.microsoft.com/office/drawing/2014/main" id="{A8BD2272-0769-453E-B725-7C51403023F5}"/>
+                <a16:creationId xmlns:a16="http://schemas.microsoft.com/office/drawing/2014/main" id="{681311CD-569F-42F1-887D-843B06746659}"/>
               </a:ext>
             </a:extLst>
           </p:cNvPr>
@@ -9475,7 +9475,7 @@
           <p:cNvPr id="6" name="">
             <a:extLst xmlns:a="http://schemas.openxmlformats.org/drawingml/2006/main">
               <a:ext uri="{FF2B5EF4-FFF2-40B4-BE49-F238E27FC236}">
-                <a16:creationId xmlns:a16="http://schemas.microsoft.com/office/drawing/2014/main" id="{20E3304C-F944-4934-875A-0E2D55C30349}"/>
+                <a16:creationId xmlns:a16="http://schemas.microsoft.com/office/drawing/2014/main" id="{3CAD429C-B514-49D9-B660-EDE06CD25B01}"/>
               </a:ext>
             </a:extLst>
           </p:cNvPr>
@@ -9506,7 +9506,7 @@
           <p:cNvPr id="7" name="">
             <a:extLst xmlns:a="http://schemas.openxmlformats.org/drawingml/2006/main">
               <a:ext uri="{FF2B5EF4-FFF2-40B4-BE49-F238E27FC236}">
-                <a16:creationId xmlns:a16="http://schemas.microsoft.com/office/drawing/2014/main" id="{D50EEBCA-18C3-4640-BC11-7A2A22C31E5F}"/>
+                <a16:creationId xmlns:a16="http://schemas.microsoft.com/office/drawing/2014/main" id="{E1032C4B-B9CD-4FB1-B9E4-9E604DF3024C}"/>
               </a:ext>
             </a:extLst>
           </p:cNvPr>
@@ -9568,7 +9568,7 @@
           <p:cNvPr id="8" name="">
             <a:extLst xmlns:a="http://schemas.openxmlformats.org/drawingml/2006/main">
               <a:ext uri="{FF2B5EF4-FFF2-40B4-BE49-F238E27FC236}">
-                <a16:creationId xmlns:a16="http://schemas.microsoft.com/office/drawing/2014/main" id="{64EEA90D-552A-4CB4-B4F9-37394F730CF7}"/>
+                <a16:creationId xmlns:a16="http://schemas.microsoft.com/office/drawing/2014/main" id="{B83F6590-4371-4427-86B8-5B3DAA516E7B}"/>
               </a:ext>
             </a:extLst>
           </p:cNvPr>
@@ -9626,7 +9626,7 @@
           <p:cNvPr id="9" name="">
             <a:extLst xmlns:a="http://schemas.openxmlformats.org/drawingml/2006/main">
               <a:ext uri="{FF2B5EF4-FFF2-40B4-BE49-F238E27FC236}">
-                <a16:creationId xmlns:a16="http://schemas.microsoft.com/office/drawing/2014/main" id="{5727A6E3-388C-47E6-B6A9-147FA098F48E}"/>
+                <a16:creationId xmlns:a16="http://schemas.microsoft.com/office/drawing/2014/main" id="{EC98AF0A-FEB1-47AB-9013-53581D002B01}"/>
               </a:ext>
             </a:extLst>
           </p:cNvPr>
@@ -9657,7 +9657,7 @@
           <p:cNvPr id="10" name="">
             <a:extLst xmlns:a="http://schemas.openxmlformats.org/drawingml/2006/main">
               <a:ext uri="{FF2B5EF4-FFF2-40B4-BE49-F238E27FC236}">
-                <a16:creationId xmlns:a16="http://schemas.microsoft.com/office/drawing/2014/main" id="{F187217C-80F1-42B9-8770-B655CF5FBEF8}"/>
+                <a16:creationId xmlns:a16="http://schemas.microsoft.com/office/drawing/2014/main" id="{7E38CE17-FCFD-40DE-9334-B698ABFC2B00}"/>
               </a:ext>
             </a:extLst>
           </p:cNvPr>
@@ -9719,7 +9719,7 @@
           <p:cNvPr id="11" name="">
             <a:extLst xmlns:a="http://schemas.openxmlformats.org/drawingml/2006/main">
               <a:ext uri="{FF2B5EF4-FFF2-40B4-BE49-F238E27FC236}">
-                <a16:creationId xmlns:a16="http://schemas.microsoft.com/office/drawing/2014/main" id="{401241D2-5EA1-4E2A-B374-A64A6592FC1B}"/>
+                <a16:creationId xmlns:a16="http://schemas.microsoft.com/office/drawing/2014/main" id="{D0E01742-EF66-4E34-A3D9-D7DD6E0BD70D}"/>
               </a:ext>
             </a:extLst>
           </p:cNvPr>
@@ -9777,7 +9777,7 @@
           <p:cNvPr id="12" name="">
             <a:extLst xmlns:a="http://schemas.openxmlformats.org/drawingml/2006/main">
               <a:ext uri="{FF2B5EF4-FFF2-40B4-BE49-F238E27FC236}">
-                <a16:creationId xmlns:a16="http://schemas.microsoft.com/office/drawing/2014/main" id="{840EB676-9777-42E4-A40F-B9322ADE7480}"/>
+                <a16:creationId xmlns:a16="http://schemas.microsoft.com/office/drawing/2014/main" id="{4AD88420-9D35-4BB1-8D4B-C96CDF63B387}"/>
               </a:ext>
             </a:extLst>
           </p:cNvPr>
@@ -9808,7 +9808,7 @@
           <p:cNvPr id="13" name="">
             <a:extLst xmlns:a="http://schemas.openxmlformats.org/drawingml/2006/main">
               <a:ext uri="{FF2B5EF4-FFF2-40B4-BE49-F238E27FC236}">
-                <a16:creationId xmlns:a16="http://schemas.microsoft.com/office/drawing/2014/main" id="{40C9C495-A0C4-41B7-8D8F-957509A26870}"/>
+                <a16:creationId xmlns:a16="http://schemas.microsoft.com/office/drawing/2014/main" id="{0F073F60-30C1-4D0A-94BE-306F2AA6EF2E}"/>
               </a:ext>
             </a:extLst>
           </p:cNvPr>
@@ -9870,7 +9870,7 @@
           <p:cNvPr id="14" name="">
             <a:extLst xmlns:a="http://schemas.openxmlformats.org/drawingml/2006/main">
               <a:ext uri="{FF2B5EF4-FFF2-40B4-BE49-F238E27FC236}">
-                <a16:creationId xmlns:a16="http://schemas.microsoft.com/office/drawing/2014/main" id="{31D4D7C7-C1EC-4A74-8C0A-C3A2087CAA4E}"/>
+                <a16:creationId xmlns:a16="http://schemas.microsoft.com/office/drawing/2014/main" id="{C06C9DD4-73E4-4A1B-B66D-8399CBCE21B6}"/>
               </a:ext>
             </a:extLst>
           </p:cNvPr>
@@ -9928,7 +9928,7 @@
           <p:cNvPr id="15" name="">
             <a:extLst xmlns:a="http://schemas.openxmlformats.org/drawingml/2006/main">
               <a:ext uri="{FF2B5EF4-FFF2-40B4-BE49-F238E27FC236}">
-                <a16:creationId xmlns:a16="http://schemas.microsoft.com/office/drawing/2014/main" id="{CDE9B295-D533-496F-BC2E-F335EA069BCC}"/>
+                <a16:creationId xmlns:a16="http://schemas.microsoft.com/office/drawing/2014/main" id="{36E107C6-D575-4A95-AE4C-FB07E73A9CD0}"/>
               </a:ext>
             </a:extLst>
           </p:cNvPr>
@@ -9959,7 +9959,7 @@
           <p:cNvPr id="16" name="">
             <a:extLst xmlns:a="http://schemas.openxmlformats.org/drawingml/2006/main">
               <a:ext uri="{FF2B5EF4-FFF2-40B4-BE49-F238E27FC236}">
-                <a16:creationId xmlns:a16="http://schemas.microsoft.com/office/drawing/2014/main" id="{0CD0C7DC-38B2-40D8-B0E0-27C365A1EFB0}"/>
+                <a16:creationId xmlns:a16="http://schemas.microsoft.com/office/drawing/2014/main" id="{2B210C3F-338C-47FD-9144-7F7C1ABE2EB8}"/>
               </a:ext>
             </a:extLst>
           </p:cNvPr>
@@ -10021,7 +10021,7 @@
           <p:cNvPr id="17" name="">
             <a:extLst xmlns:a="http://schemas.openxmlformats.org/drawingml/2006/main">
               <a:ext uri="{FF2B5EF4-FFF2-40B4-BE49-F238E27FC236}">
-                <a16:creationId xmlns:a16="http://schemas.microsoft.com/office/drawing/2014/main" id="{C69D7AA6-956E-4988-9068-4B946AEFA039}"/>
+                <a16:creationId xmlns:a16="http://schemas.microsoft.com/office/drawing/2014/main" id="{A9934D9C-5071-4598-BD06-88B6549A2EB6}"/>
               </a:ext>
             </a:extLst>
           </p:cNvPr>
@@ -10079,7 +10079,7 @@
           <p:cNvPr id="18" name="">
             <a:extLst xmlns:a="http://schemas.openxmlformats.org/drawingml/2006/main">
               <a:ext uri="{FF2B5EF4-FFF2-40B4-BE49-F238E27FC236}">
-                <a16:creationId xmlns:a16="http://schemas.microsoft.com/office/drawing/2014/main" id="{95CD45BD-582B-4F67-90DD-5BA2DDA384FB}"/>
+                <a16:creationId xmlns:a16="http://schemas.microsoft.com/office/drawing/2014/main" id="{C607B43A-41DE-4849-A56C-19FA24E342EA}"/>
               </a:ext>
             </a:extLst>
           </p:cNvPr>
@@ -10114,7 +10114,7 @@
           <p:cNvPr id="19" name="">
             <a:extLst xmlns:a="http://schemas.openxmlformats.org/drawingml/2006/main">
               <a:ext uri="{FF2B5EF4-FFF2-40B4-BE49-F238E27FC236}">
-                <a16:creationId xmlns:a16="http://schemas.microsoft.com/office/drawing/2014/main" id="{86EB59E5-E258-4EEB-B3A2-427C2FA895CB}"/>
+                <a16:creationId xmlns:a16="http://schemas.microsoft.com/office/drawing/2014/main" id="{7859AFEB-DDFF-41B9-9E16-5E24E11DD25A}"/>
               </a:ext>
             </a:extLst>
           </p:cNvPr>
@@ -10172,7 +10172,7 @@
           <p:cNvPr id="20" name="code-sample">
             <a:extLst xmlns:a="http://schemas.openxmlformats.org/drawingml/2006/main">
               <a:ext uri="{FF2B5EF4-FFF2-40B4-BE49-F238E27FC236}">
-                <a16:creationId xmlns:a16="http://schemas.microsoft.com/office/drawing/2014/main" id="{B25BDA36-206B-4736-AFE3-44C5EBED4E27}"/>
+                <a16:creationId xmlns:a16="http://schemas.microsoft.com/office/drawing/2014/main" id="{F8CBFD02-941F-45B8-8F68-F5373035E0C5}"/>
               </a:ext>
             </a:extLst>
           </p:cNvPr>
@@ -10465,7 +10465,7 @@
           <p:cNvPr id="21" name="">
             <a:extLst xmlns:a="http://schemas.openxmlformats.org/drawingml/2006/main">
               <a:ext uri="{FF2B5EF4-FFF2-40B4-BE49-F238E27FC236}">
-                <a16:creationId xmlns:a16="http://schemas.microsoft.com/office/drawing/2014/main" id="{9D1BF321-33ED-4247-AC0B-0CEF8D9C0CE7}"/>
+                <a16:creationId xmlns:a16="http://schemas.microsoft.com/office/drawing/2014/main" id="{5FCE14AA-63AB-454B-817A-1EDB46E24302}"/>
               </a:ext>
             </a:extLst>
           </p:cNvPr>
@@ -10523,7 +10523,7 @@
           <p:cNvPr id="22" name="slide-number-6">
             <a:extLst xmlns:a="http://schemas.openxmlformats.org/drawingml/2006/main">
               <a:ext uri="{FF2B5EF4-FFF2-40B4-BE49-F238E27FC236}">
-                <a16:creationId xmlns:a16="http://schemas.microsoft.com/office/drawing/2014/main" id="{7E1BB72D-EC00-4835-A035-D4CA47E9A0F4}"/>
+                <a16:creationId xmlns:a16="http://schemas.microsoft.com/office/drawing/2014/main" id="{689C40B6-B05C-4683-9FBC-146F41412C72}"/>
               </a:ext>
             </a:extLst>
           </p:cNvPr>
@@ -10579,7 +10579,7 @@
     </p:spTree>
     <p:extLst>
       <p:ext uri="{BB962C8B-B14F-4D97-AF65-F5344CB8AC3E}">
-        <p14:creationId xmlns:p14="http://schemas.microsoft.com/office/powerpoint/2010/main" val="1342738259"/>
+        <p14:creationId xmlns:p14="http://schemas.microsoft.com/office/powerpoint/2010/main" val="982924053"/>
       </p:ext>
     </p:extLst>
   </p:cSld>
@@ -10610,7 +10610,7 @@
           <p:cNvPr id="20" name="title-T1">
             <a:extLst xmlns:a="http://schemas.openxmlformats.org/drawingml/2006/main">
               <a:ext uri="{FF2B5EF4-FFF2-40B4-BE49-F238E27FC236}">
-                <a16:creationId xmlns:a16="http://schemas.microsoft.com/office/drawing/2014/main" id="{03552553-81A1-4CB9-A78E-72FB8C64B8C3}"/>
+                <a16:creationId xmlns:a16="http://schemas.microsoft.com/office/drawing/2014/main" id="{2C0FE512-4CA8-4977-8D29-5E43ABE71767}"/>
               </a:ext>
             </a:extLst>
           </p:cNvPr>
@@ -10672,7 +10672,7 @@
           <p:cNvPr id="2" name="subtitle-T1">
             <a:extLst xmlns:a="http://schemas.openxmlformats.org/drawingml/2006/main">
               <a:ext uri="{FF2B5EF4-FFF2-40B4-BE49-F238E27FC236}">
-                <a16:creationId xmlns:a16="http://schemas.microsoft.com/office/drawing/2014/main" id="{8F0BA65A-A136-4AB3-A6BF-E96D7C90345F}"/>
+                <a16:creationId xmlns:a16="http://schemas.microsoft.com/office/drawing/2014/main" id="{93510B22-EB05-4B15-ACD8-7505B61A661B}"/>
               </a:ext>
             </a:extLst>
           </p:cNvPr>
@@ -10734,7 +10734,7 @@
           <p:nvPr/>
         </p:nvPicPr>
         <p:blipFill>
-          <a:blip xmlns:r="http://schemas.openxmlformats.org/officeDocument/2006/relationships" xmlns:a="http://schemas.openxmlformats.org/drawingml/2006/main" r:embed="R8e778c9451984feb"/>
+          <a:blip xmlns:r="http://schemas.openxmlformats.org/officeDocument/2006/relationships" xmlns:a="http://schemas.openxmlformats.org/drawingml/2006/main" r:embed="R890cbf695a694f27"/>
           <a:stretch xmlns:a="http://schemas.openxmlformats.org/drawingml/2006/main"/>
         </p:blipFill>
         <p:spPr>
@@ -10756,7 +10756,7 @@
           <p:nvPr/>
         </p:nvPicPr>
         <p:blipFill>
-          <a:blip xmlns:r="http://schemas.openxmlformats.org/officeDocument/2006/relationships" xmlns:a="http://schemas.openxmlformats.org/drawingml/2006/main" r:embed="R001dabd067764fc1"/>
+          <a:blip xmlns:r="http://schemas.openxmlformats.org/officeDocument/2006/relationships" xmlns:a="http://schemas.openxmlformats.org/drawingml/2006/main" r:embed="R5b3e3a6a1589449a"/>
           <a:stretch xmlns:a="http://schemas.openxmlformats.org/drawingml/2006/main"/>
         </p:blipFill>
         <p:spPr>
@@ -10774,7 +10774,7 @@
           <p:cNvPr id="5" name="">
             <a:extLst xmlns:a="http://schemas.openxmlformats.org/drawingml/2006/main">
               <a:ext uri="{FF2B5EF4-FFF2-40B4-BE49-F238E27FC236}">
-                <a16:creationId xmlns:a16="http://schemas.microsoft.com/office/drawing/2014/main" id="{BCEBE892-BFCE-4512-B667-29D3293D9D97}"/>
+                <a16:creationId xmlns:a16="http://schemas.microsoft.com/office/drawing/2014/main" id="{AD2AE792-E3DC-4B24-96BF-6AEE40EC94F7}"/>
               </a:ext>
             </a:extLst>
           </p:cNvPr>
@@ -10813,7 +10813,7 @@
           <p:nvPr/>
         </p:nvPicPr>
         <p:blipFill>
-          <a:blip xmlns:r="http://schemas.openxmlformats.org/officeDocument/2006/relationships" xmlns:a="http://schemas.openxmlformats.org/drawingml/2006/main" r:embed="R677c166cd4334059"/>
+          <a:blip xmlns:r="http://schemas.openxmlformats.org/officeDocument/2006/relationships" xmlns:a="http://schemas.openxmlformats.org/drawingml/2006/main" r:embed="R0a104a9a7f184571"/>
           <a:stretch xmlns:a="http://schemas.openxmlformats.org/drawingml/2006/main"/>
         </p:blipFill>
         <p:spPr>
@@ -10831,7 +10831,7 @@
           <p:cNvPr id="7" name="">
             <a:extLst xmlns:a="http://schemas.openxmlformats.org/drawingml/2006/main">
               <a:ext uri="{FF2B5EF4-FFF2-40B4-BE49-F238E27FC236}">
-                <a16:creationId xmlns:a16="http://schemas.microsoft.com/office/drawing/2014/main" id="{DA22AA3C-D669-4DED-9FBD-468EC36AA1F1}"/>
+                <a16:creationId xmlns:a16="http://schemas.microsoft.com/office/drawing/2014/main" id="{D1EC1C4F-4125-42C1-8FFE-F057C5B82CFB}"/>
               </a:ext>
             </a:extLst>
           </p:cNvPr>
@@ -10889,7 +10889,7 @@
           <p:cNvPr id="8" name="">
             <a:extLst xmlns:a="http://schemas.openxmlformats.org/drawingml/2006/main">
               <a:ext uri="{FF2B5EF4-FFF2-40B4-BE49-F238E27FC236}">
-                <a16:creationId xmlns:a16="http://schemas.microsoft.com/office/drawing/2014/main" id="{07D37D97-AB72-49E2-A076-FF2AD6834676}"/>
+                <a16:creationId xmlns:a16="http://schemas.microsoft.com/office/drawing/2014/main" id="{3C05EB37-2639-4A74-AA45-BF1714ADEE20}"/>
               </a:ext>
             </a:extLst>
           </p:cNvPr>
@@ -10928,7 +10928,7 @@
           <p:nvPr/>
         </p:nvPicPr>
         <p:blipFill>
-          <a:blip xmlns:r="http://schemas.openxmlformats.org/officeDocument/2006/relationships" xmlns:a="http://schemas.openxmlformats.org/drawingml/2006/main" r:embed="R654102ad34644061"/>
+          <a:blip xmlns:r="http://schemas.openxmlformats.org/officeDocument/2006/relationships" xmlns:a="http://schemas.openxmlformats.org/drawingml/2006/main" r:embed="Rd14fef03863d4f12"/>
           <a:stretch xmlns:a="http://schemas.openxmlformats.org/drawingml/2006/main"/>
         </p:blipFill>
         <p:spPr>
@@ -10946,7 +10946,7 @@
           <p:cNvPr id="10" name="">
             <a:extLst xmlns:a="http://schemas.openxmlformats.org/drawingml/2006/main">
               <a:ext uri="{FF2B5EF4-FFF2-40B4-BE49-F238E27FC236}">
-                <a16:creationId xmlns:a16="http://schemas.microsoft.com/office/drawing/2014/main" id="{8EE06A77-7343-4E7E-AA8C-9009C33DEF28}"/>
+                <a16:creationId xmlns:a16="http://schemas.microsoft.com/office/drawing/2014/main" id="{5F7BFC65-988A-472F-AF71-02BB5BA233B1}"/>
               </a:ext>
             </a:extLst>
           </p:cNvPr>
@@ -11004,7 +11004,7 @@
           <p:cNvPr id="11" name="">
             <a:extLst xmlns:a="http://schemas.openxmlformats.org/drawingml/2006/main">
               <a:ext uri="{FF2B5EF4-FFF2-40B4-BE49-F238E27FC236}">
-                <a16:creationId xmlns:a16="http://schemas.microsoft.com/office/drawing/2014/main" id="{6D5D9929-8CE6-4BF7-8109-79DD74D8A32A}"/>
+                <a16:creationId xmlns:a16="http://schemas.microsoft.com/office/drawing/2014/main" id="{3A6EF6BC-3714-41DD-81A2-C2CA42AD3EA2}"/>
               </a:ext>
             </a:extLst>
           </p:cNvPr>
@@ -11043,7 +11043,7 @@
           <p:nvPr/>
         </p:nvPicPr>
         <p:blipFill>
-          <a:blip xmlns:r="http://schemas.openxmlformats.org/officeDocument/2006/relationships" xmlns:a="http://schemas.openxmlformats.org/drawingml/2006/main" r:embed="Re8730780ebc5468a"/>
+          <a:blip xmlns:r="http://schemas.openxmlformats.org/officeDocument/2006/relationships" xmlns:a="http://schemas.openxmlformats.org/drawingml/2006/main" r:embed="Rf7b91d95976545ac"/>
           <a:stretch xmlns:a="http://schemas.openxmlformats.org/drawingml/2006/main"/>
         </p:blipFill>
         <p:spPr>
@@ -11061,7 +11061,7 @@
           <p:cNvPr id="13" name="">
             <a:extLst xmlns:a="http://schemas.openxmlformats.org/drawingml/2006/main">
               <a:ext uri="{FF2B5EF4-FFF2-40B4-BE49-F238E27FC236}">
-                <a16:creationId xmlns:a16="http://schemas.microsoft.com/office/drawing/2014/main" id="{CF7F71B1-19ED-4D16-AFF9-F1BC4858E688}"/>
+                <a16:creationId xmlns:a16="http://schemas.microsoft.com/office/drawing/2014/main" id="{33AAAC03-9E9C-41E6-9854-7DEB6AB2F69C}"/>
               </a:ext>
             </a:extLst>
           </p:cNvPr>
@@ -11119,7 +11119,7 @@
           <p:cNvPr id="14" name="">
             <a:extLst xmlns:a="http://schemas.openxmlformats.org/drawingml/2006/main">
               <a:ext uri="{FF2B5EF4-FFF2-40B4-BE49-F238E27FC236}">
-                <a16:creationId xmlns:a16="http://schemas.microsoft.com/office/drawing/2014/main" id="{F3A680E0-631E-4DD1-9BD0-727B1C4D3669}"/>
+                <a16:creationId xmlns:a16="http://schemas.microsoft.com/office/drawing/2014/main" id="{D9DCE808-44DC-404A-9679-D539855D36C2}"/>
               </a:ext>
             </a:extLst>
           </p:cNvPr>
@@ -11158,7 +11158,7 @@
           <p:nvPr/>
         </p:nvPicPr>
         <p:blipFill>
-          <a:blip xmlns:r="http://schemas.openxmlformats.org/officeDocument/2006/relationships" xmlns:a="http://schemas.openxmlformats.org/drawingml/2006/main" r:embed="R732500a285bf48a1"/>
+          <a:blip xmlns:r="http://schemas.openxmlformats.org/officeDocument/2006/relationships" xmlns:a="http://schemas.openxmlformats.org/drawingml/2006/main" r:embed="R64320bac1d5f4426"/>
           <a:stretch xmlns:a="http://schemas.openxmlformats.org/drawingml/2006/main"/>
         </p:blipFill>
         <p:spPr>
@@ -11176,7 +11176,7 @@
           <p:cNvPr id="16" name="">
             <a:extLst xmlns:a="http://schemas.openxmlformats.org/drawingml/2006/main">
               <a:ext uri="{FF2B5EF4-FFF2-40B4-BE49-F238E27FC236}">
-                <a16:creationId xmlns:a16="http://schemas.microsoft.com/office/drawing/2014/main" id="{757D14B2-5C2D-465F-8BA7-6359E469A0DB}"/>
+                <a16:creationId xmlns:a16="http://schemas.microsoft.com/office/drawing/2014/main" id="{8565D459-9C66-44C3-8302-036F5646EC41}"/>
               </a:ext>
             </a:extLst>
           </p:cNvPr>
@@ -11234,7 +11234,7 @@
           <p:cNvPr id="17" name="">
             <a:extLst xmlns:a="http://schemas.openxmlformats.org/drawingml/2006/main">
               <a:ext uri="{FF2B5EF4-FFF2-40B4-BE49-F238E27FC236}">
-                <a16:creationId xmlns:a16="http://schemas.microsoft.com/office/drawing/2014/main" id="{94955FE2-B657-400A-9750-033FB6833F2E}"/>
+                <a16:creationId xmlns:a16="http://schemas.microsoft.com/office/drawing/2014/main" id="{01A74A14-22A8-45CF-B707-818E78273F70}"/>
               </a:ext>
             </a:extLst>
           </p:cNvPr>
@@ -11254,11 +11254,11 @@
             </a:avLst>
           </a:prstGeom>
           <a:solidFill xmlns:a="http://schemas.openxmlformats.org/drawingml/2006/main">
-            <a:srgbClr val="FFF2F2"/>
+            <a:srgbClr val="F0FAF7"/>
           </a:solidFill>
           <a:ln xmlns:a="http://schemas.openxmlformats.org/drawingml/2006/main" w="19050">
             <a:solidFill>
-              <a:srgbClr val="B3262E"/>
+              <a:srgbClr val="2A9D9F"/>
             </a:solidFill>
             <a:prstDash val="solid"/>
           </a:ln>
@@ -11269,7 +11269,7 @@
           <p:cNvPr id="18" name="">
             <a:extLst xmlns:a="http://schemas.openxmlformats.org/drawingml/2006/main">
               <a:ext uri="{FF2B5EF4-FFF2-40B4-BE49-F238E27FC236}">
-                <a16:creationId xmlns:a16="http://schemas.microsoft.com/office/drawing/2014/main" id="{04EFA7A5-8CC6-4558-9A9C-0AA73BCD1DB7}"/>
+                <a16:creationId xmlns:a16="http://schemas.microsoft.com/office/drawing/2014/main" id="{C752E27C-5D90-46B5-84DB-DDFD29FD4E09}"/>
               </a:ext>
             </a:extLst>
           </p:cNvPr>
@@ -11301,7 +11301,7 @@
             <a:pPr algn="ctr">
               <a:defRPr sz="2250" b="1">
                 <a:solidFill>
-                  <a:srgbClr val="B3262E"/>
+                  <a:srgbClr val="2A9D9F"/>
                 </a:solidFill>
                 <a:latin typeface="Nunito"/>
                 <a:ea typeface="Nunito"/>
@@ -11311,7 +11311,7 @@
             <a:r>
               <a:rPr sz="2250" b="1">
                 <a:solidFill>
-                  <a:srgbClr val="B3262E"/>
+                  <a:srgbClr val="2A9D9F"/>
                 </a:solidFill>
                 <a:latin typeface="Nunito"/>
                 <a:ea typeface="Nunito"/>
@@ -11327,7 +11327,7 @@
           <p:cNvPr id="19" name="slide-number-7">
             <a:extLst xmlns:a="http://schemas.openxmlformats.org/drawingml/2006/main">
               <a:ext uri="{FF2B5EF4-FFF2-40B4-BE49-F238E27FC236}">
-                <a16:creationId xmlns:a16="http://schemas.microsoft.com/office/drawing/2014/main" id="{D933E66C-55FB-4418-8FFC-E703A2A7F22A}"/>
+                <a16:creationId xmlns:a16="http://schemas.microsoft.com/office/drawing/2014/main" id="{7AD6C311-9F7A-4229-BD5C-89CB342DBD1C}"/>
               </a:ext>
             </a:extLst>
           </p:cNvPr>
@@ -11383,7 +11383,7 @@
     </p:spTree>
     <p:extLst>
       <p:ext uri="{BB962C8B-B14F-4D97-AF65-F5344CB8AC3E}">
-        <p14:creationId xmlns:p14="http://schemas.microsoft.com/office/powerpoint/2010/main" val="1408870258"/>
+        <p14:creationId xmlns:p14="http://schemas.microsoft.com/office/powerpoint/2010/main" val="536382754"/>
       </p:ext>
     </p:extLst>
   </p:cSld>
@@ -11414,7 +11414,7 @@
           <p:cNvPr id="16" name="title-T2">
             <a:extLst xmlns:a="http://schemas.openxmlformats.org/drawingml/2006/main">
               <a:ext uri="{FF2B5EF4-FFF2-40B4-BE49-F238E27FC236}">
-                <a16:creationId xmlns:a16="http://schemas.microsoft.com/office/drawing/2014/main" id="{9C19115B-C5C3-4617-93DE-A9E4B990DF07}"/>
+                <a16:creationId xmlns:a16="http://schemas.microsoft.com/office/drawing/2014/main" id="{94EDF3DF-0C6F-4803-AB51-CBE8EB4E7740}"/>
               </a:ext>
             </a:extLst>
           </p:cNvPr>
@@ -11476,7 +11476,7 @@
           <p:cNvPr id="2" name="subtitle-T2">
             <a:extLst xmlns:a="http://schemas.openxmlformats.org/drawingml/2006/main">
               <a:ext uri="{FF2B5EF4-FFF2-40B4-BE49-F238E27FC236}">
-                <a16:creationId xmlns:a16="http://schemas.microsoft.com/office/drawing/2014/main" id="{9712B8C4-98F3-4FF5-8AB2-622FF9CE6233}"/>
+                <a16:creationId xmlns:a16="http://schemas.microsoft.com/office/drawing/2014/main" id="{3003063E-E41A-4323-8CE4-99B4B180B246}"/>
               </a:ext>
             </a:extLst>
           </p:cNvPr>
@@ -11534,7 +11534,7 @@
           <p:cNvPr id="3" name="">
             <a:extLst xmlns:a="http://schemas.openxmlformats.org/drawingml/2006/main">
               <a:ext uri="{FF2B5EF4-FFF2-40B4-BE49-F238E27FC236}">
-                <a16:creationId xmlns:a16="http://schemas.microsoft.com/office/drawing/2014/main" id="{BA4846BF-4B63-48A6-817C-3404BB6BC35F}"/>
+                <a16:creationId xmlns:a16="http://schemas.microsoft.com/office/drawing/2014/main" id="{834186A0-C020-4936-ACBA-E3B32B6D7AAF}"/>
               </a:ext>
             </a:extLst>
           </p:cNvPr>
@@ -11596,7 +11596,7 @@
           <p:cNvPr id="4" name="">
             <a:extLst xmlns:a="http://schemas.openxmlformats.org/drawingml/2006/main">
               <a:ext uri="{FF2B5EF4-FFF2-40B4-BE49-F238E27FC236}">
-                <a16:creationId xmlns:a16="http://schemas.microsoft.com/office/drawing/2014/main" id="{23CDC7CE-AE31-4331-9EAB-3A3BDDB897B9}"/>
+                <a16:creationId xmlns:a16="http://schemas.microsoft.com/office/drawing/2014/main" id="{83989CCF-4C14-447C-A30F-57948447228B}"/>
               </a:ext>
             </a:extLst>
           </p:cNvPr>
@@ -11631,7 +11631,7 @@
           <p:cNvPr id="5" name="">
             <a:extLst xmlns:a="http://schemas.openxmlformats.org/drawingml/2006/main">
               <a:ext uri="{FF2B5EF4-FFF2-40B4-BE49-F238E27FC236}">
-                <a16:creationId xmlns:a16="http://schemas.microsoft.com/office/drawing/2014/main" id="{6EF85933-8D90-4042-9CAD-EBF4AD857452}"/>
+                <a16:creationId xmlns:a16="http://schemas.microsoft.com/office/drawing/2014/main" id="{79325D25-7322-46B6-A893-FBAEF236F50F}"/>
               </a:ext>
             </a:extLst>
           </p:cNvPr>
@@ -11689,7 +11689,7 @@
           <p:cNvPr id="6" name="">
             <a:extLst xmlns:a="http://schemas.openxmlformats.org/drawingml/2006/main">
               <a:ext uri="{FF2B5EF4-FFF2-40B4-BE49-F238E27FC236}">
-                <a16:creationId xmlns:a16="http://schemas.microsoft.com/office/drawing/2014/main" id="{0E9A8DCD-F8B6-484A-9D73-9477C0D47679}"/>
+                <a16:creationId xmlns:a16="http://schemas.microsoft.com/office/drawing/2014/main" id="{32FEF8B9-3F84-4B4A-8C40-D4ECAAEE7D76}"/>
               </a:ext>
             </a:extLst>
           </p:cNvPr>
@@ -11778,7 +11778,7 @@
           <p:cNvPr id="7" name="">
             <a:extLst xmlns:a="http://schemas.openxmlformats.org/drawingml/2006/main">
               <a:ext uri="{FF2B5EF4-FFF2-40B4-BE49-F238E27FC236}">
-                <a16:creationId xmlns:a16="http://schemas.microsoft.com/office/drawing/2014/main" id="{0348DA2F-2C15-4579-B33B-0EBF7426B041}"/>
+                <a16:creationId xmlns:a16="http://schemas.microsoft.com/office/drawing/2014/main" id="{92DCE0C1-6D91-4D14-BCD5-3548AC74B390}"/>
               </a:ext>
             </a:extLst>
           </p:cNvPr>
@@ -11871,7 +11871,7 @@
           <p:nvPr/>
         </p:nvPicPr>
         <p:blipFill>
-          <a:blip xmlns:r="http://schemas.openxmlformats.org/officeDocument/2006/relationships" xmlns:a="http://schemas.openxmlformats.org/drawingml/2006/main" r:embed="R9cba43a09b96449f"/>
+          <a:blip xmlns:r="http://schemas.openxmlformats.org/officeDocument/2006/relationships" xmlns:a="http://schemas.openxmlformats.org/drawingml/2006/main" r:embed="Rec4b4b9c78b24881"/>
           <a:stretch xmlns:a="http://schemas.openxmlformats.org/drawingml/2006/main"/>
         </p:blipFill>
         <p:spPr>
@@ -11889,7 +11889,7 @@
           <p:cNvPr id="9" name="">
             <a:extLst xmlns:a="http://schemas.openxmlformats.org/drawingml/2006/main">
               <a:ext uri="{FF2B5EF4-FFF2-40B4-BE49-F238E27FC236}">
-                <a16:creationId xmlns:a16="http://schemas.microsoft.com/office/drawing/2014/main" id="{A22559E2-5A91-48EE-8286-993B3473F2D1}"/>
+                <a16:creationId xmlns:a16="http://schemas.microsoft.com/office/drawing/2014/main" id="{15A4D352-C4D6-40F8-8C77-E3A3FD655087}"/>
               </a:ext>
             </a:extLst>
           </p:cNvPr>
@@ -11947,7 +11947,7 @@
           <p:cNvPr id="10" name="">
             <a:extLst xmlns:a="http://schemas.openxmlformats.org/drawingml/2006/main">
               <a:ext uri="{FF2B5EF4-FFF2-40B4-BE49-F238E27FC236}">
-                <a16:creationId xmlns:a16="http://schemas.microsoft.com/office/drawing/2014/main" id="{75A99A1C-92AB-430F-9168-6B197F7EF016}"/>
+                <a16:creationId xmlns:a16="http://schemas.microsoft.com/office/drawing/2014/main" id="{F044B097-73A6-4162-A58E-FA7F0574AA92}"/>
               </a:ext>
             </a:extLst>
           </p:cNvPr>
@@ -12009,7 +12009,7 @@
           <p:nvPr/>
         </p:nvPicPr>
         <p:blipFill>
-          <a:blip xmlns:r="http://schemas.openxmlformats.org/officeDocument/2006/relationships" xmlns:a="http://schemas.openxmlformats.org/drawingml/2006/main" r:embed="R113ea2ce157b42c0"/>
+          <a:blip xmlns:r="http://schemas.openxmlformats.org/officeDocument/2006/relationships" xmlns:a="http://schemas.openxmlformats.org/drawingml/2006/main" r:embed="R6174091a8f874aa2"/>
           <a:stretch xmlns:a="http://schemas.openxmlformats.org/drawingml/2006/main"/>
         </p:blipFill>
         <p:spPr>
@@ -12027,7 +12027,7 @@
           <p:cNvPr id="12" name="">
             <a:extLst xmlns:a="http://schemas.openxmlformats.org/drawingml/2006/main">
               <a:ext uri="{FF2B5EF4-FFF2-40B4-BE49-F238E27FC236}">
-                <a16:creationId xmlns:a16="http://schemas.microsoft.com/office/drawing/2014/main" id="{5010764F-F7DC-458C-84CE-A57FD8290115}"/>
+                <a16:creationId xmlns:a16="http://schemas.microsoft.com/office/drawing/2014/main" id="{37228252-9F79-46C0-AAEE-0302D613E1D6}"/>
               </a:ext>
             </a:extLst>
           </p:cNvPr>
@@ -12089,7 +12089,7 @@
           <p:nvPr/>
         </p:nvPicPr>
         <p:blipFill>
-          <a:blip xmlns:r="http://schemas.openxmlformats.org/officeDocument/2006/relationships" xmlns:a="http://schemas.openxmlformats.org/drawingml/2006/main" r:embed="R18c99afa2f524335"/>
+          <a:blip xmlns:r="http://schemas.openxmlformats.org/officeDocument/2006/relationships" xmlns:a="http://schemas.openxmlformats.org/drawingml/2006/main" r:embed="Rb8d323b342f34cad"/>
           <a:stretch xmlns:a="http://schemas.openxmlformats.org/drawingml/2006/main"/>
         </p:blipFill>
         <p:spPr>
@@ -12107,7 +12107,7 @@
           <p:cNvPr id="14" name="">
             <a:extLst xmlns:a="http://schemas.openxmlformats.org/drawingml/2006/main">
               <a:ext uri="{FF2B5EF4-FFF2-40B4-BE49-F238E27FC236}">
-                <a16:creationId xmlns:a16="http://schemas.microsoft.com/office/drawing/2014/main" id="{1F7CF5F4-EE80-48C5-ADBA-19EEC5DFEF7E}"/>
+                <a16:creationId xmlns:a16="http://schemas.microsoft.com/office/drawing/2014/main" id="{0BF9DDA0-F297-439E-90C8-1BFC1EC97BEC}"/>
               </a:ext>
             </a:extLst>
           </p:cNvPr>
@@ -12165,7 +12165,7 @@
           <p:cNvPr id="15" name="slide-number-8">
             <a:extLst xmlns:a="http://schemas.openxmlformats.org/drawingml/2006/main">
               <a:ext uri="{FF2B5EF4-FFF2-40B4-BE49-F238E27FC236}">
-                <a16:creationId xmlns:a16="http://schemas.microsoft.com/office/drawing/2014/main" id="{60785F8A-3507-41CD-B826-5EC4557708AD}"/>
+                <a16:creationId xmlns:a16="http://schemas.microsoft.com/office/drawing/2014/main" id="{1D2A6123-6CAF-4B05-B62B-6D40F0A7B435}"/>
               </a:ext>
             </a:extLst>
           </p:cNvPr>
@@ -12221,7 +12221,7 @@
     </p:spTree>
     <p:extLst>
       <p:ext uri="{BB962C8B-B14F-4D97-AF65-F5344CB8AC3E}">
-        <p14:creationId xmlns:p14="http://schemas.microsoft.com/office/powerpoint/2010/main" val="1259842193"/>
+        <p14:creationId xmlns:p14="http://schemas.microsoft.com/office/powerpoint/2010/main" val="1726573446"/>
       </p:ext>
     </p:extLst>
   </p:cSld>
@@ -12252,7 +12252,7 @@
           <p:cNvPr id="25" name="title-T2">
             <a:extLst xmlns:a="http://schemas.openxmlformats.org/drawingml/2006/main">
               <a:ext uri="{FF2B5EF4-FFF2-40B4-BE49-F238E27FC236}">
-                <a16:creationId xmlns:a16="http://schemas.microsoft.com/office/drawing/2014/main" id="{EFE6516B-B2BC-4EE5-A7C1-23524AEFFD24}"/>
+                <a16:creationId xmlns:a16="http://schemas.microsoft.com/office/drawing/2014/main" id="{8CBBB8C2-9538-48BB-9A92-259F90EB2D0D}"/>
               </a:ext>
             </a:extLst>
           </p:cNvPr>
@@ -12314,7 +12314,7 @@
           <p:cNvPr id="2" name="subtitle-T2">
             <a:extLst xmlns:a="http://schemas.openxmlformats.org/drawingml/2006/main">
               <a:ext uri="{FF2B5EF4-FFF2-40B4-BE49-F238E27FC236}">
-                <a16:creationId xmlns:a16="http://schemas.microsoft.com/office/drawing/2014/main" id="{BD3BFA6F-77F9-485D-97DA-337005ADD3C2}"/>
+                <a16:creationId xmlns:a16="http://schemas.microsoft.com/office/drawing/2014/main" id="{9014E539-755F-433A-AA35-844D3DA021F5}"/>
               </a:ext>
             </a:extLst>
           </p:cNvPr>
@@ -12372,7 +12372,7 @@
           <p:cNvPr id="3" name="">
             <a:extLst xmlns:a="http://schemas.openxmlformats.org/drawingml/2006/main">
               <a:ext uri="{FF2B5EF4-FFF2-40B4-BE49-F238E27FC236}">
-                <a16:creationId xmlns:a16="http://schemas.microsoft.com/office/drawing/2014/main" id="{ED83A50B-88FF-4FD6-9549-BB8AC6455C13}"/>
+                <a16:creationId xmlns:a16="http://schemas.microsoft.com/office/drawing/2014/main" id="{BD5EE279-FB40-453E-B283-317415C752A1}"/>
               </a:ext>
             </a:extLst>
           </p:cNvPr>
@@ -12403,7 +12403,7 @@
           <p:cNvPr id="4" name="">
             <a:extLst xmlns:a="http://schemas.openxmlformats.org/drawingml/2006/main">
               <a:ext uri="{FF2B5EF4-FFF2-40B4-BE49-F238E27FC236}">
-                <a16:creationId xmlns:a16="http://schemas.microsoft.com/office/drawing/2014/main" id="{4B345EDB-7AAE-4FF6-981B-98DA18E618A3}"/>
+                <a16:creationId xmlns:a16="http://schemas.microsoft.com/office/drawing/2014/main" id="{D8E2A404-F88A-48E7-94A0-6A7347514490}"/>
               </a:ext>
             </a:extLst>
           </p:cNvPr>
@@ -12434,7 +12434,7 @@
           <p:cNvPr id="5" name="">
             <a:extLst xmlns:a="http://schemas.openxmlformats.org/drawingml/2006/main">
               <a:ext uri="{FF2B5EF4-FFF2-40B4-BE49-F238E27FC236}">
-                <a16:creationId xmlns:a16="http://schemas.microsoft.com/office/drawing/2014/main" id="{07098E4E-6527-4973-A6A9-9AA52FE50D45}"/>
+                <a16:creationId xmlns:a16="http://schemas.microsoft.com/office/drawing/2014/main" id="{A8BD90C4-BED7-4893-BFE9-CBF31C573424}"/>
               </a:ext>
             </a:extLst>
           </p:cNvPr>
@@ -12465,7 +12465,7 @@
           <p:cNvPr id="6" name="">
             <a:extLst xmlns:a="http://schemas.openxmlformats.org/drawingml/2006/main">
               <a:ext uri="{FF2B5EF4-FFF2-40B4-BE49-F238E27FC236}">
-                <a16:creationId xmlns:a16="http://schemas.microsoft.com/office/drawing/2014/main" id="{ED54A21B-8754-4385-8054-7D12500D78F2}"/>
+                <a16:creationId xmlns:a16="http://schemas.microsoft.com/office/drawing/2014/main" id="{59864D39-30CE-419A-B5FE-E64EEBD654AF}"/>
               </a:ext>
             </a:extLst>
           </p:cNvPr>
@@ -12500,7 +12500,7 @@
           <p:cNvPr id="7" name="">
             <a:extLst xmlns:a="http://schemas.openxmlformats.org/drawingml/2006/main">
               <a:ext uri="{FF2B5EF4-FFF2-40B4-BE49-F238E27FC236}">
-                <a16:creationId xmlns:a16="http://schemas.microsoft.com/office/drawing/2014/main" id="{22F15C0F-62AE-4217-95C3-4C87891BEB1A}"/>
+                <a16:creationId xmlns:a16="http://schemas.microsoft.com/office/drawing/2014/main" id="{3A138C60-BCD8-43D2-BA17-5FDFBEB5DD64}"/>
               </a:ext>
             </a:extLst>
           </p:cNvPr>
@@ -12562,7 +12562,7 @@
           <p:cNvPr id="8" name="">
             <a:extLst xmlns:a="http://schemas.openxmlformats.org/drawingml/2006/main">
               <a:ext uri="{FF2B5EF4-FFF2-40B4-BE49-F238E27FC236}">
-                <a16:creationId xmlns:a16="http://schemas.microsoft.com/office/drawing/2014/main" id="{9C4B1DCA-AFBE-4BE4-BE41-BD58BC4E97F4}"/>
+                <a16:creationId xmlns:a16="http://schemas.microsoft.com/office/drawing/2014/main" id="{BB1095A6-0111-4224-A3B5-6D7927DD89F1}"/>
               </a:ext>
             </a:extLst>
           </p:cNvPr>
@@ -12620,7 +12620,7 @@
           <p:cNvPr id="9" name="">
             <a:extLst xmlns:a="http://schemas.openxmlformats.org/drawingml/2006/main">
               <a:ext uri="{FF2B5EF4-FFF2-40B4-BE49-F238E27FC236}">
-                <a16:creationId xmlns:a16="http://schemas.microsoft.com/office/drawing/2014/main" id="{7B4C4298-B8AD-4CFB-9098-994FC68CBC8A}"/>
+                <a16:creationId xmlns:a16="http://schemas.microsoft.com/office/drawing/2014/main" id="{566ADACC-1F8E-4A32-83A0-7635CD48EAE7}"/>
               </a:ext>
             </a:extLst>
           </p:cNvPr>
@@ -12709,7 +12709,7 @@
           <p:cNvPr id="10" name="">
             <a:extLst xmlns:a="http://schemas.openxmlformats.org/drawingml/2006/main">
               <a:ext uri="{FF2B5EF4-FFF2-40B4-BE49-F238E27FC236}">
-                <a16:creationId xmlns:a16="http://schemas.microsoft.com/office/drawing/2014/main" id="{74DFA2FA-ED11-49DB-9FFC-E5A2AA3D1FF2}"/>
+                <a16:creationId xmlns:a16="http://schemas.microsoft.com/office/drawing/2014/main" id="{8D567DA1-F84F-4BAF-A2BE-99A1152DD77F}"/>
               </a:ext>
             </a:extLst>
           </p:cNvPr>
@@ -12744,7 +12744,7 @@
           <p:cNvPr id="11" name="">
             <a:extLst xmlns:a="http://schemas.openxmlformats.org/drawingml/2006/main">
               <a:ext uri="{FF2B5EF4-FFF2-40B4-BE49-F238E27FC236}">
-                <a16:creationId xmlns:a16="http://schemas.microsoft.com/office/drawing/2014/main" id="{AF7AC6CD-EF28-4482-8432-1852C9A64918}"/>
+                <a16:creationId xmlns:a16="http://schemas.microsoft.com/office/drawing/2014/main" id="{D92EC939-7F9B-4DA4-A19F-4928EF1C159E}"/>
               </a:ext>
             </a:extLst>
           </p:cNvPr>
@@ -12806,7 +12806,7 @@
           <p:cNvPr id="12" name="">
             <a:extLst xmlns:a="http://schemas.openxmlformats.org/drawingml/2006/main">
               <a:ext uri="{FF2B5EF4-FFF2-40B4-BE49-F238E27FC236}">
-                <a16:creationId xmlns:a16="http://schemas.microsoft.com/office/drawing/2014/main" id="{2EF7DC72-E8AD-440C-91D8-55A3655854EC}"/>
+                <a16:creationId xmlns:a16="http://schemas.microsoft.com/office/drawing/2014/main" id="{7ABB5A48-FD2D-4639-A039-BDA0DAC4BE64}"/>
               </a:ext>
             </a:extLst>
           </p:cNvPr>
@@ -12864,7 +12864,7 @@
           <p:cNvPr id="13" name="">
             <a:extLst xmlns:a="http://schemas.openxmlformats.org/drawingml/2006/main">
               <a:ext uri="{FF2B5EF4-FFF2-40B4-BE49-F238E27FC236}">
-                <a16:creationId xmlns:a16="http://schemas.microsoft.com/office/drawing/2014/main" id="{033D4C36-2055-4AA2-93F5-6CD1986707FF}"/>
+                <a16:creationId xmlns:a16="http://schemas.microsoft.com/office/drawing/2014/main" id="{FBE3D340-4C7A-4763-9197-F14DC08B3ADF}"/>
               </a:ext>
             </a:extLst>
           </p:cNvPr>
@@ -12953,7 +12953,7 @@
           <p:cNvPr id="14" name="">
             <a:extLst xmlns:a="http://schemas.openxmlformats.org/drawingml/2006/main">
               <a:ext uri="{FF2B5EF4-FFF2-40B4-BE49-F238E27FC236}">
-                <a16:creationId xmlns:a16="http://schemas.microsoft.com/office/drawing/2014/main" id="{1FF580B5-A168-4DBF-9C63-8D51637ADF96}"/>
+                <a16:creationId xmlns:a16="http://schemas.microsoft.com/office/drawing/2014/main" id="{D005E067-D70B-4083-8870-5F7DBA48AE28}"/>
               </a:ext>
             </a:extLst>
           </p:cNvPr>
@@ -12988,7 +12988,7 @@
           <p:cNvPr id="15" name="">
             <a:extLst xmlns:a="http://schemas.openxmlformats.org/drawingml/2006/main">
               <a:ext uri="{FF2B5EF4-FFF2-40B4-BE49-F238E27FC236}">
-                <a16:creationId xmlns:a16="http://schemas.microsoft.com/office/drawing/2014/main" id="{B2DACC82-FE40-40A8-8E78-EA79C3AC9D2E}"/>
+                <a16:creationId xmlns:a16="http://schemas.microsoft.com/office/drawing/2014/main" id="{EF4FFF3C-B2DE-43A0-9E75-D0C928EE2D8F}"/>
               </a:ext>
             </a:extLst>
           </p:cNvPr>
@@ -13050,7 +13050,7 @@
           <p:cNvPr id="16" name="">
             <a:extLst xmlns:a="http://schemas.openxmlformats.org/drawingml/2006/main">
               <a:ext uri="{FF2B5EF4-FFF2-40B4-BE49-F238E27FC236}">
-                <a16:creationId xmlns:a16="http://schemas.microsoft.com/office/drawing/2014/main" id="{C9FE2B35-D62E-4872-B43C-5B58FFFCE80E}"/>
+                <a16:creationId xmlns:a16="http://schemas.microsoft.com/office/drawing/2014/main" id="{A75005DC-20A4-4B29-932C-E7E72024AAB3}"/>
               </a:ext>
             </a:extLst>
           </p:cNvPr>
@@ -13108,7 +13108,7 @@
           <p:cNvPr id="17" name="">
             <a:extLst xmlns:a="http://schemas.openxmlformats.org/drawingml/2006/main">
               <a:ext uri="{FF2B5EF4-FFF2-40B4-BE49-F238E27FC236}">
-                <a16:creationId xmlns:a16="http://schemas.microsoft.com/office/drawing/2014/main" id="{3310084C-0E0B-404D-968F-CB64B443EB7A}"/>
+                <a16:creationId xmlns:a16="http://schemas.microsoft.com/office/drawing/2014/main" id="{881B6DE6-4534-4B28-8629-1E3CD668B50B}"/>
               </a:ext>
             </a:extLst>
           </p:cNvPr>
@@ -13197,7 +13197,7 @@
           <p:cNvPr id="18" name="">
             <a:extLst xmlns:a="http://schemas.openxmlformats.org/drawingml/2006/main">
               <a:ext uri="{FF2B5EF4-FFF2-40B4-BE49-F238E27FC236}">
-                <a16:creationId xmlns:a16="http://schemas.microsoft.com/office/drawing/2014/main" id="{8527374B-B8DE-4987-89F8-346558C66B1A}"/>
+                <a16:creationId xmlns:a16="http://schemas.microsoft.com/office/drawing/2014/main" id="{AF114AA1-ECB4-4B39-92F4-08342C9D40A4}"/>
               </a:ext>
             </a:extLst>
           </p:cNvPr>
@@ -13232,7 +13232,7 @@
           <p:cNvPr id="19" name="">
             <a:extLst xmlns:a="http://schemas.openxmlformats.org/drawingml/2006/main">
               <a:ext uri="{FF2B5EF4-FFF2-40B4-BE49-F238E27FC236}">
-                <a16:creationId xmlns:a16="http://schemas.microsoft.com/office/drawing/2014/main" id="{BBBFDD7B-8E97-46B8-BE98-B7729D7130BF}"/>
+                <a16:creationId xmlns:a16="http://schemas.microsoft.com/office/drawing/2014/main" id="{1C9E5078-0CD3-4A58-B894-04B4E2309034}"/>
               </a:ext>
             </a:extLst>
           </p:cNvPr>
@@ -13294,7 +13294,7 @@
           <p:cNvPr id="20" name="">
             <a:extLst xmlns:a="http://schemas.openxmlformats.org/drawingml/2006/main">
               <a:ext uri="{FF2B5EF4-FFF2-40B4-BE49-F238E27FC236}">
-                <a16:creationId xmlns:a16="http://schemas.microsoft.com/office/drawing/2014/main" id="{05222F9D-A868-4019-963A-595D4C73C118}"/>
+                <a16:creationId xmlns:a16="http://schemas.microsoft.com/office/drawing/2014/main" id="{E68F061B-0FB7-44AD-AF89-9CD22E65A0CD}"/>
               </a:ext>
             </a:extLst>
           </p:cNvPr>
@@ -13352,7 +13352,7 @@
           <p:cNvPr id="21" name="">
             <a:extLst xmlns:a="http://schemas.openxmlformats.org/drawingml/2006/main">
               <a:ext uri="{FF2B5EF4-FFF2-40B4-BE49-F238E27FC236}">
-                <a16:creationId xmlns:a16="http://schemas.microsoft.com/office/drawing/2014/main" id="{937F3703-AE7E-44B5-A486-E5DEF564B956}"/>
+                <a16:creationId xmlns:a16="http://schemas.microsoft.com/office/drawing/2014/main" id="{801A29A0-E17E-43EB-B815-2C0BB07BCCC2}"/>
               </a:ext>
             </a:extLst>
           </p:cNvPr>
@@ -13441,7 +13441,7 @@
           <p:cNvPr id="22" name="">
             <a:extLst xmlns:a="http://schemas.openxmlformats.org/drawingml/2006/main">
               <a:ext uri="{FF2B5EF4-FFF2-40B4-BE49-F238E27FC236}">
-                <a16:creationId xmlns:a16="http://schemas.microsoft.com/office/drawing/2014/main" id="{96C27A5C-E3DA-461D-8837-0ED8E3BF1434}"/>
+                <a16:creationId xmlns:a16="http://schemas.microsoft.com/office/drawing/2014/main" id="{936AECE1-526E-4654-8C09-F885341F62B9}"/>
               </a:ext>
             </a:extLst>
           </p:cNvPr>
@@ -13476,7 +13476,7 @@
           <p:cNvPr id="23" name="">
             <a:extLst xmlns:a="http://schemas.openxmlformats.org/drawingml/2006/main">
               <a:ext uri="{FF2B5EF4-FFF2-40B4-BE49-F238E27FC236}">
-                <a16:creationId xmlns:a16="http://schemas.microsoft.com/office/drawing/2014/main" id="{6206DC2E-9D4D-4BEC-990E-781BFAACF130}"/>
+                <a16:creationId xmlns:a16="http://schemas.microsoft.com/office/drawing/2014/main" id="{64ED0374-C51B-40F8-B691-A3B465567363}"/>
               </a:ext>
             </a:extLst>
           </p:cNvPr>
@@ -13534,7 +13534,7 @@
           <p:cNvPr id="24" name="slide-number-9">
             <a:extLst xmlns:a="http://schemas.openxmlformats.org/drawingml/2006/main">
               <a:ext uri="{FF2B5EF4-FFF2-40B4-BE49-F238E27FC236}">
-                <a16:creationId xmlns:a16="http://schemas.microsoft.com/office/drawing/2014/main" id="{9673857F-EEFA-40FA-B9EB-CEDD6082E675}"/>
+                <a16:creationId xmlns:a16="http://schemas.microsoft.com/office/drawing/2014/main" id="{F19EC554-2F7F-47C7-B09D-06FE1D04F9F2}"/>
               </a:ext>
             </a:extLst>
           </p:cNvPr>
@@ -13590,7 +13590,7 @@
     </p:spTree>
     <p:extLst>
       <p:ext uri="{BB962C8B-B14F-4D97-AF65-F5344CB8AC3E}">
-        <p14:creationId xmlns:p14="http://schemas.microsoft.com/office/powerpoint/2010/main" val="504528141"/>
+        <p14:creationId xmlns:p14="http://schemas.microsoft.com/office/powerpoint/2010/main" val="1816725033"/>
       </p:ext>
     </p:extLst>
   </p:cSld>

</xml_diff>

<commit_message>
Update computational physics course materials
</commit_message>
<xml_diff>
--- a/.agent/lecture-slide-system/masters/PHY4605_Editable_Slide_Master.pptx
+++ b/.agent/lecture-slide-system/masters/PHY4605_Editable_Slide_Master.pptx
@@ -2,22 +2,22 @@
 <file path=ppt/presentation.xml><?xml version="1.0" encoding="utf-8"?>
 <p:presentation xmlns:p="http://schemas.openxmlformats.org/presentationml/2006/main">
   <p:sldMasterIdLst>
-    <p:sldMasterId xmlns:r="http://schemas.openxmlformats.org/officeDocument/2006/relationships" id="2147483648" r:id="R5503cc249f1f4ce3"/>
-    <p:sldMasterId xmlns:r="http://schemas.openxmlformats.org/officeDocument/2006/relationships" id="2147483650" r:id="R3fb1e6e557114417"/>
+    <p:sldMasterId xmlns:r="http://schemas.openxmlformats.org/officeDocument/2006/relationships" id="2147483648" r:id="Rb25793db681c42c8"/>
+    <p:sldMasterId xmlns:r="http://schemas.openxmlformats.org/officeDocument/2006/relationships" id="2147483650" r:id="R5639f0578fe54361"/>
   </p:sldMasterIdLst>
   <p:notesMasterIdLst>
-    <p:notesMasterId xmlns:r="http://schemas.openxmlformats.org/officeDocument/2006/relationships" r:id="R069110e5dbdb4326"/>
+    <p:notesMasterId xmlns:r="http://schemas.openxmlformats.org/officeDocument/2006/relationships" r:id="R171cc1f3564248af"/>
   </p:notesMasterIdLst>
   <p:sldIdLst>
-    <p:sldId xmlns:r="http://schemas.openxmlformats.org/officeDocument/2006/relationships" id="256" r:id="R2699b5370d9e4616"/>
-    <p:sldId xmlns:r="http://schemas.openxmlformats.org/officeDocument/2006/relationships" id="257" r:id="R3fae09ef5d1a41d4"/>
-    <p:sldId xmlns:r="http://schemas.openxmlformats.org/officeDocument/2006/relationships" id="258" r:id="R38e87e3dc4514fb0"/>
-    <p:sldId xmlns:r="http://schemas.openxmlformats.org/officeDocument/2006/relationships" id="259" r:id="R976f6b9f08a74e6b"/>
-    <p:sldId xmlns:r="http://schemas.openxmlformats.org/officeDocument/2006/relationships" id="260" r:id="Rde9b865789b34dda"/>
-    <p:sldId xmlns:r="http://schemas.openxmlformats.org/officeDocument/2006/relationships" id="261" r:id="R67acc7f4e96d4b0b"/>
-    <p:sldId xmlns:r="http://schemas.openxmlformats.org/officeDocument/2006/relationships" id="262" r:id="R4917208f561a440e"/>
-    <p:sldId xmlns:r="http://schemas.openxmlformats.org/officeDocument/2006/relationships" id="263" r:id="R6210700d02b446d3"/>
-    <p:sldId xmlns:r="http://schemas.openxmlformats.org/officeDocument/2006/relationships" id="264" r:id="R4b041e11ae8f41a4"/>
+    <p:sldId xmlns:r="http://schemas.openxmlformats.org/officeDocument/2006/relationships" id="256" r:id="R9f1a724024c04f60"/>
+    <p:sldId xmlns:r="http://schemas.openxmlformats.org/officeDocument/2006/relationships" id="257" r:id="R14635daf0a304fb8"/>
+    <p:sldId xmlns:r="http://schemas.openxmlformats.org/officeDocument/2006/relationships" id="258" r:id="R106aec5db09d4b65"/>
+    <p:sldId xmlns:r="http://schemas.openxmlformats.org/officeDocument/2006/relationships" id="259" r:id="R407935f467654be9"/>
+    <p:sldId xmlns:r="http://schemas.openxmlformats.org/officeDocument/2006/relationships" id="260" r:id="Ra1379fa6671e4b37"/>
+    <p:sldId xmlns:r="http://schemas.openxmlformats.org/officeDocument/2006/relationships" id="261" r:id="Rb94c507458d3432d"/>
+    <p:sldId xmlns:r="http://schemas.openxmlformats.org/officeDocument/2006/relationships" id="262" r:id="R2074f99f852640e5"/>
+    <p:sldId xmlns:r="http://schemas.openxmlformats.org/officeDocument/2006/relationships" id="263" r:id="Rd2888fe3689d41f2"/>
+    <p:sldId xmlns:r="http://schemas.openxmlformats.org/officeDocument/2006/relationships" id="264" r:id="R57ba494c791541e0"/>
   </p:sldIdLst>
   <p:sldSz cx="18288000" cy="10287000"/>
   <p:notesSz cx="6858000" cy="9144000"/>
@@ -936,7 +936,7 @@
           </a:p>
           <a:p xmlns:a="http://schemas.openxmlformats.org/drawingml/2006/main">
             <a:r>
-              <a:t>- symbolG: TeX `g`; SVG `.agent/lecture-slide-system/assets/equations/symbol-g.svg`; PNG `.agent/lecture-slide-system/assets/equations/symbol-g.png`; foreground `#C98A16`; target `110 × 48 px`; fit/crop `contain`; alt `LaTeX-rendered symbol g`; QA `render-equations-diagrams, PNG scale 6, retained TeX/SVG`</a:t>
+              <a:t>- symbolG: TeX `g`; SVG `.agent/lecture-slide-system/assets/equations/symbol-g.svg`; PNG `.agent/lecture-slide-system/assets/equations/symbol-g.png`; foreground `#6F4B9B`; target `110 × 48 px`; fit/crop `contain`; alt `LaTeX-rendered symbol g`; QA `render-equations-diagrams, PNG scale 6, retained TeX/SVG`</a:t>
             </a:r>
           </a:p>
           <a:p xmlns:a="http://schemas.openxmlformats.org/drawingml/2006/main">
@@ -2318,7 +2318,7 @@
   </p:cSld>
   <p:clrMap bg1="lt1" tx1="dk1" bg2="lt2" tx2="dk2" accent1="accent1" accent2="accent2" accent3="accent3" accent4="accent4" accent5="accent5" accent6="accent6" hlink="hlink" folHlink="folHlink"/>
   <p:sldLayoutIdLst>
-    <p:sldLayoutId xmlns:r="http://schemas.openxmlformats.org/officeDocument/2006/relationships" id="2147483649" r:id="Rb8ee8e6a99594e8c"/>
+    <p:sldLayoutId xmlns:r="http://schemas.openxmlformats.org/officeDocument/2006/relationships" id="2147483649" r:id="R144cbd86bf4e4fa4"/>
   </p:sldLayoutIdLst>
   <p:txStyles>
     <p:titleStyle>
@@ -2757,10 +2757,10 @@
   </p:cSld>
   <p:clrMap bg1="lt1" tx1="dk1" bg2="lt2" tx2="dk2" accent1="accent1" accent2="accent2" accent3="accent3" accent4="accent4" accent5="accent5" accent6="accent6" hlink="hlink" folHlink="folHlink"/>
   <p:sldLayoutIdLst>
-    <p:sldLayoutId xmlns:r="http://schemas.openxmlformats.org/officeDocument/2006/relationships" id="2147483651" r:id="Rdf0cbb7456c84f9b"/>
-    <p:sldLayoutId xmlns:r="http://schemas.openxmlformats.org/officeDocument/2006/relationships" id="2147483652" r:id="R65074857acbc4845"/>
-    <p:sldLayoutId xmlns:r="http://schemas.openxmlformats.org/officeDocument/2006/relationships" id="2147483653" r:id="R0775d1706fa94cbc"/>
-    <p:sldLayoutId xmlns:r="http://schemas.openxmlformats.org/officeDocument/2006/relationships" id="2147483654" r:id="Rd07d706a6c154865"/>
+    <p:sldLayoutId xmlns:r="http://schemas.openxmlformats.org/officeDocument/2006/relationships" id="2147483651" r:id="Rb387210603ea415f"/>
+    <p:sldLayoutId xmlns:r="http://schemas.openxmlformats.org/officeDocument/2006/relationships" id="2147483652" r:id="R7d08c8750ee244c7"/>
+    <p:sldLayoutId xmlns:r="http://schemas.openxmlformats.org/officeDocument/2006/relationships" id="2147483653" r:id="R1311270d782b48c3"/>
+    <p:sldLayoutId xmlns:r="http://schemas.openxmlformats.org/officeDocument/2006/relationships" id="2147483654" r:id="R7917041c06be47cc"/>
   </p:sldLayoutIdLst>
 </p:sldMaster>
 </file>
@@ -3279,7 +3279,7 @@
           <p:cNvPr id="18" name="course-tag">
             <a:extLst xmlns:a="http://schemas.openxmlformats.org/drawingml/2006/main">
               <a:ext uri="{FF2B5EF4-FFF2-40B4-BE49-F238E27FC236}">
-                <a16:creationId xmlns:a16="http://schemas.microsoft.com/office/drawing/2014/main" id="{CE6400EB-6D84-4ACA-88E5-6A8FD4818B4D}"/>
+                <a16:creationId xmlns:a16="http://schemas.microsoft.com/office/drawing/2014/main" id="{F6DEE757-0BCB-4DDC-A149-3DF07AE0FFA4}"/>
               </a:ext>
             </a:extLst>
           </p:cNvPr>
@@ -3337,7 +3337,7 @@
           <p:cNvPr id="2" name="opening-title">
             <a:extLst xmlns:a="http://schemas.openxmlformats.org/drawingml/2006/main">
               <a:ext uri="{FF2B5EF4-FFF2-40B4-BE49-F238E27FC236}">
-                <a16:creationId xmlns:a16="http://schemas.microsoft.com/office/drawing/2014/main" id="{F52E7AD9-F9AA-4EEB-9723-3B92262DEA56}"/>
+                <a16:creationId xmlns:a16="http://schemas.microsoft.com/office/drawing/2014/main" id="{97C39C58-07E7-44C3-A883-76F2F4809114}"/>
               </a:ext>
             </a:extLst>
           </p:cNvPr>
@@ -3399,7 +3399,7 @@
           <p:cNvPr id="3" name="opening-subtitle">
             <a:extLst xmlns:a="http://schemas.openxmlformats.org/drawingml/2006/main">
               <a:ext uri="{FF2B5EF4-FFF2-40B4-BE49-F238E27FC236}">
-                <a16:creationId xmlns:a16="http://schemas.microsoft.com/office/drawing/2014/main" id="{18A01F8F-BE0E-415B-9D55-7CFC6DF2196E}"/>
+                <a16:creationId xmlns:a16="http://schemas.microsoft.com/office/drawing/2014/main" id="{D05C0FEF-0090-401E-9062-2A107DD4C9E8}"/>
               </a:ext>
             </a:extLst>
           </p:cNvPr>
@@ -3461,7 +3461,7 @@
           <p:nvPr/>
         </p:nvPicPr>
         <p:blipFill>
-          <a:blip xmlns:r="http://schemas.openxmlformats.org/officeDocument/2006/relationships" xmlns:a="http://schemas.openxmlformats.org/drawingml/2006/main" r:embed="R2164c454efae4fae"/>
+          <a:blip xmlns:r="http://schemas.openxmlformats.org/officeDocument/2006/relationships" xmlns:a="http://schemas.openxmlformats.org/drawingml/2006/main" r:embed="Rc5056658848f4414"/>
           <a:stretch xmlns:a="http://schemas.openxmlformats.org/drawingml/2006/main"/>
         </p:blipFill>
         <p:spPr>
@@ -3479,7 +3479,7 @@
           <p:cNvPr id="5" name="">
             <a:extLst xmlns:a="http://schemas.openxmlformats.org/drawingml/2006/main">
               <a:ext uri="{FF2B5EF4-FFF2-40B4-BE49-F238E27FC236}">
-                <a16:creationId xmlns:a16="http://schemas.microsoft.com/office/drawing/2014/main" id="{C13C9355-D5C6-40D4-A775-668446B05313}"/>
+                <a16:creationId xmlns:a16="http://schemas.microsoft.com/office/drawing/2014/main" id="{D8379047-42E6-44D1-B70B-EE90586C27B1}"/>
               </a:ext>
             </a:extLst>
           </p:cNvPr>
@@ -3537,7 +3537,7 @@
           <p:cNvPr id="6" name="">
             <a:extLst xmlns:a="http://schemas.openxmlformats.org/drawingml/2006/main">
               <a:ext uri="{FF2B5EF4-FFF2-40B4-BE49-F238E27FC236}">
-                <a16:creationId xmlns:a16="http://schemas.microsoft.com/office/drawing/2014/main" id="{A0B6CEFB-C3EA-435D-BE74-D71F792281A4}"/>
+                <a16:creationId xmlns:a16="http://schemas.microsoft.com/office/drawing/2014/main" id="{8D0994E9-5EFD-4AE4-902C-2837CF4C569B}"/>
               </a:ext>
             </a:extLst>
           </p:cNvPr>
@@ -3595,7 +3595,7 @@
           <p:cNvPr id="7" name="">
             <a:extLst xmlns:a="http://schemas.openxmlformats.org/drawingml/2006/main">
               <a:ext uri="{FF2B5EF4-FFF2-40B4-BE49-F238E27FC236}">
-                <a16:creationId xmlns:a16="http://schemas.microsoft.com/office/drawing/2014/main" id="{9F702463-DCF5-4469-8DDA-6B7F8BC3BDF3}"/>
+                <a16:creationId xmlns:a16="http://schemas.microsoft.com/office/drawing/2014/main" id="{8EA77797-5AFC-4B56-9380-7C078BCE9E32}"/>
               </a:ext>
             </a:extLst>
           </p:cNvPr>
@@ -3653,7 +3653,7 @@
           <p:cNvPr id="8" name="">
             <a:extLst xmlns:a="http://schemas.openxmlformats.org/drawingml/2006/main">
               <a:ext uri="{FF2B5EF4-FFF2-40B4-BE49-F238E27FC236}">
-                <a16:creationId xmlns:a16="http://schemas.microsoft.com/office/drawing/2014/main" id="{05040E2B-E407-4E21-AC30-27CBAF3B4343}"/>
+                <a16:creationId xmlns:a16="http://schemas.microsoft.com/office/drawing/2014/main" id="{BAD2D9A4-7761-428D-B1AB-D31F77122A11}"/>
               </a:ext>
             </a:extLst>
           </p:cNvPr>
@@ -3684,7 +3684,7 @@
           <p:cNvPr id="9" name="">
             <a:extLst xmlns:a="http://schemas.openxmlformats.org/drawingml/2006/main">
               <a:ext uri="{FF2B5EF4-FFF2-40B4-BE49-F238E27FC236}">
-                <a16:creationId xmlns:a16="http://schemas.microsoft.com/office/drawing/2014/main" id="{AAB5C17C-D3D5-40D0-A781-56911BAAC7CF}"/>
+                <a16:creationId xmlns:a16="http://schemas.microsoft.com/office/drawing/2014/main" id="{79233D84-61FC-4D6D-BFE5-E1685B636116}"/>
               </a:ext>
             </a:extLst>
           </p:cNvPr>
@@ -3742,7 +3742,7 @@
           <p:cNvPr id="10" name="">
             <a:extLst xmlns:a="http://schemas.openxmlformats.org/drawingml/2006/main">
               <a:ext uri="{FF2B5EF4-FFF2-40B4-BE49-F238E27FC236}">
-                <a16:creationId xmlns:a16="http://schemas.microsoft.com/office/drawing/2014/main" id="{C18B756C-0B34-4A58-A6CF-E2F57514C919}"/>
+                <a16:creationId xmlns:a16="http://schemas.microsoft.com/office/drawing/2014/main" id="{DFC4593B-613C-4E8D-BD6D-C2A846F6350C}"/>
               </a:ext>
             </a:extLst>
           </p:cNvPr>
@@ -3804,7 +3804,7 @@
           <p:cNvPr id="11" name="">
             <a:extLst xmlns:a="http://schemas.openxmlformats.org/drawingml/2006/main">
               <a:ext uri="{FF2B5EF4-FFF2-40B4-BE49-F238E27FC236}">
-                <a16:creationId xmlns:a16="http://schemas.microsoft.com/office/drawing/2014/main" id="{033E0E6E-103C-4C89-923E-B2BB6B5B7288}"/>
+                <a16:creationId xmlns:a16="http://schemas.microsoft.com/office/drawing/2014/main" id="{C0695021-5DDC-4E3B-B9BD-A382924F0E46}"/>
               </a:ext>
             </a:extLst>
           </p:cNvPr>
@@ -3835,7 +3835,7 @@
           <p:cNvPr id="12" name="">
             <a:extLst xmlns:a="http://schemas.openxmlformats.org/drawingml/2006/main">
               <a:ext uri="{FF2B5EF4-FFF2-40B4-BE49-F238E27FC236}">
-                <a16:creationId xmlns:a16="http://schemas.microsoft.com/office/drawing/2014/main" id="{1E8AE32E-C253-4C80-9D66-8D8E27AD3B5A}"/>
+                <a16:creationId xmlns:a16="http://schemas.microsoft.com/office/drawing/2014/main" id="{48924852-5FB0-450B-A5B3-6C3584A8DEA6}"/>
               </a:ext>
             </a:extLst>
           </p:cNvPr>
@@ -3897,7 +3897,7 @@
           <p:cNvPr id="13" name="">
             <a:extLst xmlns:a="http://schemas.openxmlformats.org/drawingml/2006/main">
               <a:ext uri="{FF2B5EF4-FFF2-40B4-BE49-F238E27FC236}">
-                <a16:creationId xmlns:a16="http://schemas.microsoft.com/office/drawing/2014/main" id="{34A072E1-F07C-4679-A2E9-013AD940CF50}"/>
+                <a16:creationId xmlns:a16="http://schemas.microsoft.com/office/drawing/2014/main" id="{1170C20D-7A89-46C0-95F7-C020DFCC48DD}"/>
               </a:ext>
             </a:extLst>
           </p:cNvPr>
@@ -3928,7 +3928,7 @@
           <p:cNvPr id="14" name="">
             <a:extLst xmlns:a="http://schemas.openxmlformats.org/drawingml/2006/main">
               <a:ext uri="{FF2B5EF4-FFF2-40B4-BE49-F238E27FC236}">
-                <a16:creationId xmlns:a16="http://schemas.microsoft.com/office/drawing/2014/main" id="{644589DD-B3C1-403C-98C5-CA5B4B13CCDF}"/>
+                <a16:creationId xmlns:a16="http://schemas.microsoft.com/office/drawing/2014/main" id="{4C2045D1-C586-402B-B7DF-D32A6886B5A3}"/>
               </a:ext>
             </a:extLst>
           </p:cNvPr>
@@ -3990,7 +3990,7 @@
           <p:cNvPr id="15" name="">
             <a:extLst xmlns:a="http://schemas.openxmlformats.org/drawingml/2006/main">
               <a:ext uri="{FF2B5EF4-FFF2-40B4-BE49-F238E27FC236}">
-                <a16:creationId xmlns:a16="http://schemas.microsoft.com/office/drawing/2014/main" id="{CEAEA117-6BBB-4024-96CF-D1A35807E5A0}"/>
+                <a16:creationId xmlns:a16="http://schemas.microsoft.com/office/drawing/2014/main" id="{CAD0215D-48D7-472F-80E5-3D64CEF14923}"/>
               </a:ext>
             </a:extLst>
           </p:cNvPr>
@@ -4021,7 +4021,7 @@
           <p:cNvPr id="16" name="">
             <a:extLst xmlns:a="http://schemas.openxmlformats.org/drawingml/2006/main">
               <a:ext uri="{FF2B5EF4-FFF2-40B4-BE49-F238E27FC236}">
-                <a16:creationId xmlns:a16="http://schemas.microsoft.com/office/drawing/2014/main" id="{9A297E97-BCCA-46C5-87D2-A7CCF1B3A52B}"/>
+                <a16:creationId xmlns:a16="http://schemas.microsoft.com/office/drawing/2014/main" id="{5A2B0ECA-21C3-44EB-B33C-360FE18DDDAC}"/>
               </a:ext>
             </a:extLst>
           </p:cNvPr>
@@ -4083,7 +4083,7 @@
           <p:cNvPr id="17" name="">
             <a:extLst xmlns:a="http://schemas.openxmlformats.org/drawingml/2006/main">
               <a:ext uri="{FF2B5EF4-FFF2-40B4-BE49-F238E27FC236}">
-                <a16:creationId xmlns:a16="http://schemas.microsoft.com/office/drawing/2014/main" id="{066D31EB-364E-42E8-975E-1B0E48293880}"/>
+                <a16:creationId xmlns:a16="http://schemas.microsoft.com/office/drawing/2014/main" id="{7B00AF0B-4DFE-4169-92E8-442DA7A75C83}"/>
               </a:ext>
             </a:extLst>
           </p:cNvPr>
@@ -4139,7 +4139,7 @@
     </p:spTree>
     <p:extLst>
       <p:ext uri="{BB962C8B-B14F-4D97-AF65-F5344CB8AC3E}">
-        <p14:creationId xmlns:p14="http://schemas.microsoft.com/office/powerpoint/2010/main" val="540047547"/>
+        <p14:creationId xmlns:p14="http://schemas.microsoft.com/office/powerpoint/2010/main" val="1594995037"/>
       </p:ext>
     </p:extLst>
   </p:cSld>
@@ -4170,7 +4170,7 @@
           <p:cNvPr id="52" name="title-T1">
             <a:extLst xmlns:a="http://schemas.openxmlformats.org/drawingml/2006/main">
               <a:ext uri="{FF2B5EF4-FFF2-40B4-BE49-F238E27FC236}">
-                <a16:creationId xmlns:a16="http://schemas.microsoft.com/office/drawing/2014/main" id="{CA975157-4D34-4BC0-B602-B4AADDA8193C}"/>
+                <a16:creationId xmlns:a16="http://schemas.microsoft.com/office/drawing/2014/main" id="{BB593B5A-0F05-4188-A590-0AD5A0C15C2E}"/>
               </a:ext>
             </a:extLst>
           </p:cNvPr>
@@ -4232,7 +4232,7 @@
           <p:cNvPr id="2" name="subtitle-T1">
             <a:extLst xmlns:a="http://schemas.openxmlformats.org/drawingml/2006/main">
               <a:ext uri="{FF2B5EF4-FFF2-40B4-BE49-F238E27FC236}">
-                <a16:creationId xmlns:a16="http://schemas.microsoft.com/office/drawing/2014/main" id="{B78CBCFF-68D3-44BA-95DE-E5B43B5D08C0}"/>
+                <a16:creationId xmlns:a16="http://schemas.microsoft.com/office/drawing/2014/main" id="{C9983D9D-7E6C-44BB-9310-7549D160557F}"/>
               </a:ext>
             </a:extLst>
           </p:cNvPr>
@@ -4294,7 +4294,7 @@
           <p:nvPr/>
         </p:nvPicPr>
         <p:blipFill>
-          <a:blip xmlns:r="http://schemas.openxmlformats.org/officeDocument/2006/relationships" xmlns:a="http://schemas.openxmlformats.org/drawingml/2006/main" r:embed="Rb95c309005494756"/>
+          <a:blip xmlns:r="http://schemas.openxmlformats.org/officeDocument/2006/relationships" xmlns:a="http://schemas.openxmlformats.org/drawingml/2006/main" r:embed="R3b1568038d8a40fd"/>
           <a:stretch xmlns:a="http://schemas.openxmlformats.org/drawingml/2006/main"/>
         </p:blipFill>
         <p:spPr>
@@ -4312,7 +4312,7 @@
           <p:cNvPr id="4" name="">
             <a:extLst xmlns:a="http://schemas.openxmlformats.org/drawingml/2006/main">
               <a:ext uri="{FF2B5EF4-FFF2-40B4-BE49-F238E27FC236}">
-                <a16:creationId xmlns:a16="http://schemas.microsoft.com/office/drawing/2014/main" id="{9CF7D4D9-AFAF-43D0-B622-4F31BA45D5C5}"/>
+                <a16:creationId xmlns:a16="http://schemas.microsoft.com/office/drawing/2014/main" id="{048D43EB-01AA-4F24-94F6-D8292AE89853}"/>
               </a:ext>
             </a:extLst>
           </p:cNvPr>
@@ -4343,7 +4343,7 @@
           <p:cNvPr id="5" name="">
             <a:extLst xmlns:a="http://schemas.openxmlformats.org/drawingml/2006/main">
               <a:ext uri="{FF2B5EF4-FFF2-40B4-BE49-F238E27FC236}">
-                <a16:creationId xmlns:a16="http://schemas.microsoft.com/office/drawing/2014/main" id="{7D687010-1340-47D2-8266-539C54ACF213}"/>
+                <a16:creationId xmlns:a16="http://schemas.microsoft.com/office/drawing/2014/main" id="{142DE747-0669-43AF-895F-1A7A2EEFC1B1}"/>
               </a:ext>
             </a:extLst>
           </p:cNvPr>
@@ -4374,7 +4374,7 @@
           <p:cNvPr id="6" name="">
             <a:extLst xmlns:a="http://schemas.openxmlformats.org/drawingml/2006/main">
               <a:ext uri="{FF2B5EF4-FFF2-40B4-BE49-F238E27FC236}">
-                <a16:creationId xmlns:a16="http://schemas.microsoft.com/office/drawing/2014/main" id="{71BC9803-B830-4F65-9C5E-65FBF88252CA}"/>
+                <a16:creationId xmlns:a16="http://schemas.microsoft.com/office/drawing/2014/main" id="{C95457D1-41F8-4AA6-973E-FEF3F059E6EB}"/>
               </a:ext>
             </a:extLst>
           </p:cNvPr>
@@ -4407,7 +4407,7 @@
           <p:cNvPr id="7" name="">
             <a:extLst xmlns:a="http://schemas.openxmlformats.org/drawingml/2006/main">
               <a:ext uri="{FF2B5EF4-FFF2-40B4-BE49-F238E27FC236}">
-                <a16:creationId xmlns:a16="http://schemas.microsoft.com/office/drawing/2014/main" id="{71B77615-49E9-484D-8CCF-F130DC2D3EB0}"/>
+                <a16:creationId xmlns:a16="http://schemas.microsoft.com/office/drawing/2014/main" id="{197EC19F-1316-4BB3-990C-7FB4B43C31FB}"/>
               </a:ext>
             </a:extLst>
           </p:cNvPr>
@@ -4465,7 +4465,7 @@
           <p:cNvPr id="8" name="">
             <a:extLst xmlns:a="http://schemas.openxmlformats.org/drawingml/2006/main">
               <a:ext uri="{FF2B5EF4-FFF2-40B4-BE49-F238E27FC236}">
-                <a16:creationId xmlns:a16="http://schemas.microsoft.com/office/drawing/2014/main" id="{075B2063-91A1-4E69-8592-D276D225CB19}"/>
+                <a16:creationId xmlns:a16="http://schemas.microsoft.com/office/drawing/2014/main" id="{876CD317-C9D4-4105-A147-85A3DC5C7F76}"/>
               </a:ext>
             </a:extLst>
           </p:cNvPr>
@@ -4496,7 +4496,7 @@
           <p:cNvPr id="9" name="">
             <a:extLst xmlns:a="http://schemas.openxmlformats.org/drawingml/2006/main">
               <a:ext uri="{FF2B5EF4-FFF2-40B4-BE49-F238E27FC236}">
-                <a16:creationId xmlns:a16="http://schemas.microsoft.com/office/drawing/2014/main" id="{6F112DA9-DD4F-4444-9627-C4CCC1AC331B}"/>
+                <a16:creationId xmlns:a16="http://schemas.microsoft.com/office/drawing/2014/main" id="{D94EA819-FFF2-45E7-A86A-6BA75EE3FDF7}"/>
               </a:ext>
             </a:extLst>
           </p:cNvPr>
@@ -4529,7 +4529,7 @@
           <p:cNvPr id="10" name="">
             <a:extLst xmlns:a="http://schemas.openxmlformats.org/drawingml/2006/main">
               <a:ext uri="{FF2B5EF4-FFF2-40B4-BE49-F238E27FC236}">
-                <a16:creationId xmlns:a16="http://schemas.microsoft.com/office/drawing/2014/main" id="{1C2644D9-D567-4838-896C-B690C1FFC62D}"/>
+                <a16:creationId xmlns:a16="http://schemas.microsoft.com/office/drawing/2014/main" id="{B3FE04C7-8E5B-453D-90D7-483A68AA871A}"/>
               </a:ext>
             </a:extLst>
           </p:cNvPr>
@@ -4587,7 +4587,7 @@
           <p:cNvPr id="11" name="">
             <a:extLst xmlns:a="http://schemas.openxmlformats.org/drawingml/2006/main">
               <a:ext uri="{FF2B5EF4-FFF2-40B4-BE49-F238E27FC236}">
-                <a16:creationId xmlns:a16="http://schemas.microsoft.com/office/drawing/2014/main" id="{4804DA58-D71E-49BB-8BC3-239B25F06F1D}"/>
+                <a16:creationId xmlns:a16="http://schemas.microsoft.com/office/drawing/2014/main" id="{ED3ED37C-04B4-4941-9C82-3020724C97A7}"/>
               </a:ext>
             </a:extLst>
           </p:cNvPr>
@@ -4618,7 +4618,7 @@
           <p:cNvPr id="12" name="">
             <a:extLst xmlns:a="http://schemas.openxmlformats.org/drawingml/2006/main">
               <a:ext uri="{FF2B5EF4-FFF2-40B4-BE49-F238E27FC236}">
-                <a16:creationId xmlns:a16="http://schemas.microsoft.com/office/drawing/2014/main" id="{16685913-B71D-4B48-9659-073C0B6F4865}"/>
+                <a16:creationId xmlns:a16="http://schemas.microsoft.com/office/drawing/2014/main" id="{B8466040-6D5A-4384-B50F-32D1C2D089D0}"/>
               </a:ext>
             </a:extLst>
           </p:cNvPr>
@@ -4651,7 +4651,7 @@
           <p:cNvPr id="13" name="">
             <a:extLst xmlns:a="http://schemas.openxmlformats.org/drawingml/2006/main">
               <a:ext uri="{FF2B5EF4-FFF2-40B4-BE49-F238E27FC236}">
-                <a16:creationId xmlns:a16="http://schemas.microsoft.com/office/drawing/2014/main" id="{7EBA3D02-E7E2-43D4-A175-F0A8AB7EB155}"/>
+                <a16:creationId xmlns:a16="http://schemas.microsoft.com/office/drawing/2014/main" id="{BFAE23CD-AB86-4D7F-A2A5-FF589E2EB5DF}"/>
               </a:ext>
             </a:extLst>
           </p:cNvPr>
@@ -4709,7 +4709,7 @@
           <p:cNvPr id="14" name="">
             <a:extLst xmlns:a="http://schemas.openxmlformats.org/drawingml/2006/main">
               <a:ext uri="{FF2B5EF4-FFF2-40B4-BE49-F238E27FC236}">
-                <a16:creationId xmlns:a16="http://schemas.microsoft.com/office/drawing/2014/main" id="{B48B9187-A95F-49FF-8966-A57048493BFC}"/>
+                <a16:creationId xmlns:a16="http://schemas.microsoft.com/office/drawing/2014/main" id="{6A60AC9D-A1AE-4EA5-BC76-A0ABA52A2A8B}"/>
               </a:ext>
             </a:extLst>
           </p:cNvPr>
@@ -4740,7 +4740,7 @@
           <p:cNvPr id="15" name="">
             <a:extLst xmlns:a="http://schemas.openxmlformats.org/drawingml/2006/main">
               <a:ext uri="{FF2B5EF4-FFF2-40B4-BE49-F238E27FC236}">
-                <a16:creationId xmlns:a16="http://schemas.microsoft.com/office/drawing/2014/main" id="{EE413A3B-B201-4696-B191-55904AB557D5}"/>
+                <a16:creationId xmlns:a16="http://schemas.microsoft.com/office/drawing/2014/main" id="{7AC1AFF2-F2A2-4252-B6D2-F213F7C84FBB}"/>
               </a:ext>
             </a:extLst>
           </p:cNvPr>
@@ -4773,7 +4773,7 @@
           <p:cNvPr id="16" name="">
             <a:extLst xmlns:a="http://schemas.openxmlformats.org/drawingml/2006/main">
               <a:ext uri="{FF2B5EF4-FFF2-40B4-BE49-F238E27FC236}">
-                <a16:creationId xmlns:a16="http://schemas.microsoft.com/office/drawing/2014/main" id="{C0F3F1A0-8595-46E6-86D0-3C1B4B643C6F}"/>
+                <a16:creationId xmlns:a16="http://schemas.microsoft.com/office/drawing/2014/main" id="{70F9D8FC-848B-47A7-BB22-E3695C90EED6}"/>
               </a:ext>
             </a:extLst>
           </p:cNvPr>
@@ -4831,7 +4831,7 @@
           <p:cNvPr id="17" name="">
             <a:extLst xmlns:a="http://schemas.openxmlformats.org/drawingml/2006/main">
               <a:ext uri="{FF2B5EF4-FFF2-40B4-BE49-F238E27FC236}">
-                <a16:creationId xmlns:a16="http://schemas.microsoft.com/office/drawing/2014/main" id="{93DF29B3-5CE9-4C04-95D5-3D9FDB855DD3}"/>
+                <a16:creationId xmlns:a16="http://schemas.microsoft.com/office/drawing/2014/main" id="{01DD0404-BADC-4C82-B3D3-DBD6038EA9B9}"/>
               </a:ext>
             </a:extLst>
           </p:cNvPr>
@@ -4862,7 +4862,7 @@
           <p:cNvPr id="18" name="">
             <a:extLst xmlns:a="http://schemas.openxmlformats.org/drawingml/2006/main">
               <a:ext uri="{FF2B5EF4-FFF2-40B4-BE49-F238E27FC236}">
-                <a16:creationId xmlns:a16="http://schemas.microsoft.com/office/drawing/2014/main" id="{42D6BB6D-30A7-4A74-9688-DFE905882779}"/>
+                <a16:creationId xmlns:a16="http://schemas.microsoft.com/office/drawing/2014/main" id="{4D24E6E6-AE2C-43A2-913B-33643A11A234}"/>
               </a:ext>
             </a:extLst>
           </p:cNvPr>
@@ -4895,7 +4895,7 @@
           <p:cNvPr id="19" name="">
             <a:extLst xmlns:a="http://schemas.openxmlformats.org/drawingml/2006/main">
               <a:ext uri="{FF2B5EF4-FFF2-40B4-BE49-F238E27FC236}">
-                <a16:creationId xmlns:a16="http://schemas.microsoft.com/office/drawing/2014/main" id="{BC66C58F-3C9A-4EC0-A66A-44F562623C58}"/>
+                <a16:creationId xmlns:a16="http://schemas.microsoft.com/office/drawing/2014/main" id="{57A5ECA6-B1AA-4D25-AA4B-CC4AE97BED9C}"/>
               </a:ext>
             </a:extLst>
           </p:cNvPr>
@@ -4953,7 +4953,7 @@
           <p:cNvPr id="20" name="">
             <a:extLst xmlns:a="http://schemas.openxmlformats.org/drawingml/2006/main">
               <a:ext uri="{FF2B5EF4-FFF2-40B4-BE49-F238E27FC236}">
-                <a16:creationId xmlns:a16="http://schemas.microsoft.com/office/drawing/2014/main" id="{BE8BC841-2F30-445B-B960-BCD9F7778816}"/>
+                <a16:creationId xmlns:a16="http://schemas.microsoft.com/office/drawing/2014/main" id="{7811E6AF-CB3C-4952-B9B3-D428F0DAC7D6}"/>
               </a:ext>
             </a:extLst>
           </p:cNvPr>
@@ -4984,7 +4984,7 @@
           <p:cNvPr id="21" name="">
             <a:extLst xmlns:a="http://schemas.openxmlformats.org/drawingml/2006/main">
               <a:ext uri="{FF2B5EF4-FFF2-40B4-BE49-F238E27FC236}">
-                <a16:creationId xmlns:a16="http://schemas.microsoft.com/office/drawing/2014/main" id="{1EA5628F-E983-4C41-8E03-59C7C85C9CAF}"/>
+                <a16:creationId xmlns:a16="http://schemas.microsoft.com/office/drawing/2014/main" id="{43C36A11-BB6A-4855-8908-842CDD6C2D77}"/>
               </a:ext>
             </a:extLst>
           </p:cNvPr>
@@ -5017,7 +5017,7 @@
           <p:cNvPr id="22" name="">
             <a:extLst xmlns:a="http://schemas.openxmlformats.org/drawingml/2006/main">
               <a:ext uri="{FF2B5EF4-FFF2-40B4-BE49-F238E27FC236}">
-                <a16:creationId xmlns:a16="http://schemas.microsoft.com/office/drawing/2014/main" id="{00433986-F382-4F4F-9550-06757594C5EA}"/>
+                <a16:creationId xmlns:a16="http://schemas.microsoft.com/office/drawing/2014/main" id="{950FA0E9-F935-41F4-BD4C-FDC9DA5F862B}"/>
               </a:ext>
             </a:extLst>
           </p:cNvPr>
@@ -5075,7 +5075,7 @@
           <p:cNvPr id="23" name="">
             <a:extLst xmlns:a="http://schemas.openxmlformats.org/drawingml/2006/main">
               <a:ext uri="{FF2B5EF4-FFF2-40B4-BE49-F238E27FC236}">
-                <a16:creationId xmlns:a16="http://schemas.microsoft.com/office/drawing/2014/main" id="{46E82074-BCB0-4EE8-84C9-0EAD00CD7730}"/>
+                <a16:creationId xmlns:a16="http://schemas.microsoft.com/office/drawing/2014/main" id="{C7AE96B6-A868-4003-BEC0-0C7ED6B59246}"/>
               </a:ext>
             </a:extLst>
           </p:cNvPr>
@@ -5106,7 +5106,7 @@
           <p:cNvPr id="24" name="">
             <a:extLst xmlns:a="http://schemas.openxmlformats.org/drawingml/2006/main">
               <a:ext uri="{FF2B5EF4-FFF2-40B4-BE49-F238E27FC236}">
-                <a16:creationId xmlns:a16="http://schemas.microsoft.com/office/drawing/2014/main" id="{94B1E1C5-C703-41FC-8E88-E426BF02FEA1}"/>
+                <a16:creationId xmlns:a16="http://schemas.microsoft.com/office/drawing/2014/main" id="{F0FB2A96-1D14-48BC-A057-C360A09C1C70}"/>
               </a:ext>
             </a:extLst>
           </p:cNvPr>
@@ -5139,7 +5139,7 @@
           <p:cNvPr id="25" name="">
             <a:extLst xmlns:a="http://schemas.openxmlformats.org/drawingml/2006/main">
               <a:ext uri="{FF2B5EF4-FFF2-40B4-BE49-F238E27FC236}">
-                <a16:creationId xmlns:a16="http://schemas.microsoft.com/office/drawing/2014/main" id="{19196D5C-D928-4105-A37E-099D96667014}"/>
+                <a16:creationId xmlns:a16="http://schemas.microsoft.com/office/drawing/2014/main" id="{378FBA5D-682D-4C82-BAC3-9876A3091BC2}"/>
               </a:ext>
             </a:extLst>
           </p:cNvPr>
@@ -5197,7 +5197,7 @@
           <p:cNvPr id="26" name="">
             <a:extLst xmlns:a="http://schemas.openxmlformats.org/drawingml/2006/main">
               <a:ext uri="{FF2B5EF4-FFF2-40B4-BE49-F238E27FC236}">
-                <a16:creationId xmlns:a16="http://schemas.microsoft.com/office/drawing/2014/main" id="{04221DC2-2412-4435-9A7C-BE9CA28A65FA}"/>
+                <a16:creationId xmlns:a16="http://schemas.microsoft.com/office/drawing/2014/main" id="{99E33A42-0950-4A3F-9FE8-19A8057CF35A}"/>
               </a:ext>
             </a:extLst>
           </p:cNvPr>
@@ -5228,7 +5228,7 @@
           <p:cNvPr id="27" name="">
             <a:extLst xmlns:a="http://schemas.openxmlformats.org/drawingml/2006/main">
               <a:ext uri="{FF2B5EF4-FFF2-40B4-BE49-F238E27FC236}">
-                <a16:creationId xmlns:a16="http://schemas.microsoft.com/office/drawing/2014/main" id="{CD6F3CF8-6B71-42C6-BBE1-B7957CB69E76}"/>
+                <a16:creationId xmlns:a16="http://schemas.microsoft.com/office/drawing/2014/main" id="{451BC53C-4BCF-4271-9958-720A95D1E4CD}"/>
               </a:ext>
             </a:extLst>
           </p:cNvPr>
@@ -5261,7 +5261,7 @@
           <p:cNvPr id="28" name="">
             <a:extLst xmlns:a="http://schemas.openxmlformats.org/drawingml/2006/main">
               <a:ext uri="{FF2B5EF4-FFF2-40B4-BE49-F238E27FC236}">
-                <a16:creationId xmlns:a16="http://schemas.microsoft.com/office/drawing/2014/main" id="{EF223D17-8574-4FFB-902F-5CC5720E1CB0}"/>
+                <a16:creationId xmlns:a16="http://schemas.microsoft.com/office/drawing/2014/main" id="{BFFDF911-4DB8-4515-A5F2-15F28AE3609E}"/>
               </a:ext>
             </a:extLst>
           </p:cNvPr>
@@ -5319,7 +5319,7 @@
           <p:cNvPr id="29" name="">
             <a:extLst xmlns:a="http://schemas.openxmlformats.org/drawingml/2006/main">
               <a:ext uri="{FF2B5EF4-FFF2-40B4-BE49-F238E27FC236}">
-                <a16:creationId xmlns:a16="http://schemas.microsoft.com/office/drawing/2014/main" id="{E40C4367-9741-4A52-9B83-86CBE2824582}"/>
+                <a16:creationId xmlns:a16="http://schemas.microsoft.com/office/drawing/2014/main" id="{7384CFF8-F1BA-4597-B65F-1CC68991DBFE}"/>
               </a:ext>
             </a:extLst>
           </p:cNvPr>
@@ -5350,7 +5350,7 @@
           <p:cNvPr id="30" name="">
             <a:extLst xmlns:a="http://schemas.openxmlformats.org/drawingml/2006/main">
               <a:ext uri="{FF2B5EF4-FFF2-40B4-BE49-F238E27FC236}">
-                <a16:creationId xmlns:a16="http://schemas.microsoft.com/office/drawing/2014/main" id="{C223AB71-752F-407C-A4BF-DBA3A76582BF}"/>
+                <a16:creationId xmlns:a16="http://schemas.microsoft.com/office/drawing/2014/main" id="{C48FCFFE-41E9-4AF8-8A19-67E694CF77E1}"/>
               </a:ext>
             </a:extLst>
           </p:cNvPr>
@@ -5383,7 +5383,7 @@
           <p:cNvPr id="31" name="">
             <a:extLst xmlns:a="http://schemas.openxmlformats.org/drawingml/2006/main">
               <a:ext uri="{FF2B5EF4-FFF2-40B4-BE49-F238E27FC236}">
-                <a16:creationId xmlns:a16="http://schemas.microsoft.com/office/drawing/2014/main" id="{F7F7962F-FCF3-45A4-B1CD-AFAAAE41987A}"/>
+                <a16:creationId xmlns:a16="http://schemas.microsoft.com/office/drawing/2014/main" id="{F9F2660E-797F-49BC-AAD0-4CF6492B94DE}"/>
               </a:ext>
             </a:extLst>
           </p:cNvPr>
@@ -5441,7 +5441,7 @@
           <p:cNvPr id="32" name="">
             <a:extLst xmlns:a="http://schemas.openxmlformats.org/drawingml/2006/main">
               <a:ext uri="{FF2B5EF4-FFF2-40B4-BE49-F238E27FC236}">
-                <a16:creationId xmlns:a16="http://schemas.microsoft.com/office/drawing/2014/main" id="{731DB297-3DEE-4483-99A9-D853B9DFD0C4}"/>
+                <a16:creationId xmlns:a16="http://schemas.microsoft.com/office/drawing/2014/main" id="{650C7352-5AA7-4E2C-B8FC-BB4617EE3852}"/>
               </a:ext>
             </a:extLst>
           </p:cNvPr>
@@ -5472,7 +5472,7 @@
           <p:cNvPr id="33" name="">
             <a:extLst xmlns:a="http://schemas.openxmlformats.org/drawingml/2006/main">
               <a:ext uri="{FF2B5EF4-FFF2-40B4-BE49-F238E27FC236}">
-                <a16:creationId xmlns:a16="http://schemas.microsoft.com/office/drawing/2014/main" id="{AA506D51-BC91-43A4-9290-B22176A95908}"/>
+                <a16:creationId xmlns:a16="http://schemas.microsoft.com/office/drawing/2014/main" id="{44766686-2329-4B98-8597-7675AA083E5B}"/>
               </a:ext>
             </a:extLst>
           </p:cNvPr>
@@ -5505,7 +5505,7 @@
           <p:cNvPr id="34" name="">
             <a:extLst xmlns:a="http://schemas.openxmlformats.org/drawingml/2006/main">
               <a:ext uri="{FF2B5EF4-FFF2-40B4-BE49-F238E27FC236}">
-                <a16:creationId xmlns:a16="http://schemas.microsoft.com/office/drawing/2014/main" id="{703358F1-1838-4292-A00A-7D3A04AD23D5}"/>
+                <a16:creationId xmlns:a16="http://schemas.microsoft.com/office/drawing/2014/main" id="{5CA8BD6B-617C-4A52-ABEB-5C8EC26F2A11}"/>
               </a:ext>
             </a:extLst>
           </p:cNvPr>
@@ -5563,7 +5563,7 @@
           <p:cNvPr id="35" name="">
             <a:extLst xmlns:a="http://schemas.openxmlformats.org/drawingml/2006/main">
               <a:ext uri="{FF2B5EF4-FFF2-40B4-BE49-F238E27FC236}">
-                <a16:creationId xmlns:a16="http://schemas.microsoft.com/office/drawing/2014/main" id="{14ADACA5-5227-4A7E-B080-288C47B772A9}"/>
+                <a16:creationId xmlns:a16="http://schemas.microsoft.com/office/drawing/2014/main" id="{4319CCCA-08AA-46BD-9E1B-B01B532E53EB}"/>
               </a:ext>
             </a:extLst>
           </p:cNvPr>
@@ -5594,7 +5594,7 @@
           <p:cNvPr id="36" name="">
             <a:extLst xmlns:a="http://schemas.openxmlformats.org/drawingml/2006/main">
               <a:ext uri="{FF2B5EF4-FFF2-40B4-BE49-F238E27FC236}">
-                <a16:creationId xmlns:a16="http://schemas.microsoft.com/office/drawing/2014/main" id="{346D0E2C-E4A3-4DB1-8754-D5F6E391A5ED}"/>
+                <a16:creationId xmlns:a16="http://schemas.microsoft.com/office/drawing/2014/main" id="{58DAF6EE-DE75-49C0-9F45-0589839B7CD4}"/>
               </a:ext>
             </a:extLst>
           </p:cNvPr>
@@ -5627,7 +5627,7 @@
           <p:cNvPr id="37" name="">
             <a:extLst xmlns:a="http://schemas.openxmlformats.org/drawingml/2006/main">
               <a:ext uri="{FF2B5EF4-FFF2-40B4-BE49-F238E27FC236}">
-                <a16:creationId xmlns:a16="http://schemas.microsoft.com/office/drawing/2014/main" id="{8ABB79F2-FAC7-4CA2-A832-332EF42A7DC5}"/>
+                <a16:creationId xmlns:a16="http://schemas.microsoft.com/office/drawing/2014/main" id="{7C8395C0-A61D-45BF-B536-A73F93619808}"/>
               </a:ext>
             </a:extLst>
           </p:cNvPr>
@@ -5685,7 +5685,7 @@
           <p:cNvPr id="38" name="">
             <a:extLst xmlns:a="http://schemas.openxmlformats.org/drawingml/2006/main">
               <a:ext uri="{FF2B5EF4-FFF2-40B4-BE49-F238E27FC236}">
-                <a16:creationId xmlns:a16="http://schemas.microsoft.com/office/drawing/2014/main" id="{798DC0D3-FA72-432C-B9DD-AA7C3D7F72CD}"/>
+                <a16:creationId xmlns:a16="http://schemas.microsoft.com/office/drawing/2014/main" id="{5CD7EF1B-1327-41EF-BD15-410DEB22D3BB}"/>
               </a:ext>
             </a:extLst>
           </p:cNvPr>
@@ -5720,7 +5720,7 @@
           <p:cNvPr id="39" name="">
             <a:extLst xmlns:a="http://schemas.openxmlformats.org/drawingml/2006/main">
               <a:ext uri="{FF2B5EF4-FFF2-40B4-BE49-F238E27FC236}">
-                <a16:creationId xmlns:a16="http://schemas.microsoft.com/office/drawing/2014/main" id="{9C1F6132-8975-4F1D-ADE6-E36A85ADBBE4}"/>
+                <a16:creationId xmlns:a16="http://schemas.microsoft.com/office/drawing/2014/main" id="{226F1CBD-CFC6-45D2-B77C-5917656D039E}"/>
               </a:ext>
             </a:extLst>
           </p:cNvPr>
@@ -5782,7 +5782,7 @@
           <p:nvPr/>
         </p:nvPicPr>
         <p:blipFill>
-          <a:blip xmlns:r="http://schemas.openxmlformats.org/officeDocument/2006/relationships" xmlns:a="http://schemas.openxmlformats.org/drawingml/2006/main" r:embed="R49fbd20e6f544e3d"/>
+          <a:blip xmlns:r="http://schemas.openxmlformats.org/officeDocument/2006/relationships" xmlns:a="http://schemas.openxmlformats.org/drawingml/2006/main" r:embed="R63fb34e20ead4068"/>
           <a:stretch xmlns:a="http://schemas.openxmlformats.org/drawingml/2006/main"/>
         </p:blipFill>
         <p:spPr>
@@ -5800,7 +5800,7 @@
           <p:cNvPr id="41" name="">
             <a:extLst xmlns:a="http://schemas.openxmlformats.org/drawingml/2006/main">
               <a:ext uri="{FF2B5EF4-FFF2-40B4-BE49-F238E27FC236}">
-                <a16:creationId xmlns:a16="http://schemas.microsoft.com/office/drawing/2014/main" id="{3DC6DD88-1F57-4B5C-887E-A206EEBEC82A}"/>
+                <a16:creationId xmlns:a16="http://schemas.microsoft.com/office/drawing/2014/main" id="{12E6C616-E7D8-4C9C-8A18-33B6611AA863}"/>
               </a:ext>
             </a:extLst>
           </p:cNvPr>
@@ -5858,7 +5858,7 @@
           <p:cNvPr id="42" name="">
             <a:extLst xmlns:a="http://schemas.openxmlformats.org/drawingml/2006/main">
               <a:ext uri="{FF2B5EF4-FFF2-40B4-BE49-F238E27FC236}">
-                <a16:creationId xmlns:a16="http://schemas.microsoft.com/office/drawing/2014/main" id="{26CD00B7-98C7-4005-AFEB-DFC78C7F15CB}"/>
+                <a16:creationId xmlns:a16="http://schemas.microsoft.com/office/drawing/2014/main" id="{A006C5C9-8910-4F80-A429-E7CE0C798309}"/>
               </a:ext>
             </a:extLst>
           </p:cNvPr>
@@ -5893,7 +5893,7 @@
           <p:cNvPr id="43" name="">
             <a:extLst xmlns:a="http://schemas.openxmlformats.org/drawingml/2006/main">
               <a:ext uri="{FF2B5EF4-FFF2-40B4-BE49-F238E27FC236}">
-                <a16:creationId xmlns:a16="http://schemas.microsoft.com/office/drawing/2014/main" id="{9C42CC56-E5D4-41F9-8CD6-75D1AD67E6A1}"/>
+                <a16:creationId xmlns:a16="http://schemas.microsoft.com/office/drawing/2014/main" id="{5A810CD8-0177-457D-882F-11F00427F55D}"/>
               </a:ext>
             </a:extLst>
           </p:cNvPr>
@@ -5955,7 +5955,7 @@
           <p:nvPr/>
         </p:nvPicPr>
         <p:blipFill>
-          <a:blip xmlns:r="http://schemas.openxmlformats.org/officeDocument/2006/relationships" xmlns:a="http://schemas.openxmlformats.org/drawingml/2006/main" r:embed="R612650c231764ab0"/>
+          <a:blip xmlns:r="http://schemas.openxmlformats.org/officeDocument/2006/relationships" xmlns:a="http://schemas.openxmlformats.org/drawingml/2006/main" r:embed="R012b4033ffc44518"/>
           <a:stretch xmlns:a="http://schemas.openxmlformats.org/drawingml/2006/main"/>
         </p:blipFill>
         <p:spPr>
@@ -5973,7 +5973,7 @@
           <p:cNvPr id="45" name="">
             <a:extLst xmlns:a="http://schemas.openxmlformats.org/drawingml/2006/main">
               <a:ext uri="{FF2B5EF4-FFF2-40B4-BE49-F238E27FC236}">
-                <a16:creationId xmlns:a16="http://schemas.microsoft.com/office/drawing/2014/main" id="{CF3C11B9-6AEC-4743-9894-2D4F1C5B1EFC}"/>
+                <a16:creationId xmlns:a16="http://schemas.microsoft.com/office/drawing/2014/main" id="{642980F8-8523-41E2-857C-2FC2BD9E58CD}"/>
               </a:ext>
             </a:extLst>
           </p:cNvPr>
@@ -6031,7 +6031,7 @@
           <p:cNvPr id="46" name="">
             <a:extLst xmlns:a="http://schemas.openxmlformats.org/drawingml/2006/main">
               <a:ext uri="{FF2B5EF4-FFF2-40B4-BE49-F238E27FC236}">
-                <a16:creationId xmlns:a16="http://schemas.microsoft.com/office/drawing/2014/main" id="{766B3966-088C-47F6-8BCE-20195160D66F}"/>
+                <a16:creationId xmlns:a16="http://schemas.microsoft.com/office/drawing/2014/main" id="{11B6F3DE-FB92-42E6-AA0F-866C28B951C7}"/>
               </a:ext>
             </a:extLst>
           </p:cNvPr>
@@ -6066,7 +6066,7 @@
           <p:cNvPr id="47" name="">
             <a:extLst xmlns:a="http://schemas.openxmlformats.org/drawingml/2006/main">
               <a:ext uri="{FF2B5EF4-FFF2-40B4-BE49-F238E27FC236}">
-                <a16:creationId xmlns:a16="http://schemas.microsoft.com/office/drawing/2014/main" id="{31EF1B92-8F02-4703-B3BF-3AFAA00B0DEB}"/>
+                <a16:creationId xmlns:a16="http://schemas.microsoft.com/office/drawing/2014/main" id="{75870DB9-C351-4370-A374-1B2C8796C879}"/>
               </a:ext>
             </a:extLst>
           </p:cNvPr>
@@ -6128,7 +6128,7 @@
           <p:nvPr/>
         </p:nvPicPr>
         <p:blipFill>
-          <a:blip xmlns:r="http://schemas.openxmlformats.org/officeDocument/2006/relationships" xmlns:a="http://schemas.openxmlformats.org/drawingml/2006/main" r:embed="Rb8c9c9d76805474c"/>
+          <a:blip xmlns:r="http://schemas.openxmlformats.org/officeDocument/2006/relationships" xmlns:a="http://schemas.openxmlformats.org/drawingml/2006/main" r:embed="Rf88b60d6db4d4ee6"/>
           <a:stretch xmlns:a="http://schemas.openxmlformats.org/drawingml/2006/main"/>
         </p:blipFill>
         <p:spPr>
@@ -6146,7 +6146,7 @@
           <p:cNvPr id="49" name="">
             <a:extLst xmlns:a="http://schemas.openxmlformats.org/drawingml/2006/main">
               <a:ext uri="{FF2B5EF4-FFF2-40B4-BE49-F238E27FC236}">
-                <a16:creationId xmlns:a16="http://schemas.microsoft.com/office/drawing/2014/main" id="{BE3834B9-0CCF-4664-A255-201532513A0B}"/>
+                <a16:creationId xmlns:a16="http://schemas.microsoft.com/office/drawing/2014/main" id="{FC000621-1AB5-425C-AC36-97F6E2442646}"/>
               </a:ext>
             </a:extLst>
           </p:cNvPr>
@@ -6204,7 +6204,7 @@
           <p:cNvPr id="50" name="">
             <a:extLst xmlns:a="http://schemas.openxmlformats.org/drawingml/2006/main">
               <a:ext uri="{FF2B5EF4-FFF2-40B4-BE49-F238E27FC236}">
-                <a16:creationId xmlns:a16="http://schemas.microsoft.com/office/drawing/2014/main" id="{CB7F945C-4070-40B8-813C-2A9E91229175}"/>
+                <a16:creationId xmlns:a16="http://schemas.microsoft.com/office/drawing/2014/main" id="{0EFE54BD-1401-4DF8-957D-B6E4712B5E58}"/>
               </a:ext>
             </a:extLst>
           </p:cNvPr>
@@ -6262,7 +6262,7 @@
           <p:cNvPr id="51" name="slide-number-2">
             <a:extLst xmlns:a="http://schemas.openxmlformats.org/drawingml/2006/main">
               <a:ext uri="{FF2B5EF4-FFF2-40B4-BE49-F238E27FC236}">
-                <a16:creationId xmlns:a16="http://schemas.microsoft.com/office/drawing/2014/main" id="{FFA22432-6DEC-49B6-8E73-7629A7BD1277}"/>
+                <a16:creationId xmlns:a16="http://schemas.microsoft.com/office/drawing/2014/main" id="{FDA11671-9C8E-401D-86B9-37422B89668D}"/>
               </a:ext>
             </a:extLst>
           </p:cNvPr>
@@ -6318,7 +6318,7 @@
     </p:spTree>
     <p:extLst>
       <p:ext uri="{BB962C8B-B14F-4D97-AF65-F5344CB8AC3E}">
-        <p14:creationId xmlns:p14="http://schemas.microsoft.com/office/powerpoint/2010/main" val="669557018"/>
+        <p14:creationId xmlns:p14="http://schemas.microsoft.com/office/powerpoint/2010/main" val="29980604"/>
       </p:ext>
     </p:extLst>
   </p:cSld>
@@ -6349,7 +6349,7 @@
           <p:cNvPr id="15" name="title-T2">
             <a:extLst xmlns:a="http://schemas.openxmlformats.org/drawingml/2006/main">
               <a:ext uri="{FF2B5EF4-FFF2-40B4-BE49-F238E27FC236}">
-                <a16:creationId xmlns:a16="http://schemas.microsoft.com/office/drawing/2014/main" id="{8C0DF0C3-9B54-41C4-8151-E664591D4A44}"/>
+                <a16:creationId xmlns:a16="http://schemas.microsoft.com/office/drawing/2014/main" id="{1E6F3FFC-3BB1-4B19-9449-BB398594DCE5}"/>
               </a:ext>
             </a:extLst>
           </p:cNvPr>
@@ -6411,7 +6411,7 @@
           <p:cNvPr id="2" name="subtitle-T2">
             <a:extLst xmlns:a="http://schemas.openxmlformats.org/drawingml/2006/main">
               <a:ext uri="{FF2B5EF4-FFF2-40B4-BE49-F238E27FC236}">
-                <a16:creationId xmlns:a16="http://schemas.microsoft.com/office/drawing/2014/main" id="{376D9BD3-AF88-46A4-BCAA-0D31F7604161}"/>
+                <a16:creationId xmlns:a16="http://schemas.microsoft.com/office/drawing/2014/main" id="{D618E7E2-4E45-47EB-A3BA-00CD4F031D22}"/>
               </a:ext>
             </a:extLst>
           </p:cNvPr>
@@ -6469,7 +6469,7 @@
           <p:cNvPr id="3" name="">
             <a:extLst xmlns:a="http://schemas.openxmlformats.org/drawingml/2006/main">
               <a:ext uri="{FF2B5EF4-FFF2-40B4-BE49-F238E27FC236}">
-                <a16:creationId xmlns:a16="http://schemas.microsoft.com/office/drawing/2014/main" id="{EAE8FDDF-BC46-4115-A444-20DF56B56136}"/>
+                <a16:creationId xmlns:a16="http://schemas.microsoft.com/office/drawing/2014/main" id="{E226DA71-4C9F-4507-B05F-3E944E06466C}"/>
               </a:ext>
             </a:extLst>
           </p:cNvPr>
@@ -6504,7 +6504,7 @@
           <p:cNvPr id="4" name="">
             <a:extLst xmlns:a="http://schemas.openxmlformats.org/drawingml/2006/main">
               <a:ext uri="{FF2B5EF4-FFF2-40B4-BE49-F238E27FC236}">
-                <a16:creationId xmlns:a16="http://schemas.microsoft.com/office/drawing/2014/main" id="{63B566CE-03DD-464E-8BE7-9E60D4A4DB52}"/>
+                <a16:creationId xmlns:a16="http://schemas.microsoft.com/office/drawing/2014/main" id="{BAFBCF20-887B-40A8-8F6B-B1007CC937F7}"/>
               </a:ext>
             </a:extLst>
           </p:cNvPr>
@@ -6562,7 +6562,7 @@
           <p:cNvPr id="5" name="">
             <a:extLst xmlns:a="http://schemas.openxmlformats.org/drawingml/2006/main">
               <a:ext uri="{FF2B5EF4-FFF2-40B4-BE49-F238E27FC236}">
-                <a16:creationId xmlns:a16="http://schemas.microsoft.com/office/drawing/2014/main" id="{BCBD4FF3-2C57-4454-A2EF-8AD27A88E185}"/>
+                <a16:creationId xmlns:a16="http://schemas.microsoft.com/office/drawing/2014/main" id="{1A9D741B-6682-4D1A-9C65-97B29A1BFECB}"/>
               </a:ext>
             </a:extLst>
           </p:cNvPr>
@@ -6624,7 +6624,7 @@
           <p:nvPr/>
         </p:nvPicPr>
         <p:blipFill>
-          <a:blip xmlns:r="http://schemas.openxmlformats.org/officeDocument/2006/relationships" xmlns:a="http://schemas.openxmlformats.org/drawingml/2006/main" r:embed="R6af40ee71bcc40bd"/>
+          <a:blip xmlns:r="http://schemas.openxmlformats.org/officeDocument/2006/relationships" xmlns:a="http://schemas.openxmlformats.org/drawingml/2006/main" r:embed="Rb97d6dd8ede44d98"/>
           <a:stretch xmlns:a="http://schemas.openxmlformats.org/drawingml/2006/main"/>
         </p:blipFill>
         <p:spPr>
@@ -6642,7 +6642,7 @@
           <p:cNvPr id="7" name="">
             <a:extLst xmlns:a="http://schemas.openxmlformats.org/drawingml/2006/main">
               <a:ext uri="{FF2B5EF4-FFF2-40B4-BE49-F238E27FC236}">
-                <a16:creationId xmlns:a16="http://schemas.microsoft.com/office/drawing/2014/main" id="{4689109E-AB98-4BFC-8C18-9E9A92C35CA3}"/>
+                <a16:creationId xmlns:a16="http://schemas.microsoft.com/office/drawing/2014/main" id="{6932A8CB-472F-4A14-B2FE-5AA7D801C5F7}"/>
               </a:ext>
             </a:extLst>
           </p:cNvPr>
@@ -6700,7 +6700,7 @@
           <p:cNvPr id="8" name="">
             <a:extLst xmlns:a="http://schemas.openxmlformats.org/drawingml/2006/main">
               <a:ext uri="{FF2B5EF4-FFF2-40B4-BE49-F238E27FC236}">
-                <a16:creationId xmlns:a16="http://schemas.microsoft.com/office/drawing/2014/main" id="{A4642906-20AC-437E-8086-EB5802B395E7}"/>
+                <a16:creationId xmlns:a16="http://schemas.microsoft.com/office/drawing/2014/main" id="{30213A9F-7EB6-419D-9E39-74F11AE7A465}"/>
               </a:ext>
             </a:extLst>
           </p:cNvPr>
@@ -6758,7 +6758,7 @@
           <p:cNvPr id="9" name="">
             <a:extLst xmlns:a="http://schemas.openxmlformats.org/drawingml/2006/main">
               <a:ext uri="{FF2B5EF4-FFF2-40B4-BE49-F238E27FC236}">
-                <a16:creationId xmlns:a16="http://schemas.microsoft.com/office/drawing/2014/main" id="{58BD4D0F-E1F9-4868-AA46-66D2A7FF9989}"/>
+                <a16:creationId xmlns:a16="http://schemas.microsoft.com/office/drawing/2014/main" id="{952F3D1B-4077-4B31-907A-893122498287}"/>
               </a:ext>
             </a:extLst>
           </p:cNvPr>
@@ -6820,7 +6820,7 @@
           <p:nvPr/>
         </p:nvPicPr>
         <p:blipFill>
-          <a:blip xmlns:r="http://schemas.openxmlformats.org/officeDocument/2006/relationships" xmlns:a="http://schemas.openxmlformats.org/drawingml/2006/main" r:embed="R362a4f14649f447e"/>
+          <a:blip xmlns:r="http://schemas.openxmlformats.org/officeDocument/2006/relationships" xmlns:a="http://schemas.openxmlformats.org/drawingml/2006/main" r:embed="Rbb3a12eb46db4136"/>
           <a:stretch xmlns:a="http://schemas.openxmlformats.org/drawingml/2006/main"/>
         </p:blipFill>
         <p:spPr>
@@ -6838,7 +6838,7 @@
           <p:cNvPr id="11" name="">
             <a:extLst xmlns:a="http://schemas.openxmlformats.org/drawingml/2006/main">
               <a:ext uri="{FF2B5EF4-FFF2-40B4-BE49-F238E27FC236}">
-                <a16:creationId xmlns:a16="http://schemas.microsoft.com/office/drawing/2014/main" id="{1291E696-C2BD-4991-BEB5-E5A1BF157445}"/>
+                <a16:creationId xmlns:a16="http://schemas.microsoft.com/office/drawing/2014/main" id="{58027D01-CA9F-4284-B7E3-8817D59E85C0}"/>
               </a:ext>
             </a:extLst>
           </p:cNvPr>
@@ -6904,7 +6904,7 @@
           <p:nvPr/>
         </p:nvPicPr>
         <p:blipFill>
-          <a:blip xmlns:r="http://schemas.openxmlformats.org/officeDocument/2006/relationships" xmlns:a="http://schemas.openxmlformats.org/drawingml/2006/main" r:embed="R9a93962bbe2d423e"/>
+          <a:blip xmlns:r="http://schemas.openxmlformats.org/officeDocument/2006/relationships" xmlns:a="http://schemas.openxmlformats.org/drawingml/2006/main" r:embed="Rf80205d1853148d7"/>
           <a:stretch xmlns:a="http://schemas.openxmlformats.org/drawingml/2006/main"/>
         </p:blipFill>
         <p:spPr>
@@ -6922,7 +6922,7 @@
           <p:cNvPr id="13" name="">
             <a:extLst xmlns:a="http://schemas.openxmlformats.org/drawingml/2006/main">
               <a:ext uri="{FF2B5EF4-FFF2-40B4-BE49-F238E27FC236}">
-                <a16:creationId xmlns:a16="http://schemas.microsoft.com/office/drawing/2014/main" id="{39423741-4562-4401-9F1E-FBEDCC859711}"/>
+                <a16:creationId xmlns:a16="http://schemas.microsoft.com/office/drawing/2014/main" id="{CC0CDB1B-B810-47A9-83D9-0CC0D73E4BAD}"/>
               </a:ext>
             </a:extLst>
           </p:cNvPr>
@@ -6980,7 +6980,7 @@
           <p:cNvPr id="14" name="slide-number-3">
             <a:extLst xmlns:a="http://schemas.openxmlformats.org/drawingml/2006/main">
               <a:ext uri="{FF2B5EF4-FFF2-40B4-BE49-F238E27FC236}">
-                <a16:creationId xmlns:a16="http://schemas.microsoft.com/office/drawing/2014/main" id="{735A5AC4-4ACB-4FD8-8E83-890307F832DC}"/>
+                <a16:creationId xmlns:a16="http://schemas.microsoft.com/office/drawing/2014/main" id="{1A75AF0E-228A-4296-8AAD-BC2C4DEF42A1}"/>
               </a:ext>
             </a:extLst>
           </p:cNvPr>
@@ -7036,7 +7036,7 @@
     </p:spTree>
     <p:extLst>
       <p:ext uri="{BB962C8B-B14F-4D97-AF65-F5344CB8AC3E}">
-        <p14:creationId xmlns:p14="http://schemas.microsoft.com/office/powerpoint/2010/main" val="791925073"/>
+        <p14:creationId xmlns:p14="http://schemas.microsoft.com/office/powerpoint/2010/main" val="1577626368"/>
       </p:ext>
     </p:extLst>
   </p:cSld>
@@ -7067,7 +7067,7 @@
           <p:cNvPr id="18" name="title-T3">
             <a:extLst xmlns:a="http://schemas.openxmlformats.org/drawingml/2006/main">
               <a:ext uri="{FF2B5EF4-FFF2-40B4-BE49-F238E27FC236}">
-                <a16:creationId xmlns:a16="http://schemas.microsoft.com/office/drawing/2014/main" id="{FCFE3C73-35F2-436E-B6BD-EE8BEF47E966}"/>
+                <a16:creationId xmlns:a16="http://schemas.microsoft.com/office/drawing/2014/main" id="{626D4692-587E-46D7-A738-BAC0EDDA2871}"/>
               </a:ext>
             </a:extLst>
           </p:cNvPr>
@@ -7156,7 +7156,7 @@
           <p:cNvPr id="2" name="subtitle-T3">
             <a:extLst xmlns:a="http://schemas.openxmlformats.org/drawingml/2006/main">
               <a:ext uri="{FF2B5EF4-FFF2-40B4-BE49-F238E27FC236}">
-                <a16:creationId xmlns:a16="http://schemas.microsoft.com/office/drawing/2014/main" id="{F4BA773C-B81F-4215-B888-0799880B39E2}"/>
+                <a16:creationId xmlns:a16="http://schemas.microsoft.com/office/drawing/2014/main" id="{A4C51AAB-71DD-4F63-9231-D4CF084591B1}"/>
               </a:ext>
             </a:extLst>
           </p:cNvPr>
@@ -7214,7 +7214,7 @@
           <p:cNvPr id="3" name="">
             <a:extLst xmlns:a="http://schemas.openxmlformats.org/drawingml/2006/main">
               <a:ext uri="{FF2B5EF4-FFF2-40B4-BE49-F238E27FC236}">
-                <a16:creationId xmlns:a16="http://schemas.microsoft.com/office/drawing/2014/main" id="{CA170234-2869-49D8-B224-E3C6F150DB85}"/>
+                <a16:creationId xmlns:a16="http://schemas.microsoft.com/office/drawing/2014/main" id="{C3130175-720F-4FF7-A398-582A1545FC62}"/>
               </a:ext>
             </a:extLst>
           </p:cNvPr>
@@ -7276,7 +7276,7 @@
           <p:nvPr/>
         </p:nvPicPr>
         <p:blipFill>
-          <a:blip xmlns:r="http://schemas.openxmlformats.org/officeDocument/2006/relationships" xmlns:a="http://schemas.openxmlformats.org/drawingml/2006/main" r:embed="Ra0b9cd33cdc34c7a"/>
+          <a:blip xmlns:r="http://schemas.openxmlformats.org/officeDocument/2006/relationships" xmlns:a="http://schemas.openxmlformats.org/drawingml/2006/main" r:embed="R979dc0ad5dd44d42"/>
           <a:stretch xmlns:a="http://schemas.openxmlformats.org/drawingml/2006/main"/>
         </p:blipFill>
         <p:spPr>
@@ -7294,7 +7294,7 @@
           <p:cNvPr id="5" name="">
             <a:extLst xmlns:a="http://schemas.openxmlformats.org/drawingml/2006/main">
               <a:ext uri="{FF2B5EF4-FFF2-40B4-BE49-F238E27FC236}">
-                <a16:creationId xmlns:a16="http://schemas.microsoft.com/office/drawing/2014/main" id="{6BC41C1B-E1EE-4EEB-B45F-37612E07E382}"/>
+                <a16:creationId xmlns:a16="http://schemas.microsoft.com/office/drawing/2014/main" id="{98A320FE-3EE3-41BC-BE8F-3900D85ED1CE}"/>
               </a:ext>
             </a:extLst>
           </p:cNvPr>
@@ -7329,7 +7329,7 @@
           <p:cNvPr id="6" name="">
             <a:extLst xmlns:a="http://schemas.openxmlformats.org/drawingml/2006/main">
               <a:ext uri="{FF2B5EF4-FFF2-40B4-BE49-F238E27FC236}">
-                <a16:creationId xmlns:a16="http://schemas.microsoft.com/office/drawing/2014/main" id="{BAD96FB0-92B1-45AB-AECE-82FB01ABCF9F}"/>
+                <a16:creationId xmlns:a16="http://schemas.microsoft.com/office/drawing/2014/main" id="{BB2EDE8E-1500-49D3-82EC-6D4835F80EC4}"/>
               </a:ext>
             </a:extLst>
           </p:cNvPr>
@@ -7391,7 +7391,7 @@
           <p:nvPr/>
         </p:nvPicPr>
         <p:blipFill>
-          <a:blip xmlns:r="http://schemas.openxmlformats.org/officeDocument/2006/relationships" xmlns:a="http://schemas.openxmlformats.org/drawingml/2006/main" r:embed="R3815dabd60034339"/>
+          <a:blip xmlns:r="http://schemas.openxmlformats.org/officeDocument/2006/relationships" xmlns:a="http://schemas.openxmlformats.org/drawingml/2006/main" r:embed="Raf3313667eb644e0"/>
           <a:stretch xmlns:a="http://schemas.openxmlformats.org/drawingml/2006/main"/>
         </p:blipFill>
         <p:spPr>
@@ -7409,7 +7409,7 @@
           <p:cNvPr id="8" name="">
             <a:extLst xmlns:a="http://schemas.openxmlformats.org/drawingml/2006/main">
               <a:ext uri="{FF2B5EF4-FFF2-40B4-BE49-F238E27FC236}">
-                <a16:creationId xmlns:a16="http://schemas.microsoft.com/office/drawing/2014/main" id="{2731F051-7416-4B0E-B3AA-C1DDA325EB5F}"/>
+                <a16:creationId xmlns:a16="http://schemas.microsoft.com/office/drawing/2014/main" id="{5DBD01C5-3553-4AA7-BFA4-04C5B3F7CA08}"/>
               </a:ext>
             </a:extLst>
           </p:cNvPr>
@@ -7471,7 +7471,7 @@
           <p:nvPr/>
         </p:nvPicPr>
         <p:blipFill>
-          <a:blip xmlns:r="http://schemas.openxmlformats.org/officeDocument/2006/relationships" xmlns:a="http://schemas.openxmlformats.org/drawingml/2006/main" r:embed="R1095a38d54444802"/>
+          <a:blip xmlns:r="http://schemas.openxmlformats.org/officeDocument/2006/relationships" xmlns:a="http://schemas.openxmlformats.org/drawingml/2006/main" r:embed="Ra957333ef93848b8"/>
           <a:stretch xmlns:a="http://schemas.openxmlformats.org/drawingml/2006/main"/>
         </p:blipFill>
         <p:spPr>
@@ -7489,7 +7489,7 @@
           <p:cNvPr id="10" name="">
             <a:extLst xmlns:a="http://schemas.openxmlformats.org/drawingml/2006/main">
               <a:ext uri="{FF2B5EF4-FFF2-40B4-BE49-F238E27FC236}">
-                <a16:creationId xmlns:a16="http://schemas.microsoft.com/office/drawing/2014/main" id="{A7C29626-82D6-4DF3-9195-40D0CD0C79E8}"/>
+                <a16:creationId xmlns:a16="http://schemas.microsoft.com/office/drawing/2014/main" id="{87FF1276-2AC0-473F-BC87-6A187431117B}"/>
               </a:ext>
             </a:extLst>
           </p:cNvPr>
@@ -7547,7 +7547,7 @@
           <p:cNvPr id="11" name="">
             <a:extLst xmlns:a="http://schemas.openxmlformats.org/drawingml/2006/main">
               <a:ext uri="{FF2B5EF4-FFF2-40B4-BE49-F238E27FC236}">
-                <a16:creationId xmlns:a16="http://schemas.microsoft.com/office/drawing/2014/main" id="{1853E5D5-5DFF-447D-BDF1-7DFF456B1FA6}"/>
+                <a16:creationId xmlns:a16="http://schemas.microsoft.com/office/drawing/2014/main" id="{7313BDEA-EBFB-464C-8332-38DE80210B0E}"/>
               </a:ext>
             </a:extLst>
           </p:cNvPr>
@@ -7586,7 +7586,7 @@
           <p:nvPr/>
         </p:nvPicPr>
         <p:blipFill>
-          <a:blip xmlns:r="http://schemas.openxmlformats.org/officeDocument/2006/relationships" xmlns:a="http://schemas.openxmlformats.org/drawingml/2006/main" r:embed="Rdd92143cdcec4265"/>
+          <a:blip xmlns:r="http://schemas.openxmlformats.org/officeDocument/2006/relationships" xmlns:a="http://schemas.openxmlformats.org/drawingml/2006/main" r:embed="Rd394fe7687784313"/>
           <a:stretch xmlns:a="http://schemas.openxmlformats.org/drawingml/2006/main"/>
         </p:blipFill>
         <p:spPr>
@@ -7604,7 +7604,7 @@
           <p:cNvPr id="13" name="">
             <a:extLst xmlns:a="http://schemas.openxmlformats.org/drawingml/2006/main">
               <a:ext uri="{FF2B5EF4-FFF2-40B4-BE49-F238E27FC236}">
-                <a16:creationId xmlns:a16="http://schemas.microsoft.com/office/drawing/2014/main" id="{FF734DBA-32E9-4A22-BAFF-C9795AD27957}"/>
+                <a16:creationId xmlns:a16="http://schemas.microsoft.com/office/drawing/2014/main" id="{2736D82C-D7AA-4BF4-BE29-A822F3C92780}"/>
               </a:ext>
             </a:extLst>
           </p:cNvPr>
@@ -7662,7 +7662,7 @@
           <p:cNvPr id="14" name="">
             <a:extLst xmlns:a="http://schemas.openxmlformats.org/drawingml/2006/main">
               <a:ext uri="{FF2B5EF4-FFF2-40B4-BE49-F238E27FC236}">
-                <a16:creationId xmlns:a16="http://schemas.microsoft.com/office/drawing/2014/main" id="{0B7074BF-B18C-46CC-9362-9B80E777AAA0}"/>
+                <a16:creationId xmlns:a16="http://schemas.microsoft.com/office/drawing/2014/main" id="{DA17DB9A-D8DF-4FAE-9B5E-DA2BBD4F5E98}"/>
               </a:ext>
             </a:extLst>
           </p:cNvPr>
@@ -7720,7 +7720,7 @@
           <p:cNvPr id="15" name="">
             <a:extLst xmlns:a="http://schemas.openxmlformats.org/drawingml/2006/main">
               <a:ext uri="{FF2B5EF4-FFF2-40B4-BE49-F238E27FC236}">
-                <a16:creationId xmlns:a16="http://schemas.microsoft.com/office/drawing/2014/main" id="{7467A044-C5E6-469E-9F83-E64B0E8FA1B4}"/>
+                <a16:creationId xmlns:a16="http://schemas.microsoft.com/office/drawing/2014/main" id="{6824BDFF-55E8-4D38-AACA-3AB23AE75674}"/>
               </a:ext>
             </a:extLst>
           </p:cNvPr>
@@ -7755,7 +7755,7 @@
           <p:cNvPr id="16" name="">
             <a:extLst xmlns:a="http://schemas.openxmlformats.org/drawingml/2006/main">
               <a:ext uri="{FF2B5EF4-FFF2-40B4-BE49-F238E27FC236}">
-                <a16:creationId xmlns:a16="http://schemas.microsoft.com/office/drawing/2014/main" id="{AB8396BC-94B5-4606-A6F5-1B1911AF5B50}"/>
+                <a16:creationId xmlns:a16="http://schemas.microsoft.com/office/drawing/2014/main" id="{77245717-616D-496D-A4AD-FA2003758250}"/>
               </a:ext>
             </a:extLst>
           </p:cNvPr>
@@ -7813,7 +7813,7 @@
           <p:cNvPr id="17" name="slide-number-4">
             <a:extLst xmlns:a="http://schemas.openxmlformats.org/drawingml/2006/main">
               <a:ext uri="{FF2B5EF4-FFF2-40B4-BE49-F238E27FC236}">
-                <a16:creationId xmlns:a16="http://schemas.microsoft.com/office/drawing/2014/main" id="{7729497F-F63C-4330-B20E-36C5EEADC46B}"/>
+                <a16:creationId xmlns:a16="http://schemas.microsoft.com/office/drawing/2014/main" id="{3A132826-6039-42C7-B945-7CACC58FFF6A}"/>
               </a:ext>
             </a:extLst>
           </p:cNvPr>
@@ -7869,7 +7869,7 @@
     </p:spTree>
     <p:extLst>
       <p:ext uri="{BB962C8B-B14F-4D97-AF65-F5344CB8AC3E}">
-        <p14:creationId xmlns:p14="http://schemas.microsoft.com/office/powerpoint/2010/main" val="98733338"/>
+        <p14:creationId xmlns:p14="http://schemas.microsoft.com/office/powerpoint/2010/main" val="1134815800"/>
       </p:ext>
     </p:extLst>
   </p:cSld>
@@ -7900,7 +7900,7 @@
           <p:cNvPr id="29" name="title-T1">
             <a:extLst xmlns:a="http://schemas.openxmlformats.org/drawingml/2006/main">
               <a:ext uri="{FF2B5EF4-FFF2-40B4-BE49-F238E27FC236}">
-                <a16:creationId xmlns:a16="http://schemas.microsoft.com/office/drawing/2014/main" id="{913D7782-85D1-41B0-890F-F17436CB90BD}"/>
+                <a16:creationId xmlns:a16="http://schemas.microsoft.com/office/drawing/2014/main" id="{E98F86A9-39B1-4A12-8F30-E3A13AB922BD}"/>
               </a:ext>
             </a:extLst>
           </p:cNvPr>
@@ -7962,7 +7962,7 @@
           <p:cNvPr id="2" name="subtitle-T1">
             <a:extLst xmlns:a="http://schemas.openxmlformats.org/drawingml/2006/main">
               <a:ext uri="{FF2B5EF4-FFF2-40B4-BE49-F238E27FC236}">
-                <a16:creationId xmlns:a16="http://schemas.microsoft.com/office/drawing/2014/main" id="{BC451CB8-7EC5-4311-A1F3-5E262B6AD14D}"/>
+                <a16:creationId xmlns:a16="http://schemas.microsoft.com/office/drawing/2014/main" id="{D5E1EF17-B814-4278-946E-16EDB75DC879}"/>
               </a:ext>
             </a:extLst>
           </p:cNvPr>
@@ -8020,7 +8020,7 @@
           <p:cNvPr id="3" name="">
             <a:extLst xmlns:a="http://schemas.openxmlformats.org/drawingml/2006/main">
               <a:ext uri="{FF2B5EF4-FFF2-40B4-BE49-F238E27FC236}">
-                <a16:creationId xmlns:a16="http://schemas.microsoft.com/office/drawing/2014/main" id="{86AAD2C8-898E-4F52-811C-CCA47FE4C09B}"/>
+                <a16:creationId xmlns:a16="http://schemas.microsoft.com/office/drawing/2014/main" id="{9FF1ADA1-C5A2-4D7A-93DB-EC1ECA81A043}"/>
               </a:ext>
             </a:extLst>
           </p:cNvPr>
@@ -8078,7 +8078,7 @@
           <p:cNvPr id="4" name="">
             <a:extLst xmlns:a="http://schemas.openxmlformats.org/drawingml/2006/main">
               <a:ext uri="{FF2B5EF4-FFF2-40B4-BE49-F238E27FC236}">
-                <a16:creationId xmlns:a16="http://schemas.microsoft.com/office/drawing/2014/main" id="{DC872571-EF06-4CA7-8E5C-1C0020BE0829}"/>
+                <a16:creationId xmlns:a16="http://schemas.microsoft.com/office/drawing/2014/main" id="{2F58989B-D2B4-4CA8-913A-18153574E47F}"/>
               </a:ext>
             </a:extLst>
           </p:cNvPr>
@@ -8136,7 +8136,7 @@
           <p:cNvPr id="5" name="">
             <a:extLst xmlns:a="http://schemas.openxmlformats.org/drawingml/2006/main">
               <a:ext uri="{FF2B5EF4-FFF2-40B4-BE49-F238E27FC236}">
-                <a16:creationId xmlns:a16="http://schemas.microsoft.com/office/drawing/2014/main" id="{A6E60D49-B926-4BBE-8D4E-5A33649A65C7}"/>
+                <a16:creationId xmlns:a16="http://schemas.microsoft.com/office/drawing/2014/main" id="{4A089432-8E1A-4597-AB07-CD64382AFBC6}"/>
               </a:ext>
             </a:extLst>
           </p:cNvPr>
@@ -8194,7 +8194,7 @@
           <p:cNvPr id="6" name="">
             <a:extLst xmlns:a="http://schemas.openxmlformats.org/drawingml/2006/main">
               <a:ext uri="{FF2B5EF4-FFF2-40B4-BE49-F238E27FC236}">
-                <a16:creationId xmlns:a16="http://schemas.microsoft.com/office/drawing/2014/main" id="{DCE9D3B5-04CD-493D-84C2-BD62E0933590}"/>
+                <a16:creationId xmlns:a16="http://schemas.microsoft.com/office/drawing/2014/main" id="{7ACC3D8A-6BE7-48E9-BE52-7A25E462FB40}"/>
               </a:ext>
             </a:extLst>
           </p:cNvPr>
@@ -8252,7 +8252,7 @@
           <p:cNvPr id="7" name="">
             <a:extLst xmlns:a="http://schemas.openxmlformats.org/drawingml/2006/main">
               <a:ext uri="{FF2B5EF4-FFF2-40B4-BE49-F238E27FC236}">
-                <a16:creationId xmlns:a16="http://schemas.microsoft.com/office/drawing/2014/main" id="{DE9C3ACD-C00D-47BF-B8A1-515566988201}"/>
+                <a16:creationId xmlns:a16="http://schemas.microsoft.com/office/drawing/2014/main" id="{BEFFCC6C-AEC8-4D19-9E86-79DF8BA5344F}"/>
               </a:ext>
             </a:extLst>
           </p:cNvPr>
@@ -8291,7 +8291,7 @@
           <p:nvPr/>
         </p:nvPicPr>
         <p:blipFill>
-          <a:blip xmlns:r="http://schemas.openxmlformats.org/officeDocument/2006/relationships" xmlns:a="http://schemas.openxmlformats.org/drawingml/2006/main" r:embed="R4a089d3079af4728"/>
+          <a:blip xmlns:r="http://schemas.openxmlformats.org/officeDocument/2006/relationships" xmlns:a="http://schemas.openxmlformats.org/drawingml/2006/main" r:embed="Rb810344c4e7e4a44"/>
           <a:stretch xmlns:a="http://schemas.openxmlformats.org/drawingml/2006/main"/>
         </p:blipFill>
         <p:spPr>
@@ -8309,7 +8309,7 @@
           <p:cNvPr id="9" name="">
             <a:extLst xmlns:a="http://schemas.openxmlformats.org/drawingml/2006/main">
               <a:ext uri="{FF2B5EF4-FFF2-40B4-BE49-F238E27FC236}">
-                <a16:creationId xmlns:a16="http://schemas.microsoft.com/office/drawing/2014/main" id="{5BD75179-89F5-4219-BAED-70385CF57C05}"/>
+                <a16:creationId xmlns:a16="http://schemas.microsoft.com/office/drawing/2014/main" id="{4BC52D3A-666E-458E-9F0F-7D03B513675E}"/>
               </a:ext>
             </a:extLst>
           </p:cNvPr>
@@ -8367,7 +8367,7 @@
           <p:cNvPr id="10" name="">
             <a:extLst xmlns:a="http://schemas.openxmlformats.org/drawingml/2006/main">
               <a:ext uri="{FF2B5EF4-FFF2-40B4-BE49-F238E27FC236}">
-                <a16:creationId xmlns:a16="http://schemas.microsoft.com/office/drawing/2014/main" id="{AFF9D611-7406-4F8E-A18B-C7499766FC98}"/>
+                <a16:creationId xmlns:a16="http://schemas.microsoft.com/office/drawing/2014/main" id="{3E8CB5A2-C43D-481A-BBB4-73F1E69FECB5}"/>
               </a:ext>
             </a:extLst>
           </p:cNvPr>
@@ -8429,7 +8429,7 @@
           <p:nvPr/>
         </p:nvPicPr>
         <p:blipFill>
-          <a:blip xmlns:r="http://schemas.openxmlformats.org/officeDocument/2006/relationships" xmlns:a="http://schemas.openxmlformats.org/drawingml/2006/main" r:embed="Reeea93ebdeab4e2e"/>
+          <a:blip xmlns:r="http://schemas.openxmlformats.org/officeDocument/2006/relationships" xmlns:a="http://schemas.openxmlformats.org/drawingml/2006/main" r:embed="R7876a0152fe948bc"/>
           <a:stretch xmlns:a="http://schemas.openxmlformats.org/drawingml/2006/main"/>
         </p:blipFill>
         <p:spPr>
@@ -8447,7 +8447,7 @@
           <p:cNvPr id="12" name="">
             <a:extLst xmlns:a="http://schemas.openxmlformats.org/drawingml/2006/main">
               <a:ext uri="{FF2B5EF4-FFF2-40B4-BE49-F238E27FC236}">
-                <a16:creationId xmlns:a16="http://schemas.microsoft.com/office/drawing/2014/main" id="{3A3EB549-FEDF-4DB8-8592-7B50D0CA45BE}"/>
+                <a16:creationId xmlns:a16="http://schemas.microsoft.com/office/drawing/2014/main" id="{3B6E0CE9-699F-40E3-8263-0488948893B0}"/>
               </a:ext>
             </a:extLst>
           </p:cNvPr>
@@ -8486,7 +8486,7 @@
           <p:nvPr/>
         </p:nvPicPr>
         <p:blipFill>
-          <a:blip xmlns:r="http://schemas.openxmlformats.org/officeDocument/2006/relationships" xmlns:a="http://schemas.openxmlformats.org/drawingml/2006/main" r:embed="Rbc0a5ba3f8f2426a"/>
+          <a:blip xmlns:r="http://schemas.openxmlformats.org/officeDocument/2006/relationships" xmlns:a="http://schemas.openxmlformats.org/drawingml/2006/main" r:embed="R109c588d334045ee"/>
           <a:stretch xmlns:a="http://schemas.openxmlformats.org/drawingml/2006/main"/>
         </p:blipFill>
         <p:spPr>
@@ -8504,7 +8504,7 @@
           <p:cNvPr id="14" name="">
             <a:extLst xmlns:a="http://schemas.openxmlformats.org/drawingml/2006/main">
               <a:ext uri="{FF2B5EF4-FFF2-40B4-BE49-F238E27FC236}">
-                <a16:creationId xmlns:a16="http://schemas.microsoft.com/office/drawing/2014/main" id="{C5FD0152-9C9E-473C-BD2B-8166D48DE53C}"/>
+                <a16:creationId xmlns:a16="http://schemas.microsoft.com/office/drawing/2014/main" id="{53578822-E5DA-4D5C-A8E1-2BDC7E3CF0C6}"/>
               </a:ext>
             </a:extLst>
           </p:cNvPr>
@@ -8562,7 +8562,7 @@
           <p:cNvPr id="15" name="">
             <a:extLst xmlns:a="http://schemas.openxmlformats.org/drawingml/2006/main">
               <a:ext uri="{FF2B5EF4-FFF2-40B4-BE49-F238E27FC236}">
-                <a16:creationId xmlns:a16="http://schemas.microsoft.com/office/drawing/2014/main" id="{E1DE1191-71A6-48FE-A742-2815444F199E}"/>
+                <a16:creationId xmlns:a16="http://schemas.microsoft.com/office/drawing/2014/main" id="{C0D38C02-072A-426F-BE97-E61F2C0AFBAD}"/>
               </a:ext>
             </a:extLst>
           </p:cNvPr>
@@ -8624,7 +8624,7 @@
           <p:nvPr/>
         </p:nvPicPr>
         <p:blipFill>
-          <a:blip xmlns:r="http://schemas.openxmlformats.org/officeDocument/2006/relationships" xmlns:a="http://schemas.openxmlformats.org/drawingml/2006/main" r:embed="Rb9527e82e0c54237"/>
+          <a:blip xmlns:r="http://schemas.openxmlformats.org/officeDocument/2006/relationships" xmlns:a="http://schemas.openxmlformats.org/drawingml/2006/main" r:embed="Rf2fe4153ccd9425a"/>
           <a:stretch xmlns:a="http://schemas.openxmlformats.org/drawingml/2006/main"/>
         </p:blipFill>
         <p:spPr>
@@ -8642,7 +8642,7 @@
           <p:cNvPr id="17" name="">
             <a:extLst xmlns:a="http://schemas.openxmlformats.org/drawingml/2006/main">
               <a:ext uri="{FF2B5EF4-FFF2-40B4-BE49-F238E27FC236}">
-                <a16:creationId xmlns:a16="http://schemas.microsoft.com/office/drawing/2014/main" id="{E8390E2C-FBDB-4521-BEA4-D4B0523F8036}"/>
+                <a16:creationId xmlns:a16="http://schemas.microsoft.com/office/drawing/2014/main" id="{066EE614-E43A-4598-AA21-BEB33E32F3CC}"/>
               </a:ext>
             </a:extLst>
           </p:cNvPr>
@@ -8681,7 +8681,7 @@
           <p:nvPr/>
         </p:nvPicPr>
         <p:blipFill>
-          <a:blip xmlns:r="http://schemas.openxmlformats.org/officeDocument/2006/relationships" xmlns:a="http://schemas.openxmlformats.org/drawingml/2006/main" r:embed="R0de8e97d79b5404d"/>
+          <a:blip xmlns:r="http://schemas.openxmlformats.org/officeDocument/2006/relationships" xmlns:a="http://schemas.openxmlformats.org/drawingml/2006/main" r:embed="Ra6df39aad3fe474e"/>
           <a:stretch xmlns:a="http://schemas.openxmlformats.org/drawingml/2006/main"/>
         </p:blipFill>
         <p:spPr>
@@ -8699,7 +8699,7 @@
           <p:cNvPr id="19" name="">
             <a:extLst xmlns:a="http://schemas.openxmlformats.org/drawingml/2006/main">
               <a:ext uri="{FF2B5EF4-FFF2-40B4-BE49-F238E27FC236}">
-                <a16:creationId xmlns:a16="http://schemas.microsoft.com/office/drawing/2014/main" id="{04520658-6CAB-42D4-9757-E0A65EA82C32}"/>
+                <a16:creationId xmlns:a16="http://schemas.microsoft.com/office/drawing/2014/main" id="{7CDAA79B-C3B5-4ABA-B41B-06DFBCFCCF92}"/>
               </a:ext>
             </a:extLst>
           </p:cNvPr>
@@ -8757,7 +8757,7 @@
           <p:cNvPr id="20" name="">
             <a:extLst xmlns:a="http://schemas.openxmlformats.org/drawingml/2006/main">
               <a:ext uri="{FF2B5EF4-FFF2-40B4-BE49-F238E27FC236}">
-                <a16:creationId xmlns:a16="http://schemas.microsoft.com/office/drawing/2014/main" id="{B874F767-89A2-4EAA-B3B1-ED3E42B0D5B8}"/>
+                <a16:creationId xmlns:a16="http://schemas.microsoft.com/office/drawing/2014/main" id="{8CB4A4A7-CEDD-4D65-86DC-A4158D7C9BD5}"/>
               </a:ext>
             </a:extLst>
           </p:cNvPr>
@@ -8819,7 +8819,7 @@
           <p:nvPr/>
         </p:nvPicPr>
         <p:blipFill>
-          <a:blip xmlns:r="http://schemas.openxmlformats.org/officeDocument/2006/relationships" xmlns:a="http://schemas.openxmlformats.org/drawingml/2006/main" r:embed="Re1edf14c4dd04148"/>
+          <a:blip xmlns:r="http://schemas.openxmlformats.org/officeDocument/2006/relationships" xmlns:a="http://schemas.openxmlformats.org/drawingml/2006/main" r:embed="Read0ee643d754d4b"/>
           <a:stretch xmlns:a="http://schemas.openxmlformats.org/drawingml/2006/main"/>
         </p:blipFill>
         <p:spPr>
@@ -8837,7 +8837,7 @@
           <p:cNvPr id="22" name="">
             <a:extLst xmlns:a="http://schemas.openxmlformats.org/drawingml/2006/main">
               <a:ext uri="{FF2B5EF4-FFF2-40B4-BE49-F238E27FC236}">
-                <a16:creationId xmlns:a16="http://schemas.microsoft.com/office/drawing/2014/main" id="{5F15AA46-B5E1-47AE-9221-150F67018556}"/>
+                <a16:creationId xmlns:a16="http://schemas.microsoft.com/office/drawing/2014/main" id="{06BC684C-1C8F-41B8-B2B2-A913ED36B8F6}"/>
               </a:ext>
             </a:extLst>
           </p:cNvPr>
@@ -8857,11 +8857,11 @@
             </a:avLst>
           </a:prstGeom>
           <a:solidFill xmlns:a="http://schemas.openxmlformats.org/drawingml/2006/main">
-            <a:srgbClr val="FFF7E6"/>
+            <a:srgbClr val="F5F1FB"/>
           </a:solidFill>
           <a:ln xmlns:a="http://schemas.openxmlformats.org/drawingml/2006/main" w="19050">
             <a:solidFill>
-              <a:srgbClr val="C98A16"/>
+              <a:srgbClr val="6F4B9B"/>
             </a:solidFill>
             <a:prstDash val="solid"/>
           </a:ln>
@@ -8876,7 +8876,7 @@
           <p:nvPr/>
         </p:nvPicPr>
         <p:blipFill>
-          <a:blip xmlns:r="http://schemas.openxmlformats.org/officeDocument/2006/relationships" xmlns:a="http://schemas.openxmlformats.org/drawingml/2006/main" r:embed="R6faba367bcc44f26"/>
+          <a:blip xmlns:r="http://schemas.openxmlformats.org/officeDocument/2006/relationships" xmlns:a="http://schemas.openxmlformats.org/drawingml/2006/main" r:embed="Rc1b7cd9c1ba64243"/>
           <a:stretch xmlns:a="http://schemas.openxmlformats.org/drawingml/2006/main"/>
         </p:blipFill>
         <p:spPr>
@@ -8894,7 +8894,7 @@
           <p:cNvPr id="24" name="">
             <a:extLst xmlns:a="http://schemas.openxmlformats.org/drawingml/2006/main">
               <a:ext uri="{FF2B5EF4-FFF2-40B4-BE49-F238E27FC236}">
-                <a16:creationId xmlns:a16="http://schemas.microsoft.com/office/drawing/2014/main" id="{09FCD1F3-2F91-4B71-B18D-424E4042EA61}"/>
+                <a16:creationId xmlns:a16="http://schemas.microsoft.com/office/drawing/2014/main" id="{668145DB-F98D-45A2-AD82-DAFF3723DDAA}"/>
               </a:ext>
             </a:extLst>
           </p:cNvPr>
@@ -8952,7 +8952,7 @@
           <p:cNvPr id="25" name="">
             <a:extLst xmlns:a="http://schemas.openxmlformats.org/drawingml/2006/main">
               <a:ext uri="{FF2B5EF4-FFF2-40B4-BE49-F238E27FC236}">
-                <a16:creationId xmlns:a16="http://schemas.microsoft.com/office/drawing/2014/main" id="{DA3CC2AD-C3A4-4A16-B584-9F2B0ECA45D3}"/>
+                <a16:creationId xmlns:a16="http://schemas.microsoft.com/office/drawing/2014/main" id="{C24FC67B-11B5-4AE8-AA6B-397D368EC6E8}"/>
               </a:ext>
             </a:extLst>
           </p:cNvPr>
@@ -9014,7 +9014,7 @@
           <p:nvPr/>
         </p:nvPicPr>
         <p:blipFill>
-          <a:blip xmlns:r="http://schemas.openxmlformats.org/officeDocument/2006/relationships" xmlns:a="http://schemas.openxmlformats.org/drawingml/2006/main" r:embed="R4e6e38d0f4964b1a"/>
+          <a:blip xmlns:r="http://schemas.openxmlformats.org/officeDocument/2006/relationships" xmlns:a="http://schemas.openxmlformats.org/drawingml/2006/main" r:embed="R381c6d8354c9444f"/>
           <a:stretch xmlns:a="http://schemas.openxmlformats.org/drawingml/2006/main"/>
         </p:blipFill>
         <p:spPr>
@@ -9032,7 +9032,7 @@
           <p:cNvPr id="27" name="">
             <a:extLst xmlns:a="http://schemas.openxmlformats.org/drawingml/2006/main">
               <a:ext uri="{FF2B5EF4-FFF2-40B4-BE49-F238E27FC236}">
-                <a16:creationId xmlns:a16="http://schemas.microsoft.com/office/drawing/2014/main" id="{A0281425-36A1-4A2C-AFC4-3BACE3930AC1}"/>
+                <a16:creationId xmlns:a16="http://schemas.microsoft.com/office/drawing/2014/main" id="{8518136D-EAD9-43D6-9418-3E7B5BF683C0}"/>
               </a:ext>
             </a:extLst>
           </p:cNvPr>
@@ -9090,7 +9090,7 @@
           <p:cNvPr id="28" name="slide-number-5">
             <a:extLst xmlns:a="http://schemas.openxmlformats.org/drawingml/2006/main">
               <a:ext uri="{FF2B5EF4-FFF2-40B4-BE49-F238E27FC236}">
-                <a16:creationId xmlns:a16="http://schemas.microsoft.com/office/drawing/2014/main" id="{CB1EEF48-844C-4702-BCE5-721B0700E818}"/>
+                <a16:creationId xmlns:a16="http://schemas.microsoft.com/office/drawing/2014/main" id="{16EE2E2D-DF71-4650-9C47-47148C0F422A}"/>
               </a:ext>
             </a:extLst>
           </p:cNvPr>
@@ -9146,7 +9146,7 @@
     </p:spTree>
     <p:extLst>
       <p:ext uri="{BB962C8B-B14F-4D97-AF65-F5344CB8AC3E}">
-        <p14:creationId xmlns:p14="http://schemas.microsoft.com/office/powerpoint/2010/main" val="876741180"/>
+        <p14:creationId xmlns:p14="http://schemas.microsoft.com/office/powerpoint/2010/main" val="981358159"/>
       </p:ext>
     </p:extLst>
   </p:cSld>
@@ -9177,7 +9177,7 @@
           <p:cNvPr id="23" name="title-T1">
             <a:extLst xmlns:a="http://schemas.openxmlformats.org/drawingml/2006/main">
               <a:ext uri="{FF2B5EF4-FFF2-40B4-BE49-F238E27FC236}">
-                <a16:creationId xmlns:a16="http://schemas.microsoft.com/office/drawing/2014/main" id="{9DD4F7A1-75FF-43B1-BA23-84B43B3A9DEF}"/>
+                <a16:creationId xmlns:a16="http://schemas.microsoft.com/office/drawing/2014/main" id="{2087FB78-736C-4348-AC5B-F4D93351990C}"/>
               </a:ext>
             </a:extLst>
           </p:cNvPr>
@@ -9239,7 +9239,7 @@
           <p:cNvPr id="2" name="subtitle-T1-slide6">
             <a:extLst xmlns:a="http://schemas.openxmlformats.org/drawingml/2006/main">
               <a:ext uri="{FF2B5EF4-FFF2-40B4-BE49-F238E27FC236}">
-                <a16:creationId xmlns:a16="http://schemas.microsoft.com/office/drawing/2014/main" id="{3D151053-B497-41A5-B0BF-5FA282822E25}"/>
+                <a16:creationId xmlns:a16="http://schemas.microsoft.com/office/drawing/2014/main" id="{01FD7C05-8F1C-4356-B191-83858483F058}"/>
               </a:ext>
             </a:extLst>
           </p:cNvPr>
@@ -9297,7 +9297,7 @@
           <p:cNvPr id="3" name="">
             <a:extLst xmlns:a="http://schemas.openxmlformats.org/drawingml/2006/main">
               <a:ext uri="{FF2B5EF4-FFF2-40B4-BE49-F238E27FC236}">
-                <a16:creationId xmlns:a16="http://schemas.microsoft.com/office/drawing/2014/main" id="{1E933BE6-B850-47DC-8177-4519C59467FD}"/>
+                <a16:creationId xmlns:a16="http://schemas.microsoft.com/office/drawing/2014/main" id="{B2A8B700-FCBE-4D7B-B193-42983B592778}"/>
               </a:ext>
             </a:extLst>
           </p:cNvPr>
@@ -9355,7 +9355,7 @@
           <p:cNvPr id="4" name="">
             <a:extLst xmlns:a="http://schemas.openxmlformats.org/drawingml/2006/main">
               <a:ext uri="{FF2B5EF4-FFF2-40B4-BE49-F238E27FC236}">
-                <a16:creationId xmlns:a16="http://schemas.microsoft.com/office/drawing/2014/main" id="{7211F809-A4AA-4716-A33B-BE1C6F24DD9C}"/>
+                <a16:creationId xmlns:a16="http://schemas.microsoft.com/office/drawing/2014/main" id="{9FA5E51F-8125-403B-88EF-90E4C438C3ED}"/>
               </a:ext>
             </a:extLst>
           </p:cNvPr>
@@ -9417,7 +9417,7 @@
           <p:cNvPr id="5" name="">
             <a:extLst xmlns:a="http://schemas.openxmlformats.org/drawingml/2006/main">
               <a:ext uri="{FF2B5EF4-FFF2-40B4-BE49-F238E27FC236}">
-                <a16:creationId xmlns:a16="http://schemas.microsoft.com/office/drawing/2014/main" id="{681311CD-569F-42F1-887D-843B06746659}"/>
+                <a16:creationId xmlns:a16="http://schemas.microsoft.com/office/drawing/2014/main" id="{A8BD2272-0769-453E-B725-7C51403023F5}"/>
               </a:ext>
             </a:extLst>
           </p:cNvPr>
@@ -9475,7 +9475,7 @@
           <p:cNvPr id="6" name="">
             <a:extLst xmlns:a="http://schemas.openxmlformats.org/drawingml/2006/main">
               <a:ext uri="{FF2B5EF4-FFF2-40B4-BE49-F238E27FC236}">
-                <a16:creationId xmlns:a16="http://schemas.microsoft.com/office/drawing/2014/main" id="{3CAD429C-B514-49D9-B660-EDE06CD25B01}"/>
+                <a16:creationId xmlns:a16="http://schemas.microsoft.com/office/drawing/2014/main" id="{20E3304C-F944-4934-875A-0E2D55C30349}"/>
               </a:ext>
             </a:extLst>
           </p:cNvPr>
@@ -9506,7 +9506,7 @@
           <p:cNvPr id="7" name="">
             <a:extLst xmlns:a="http://schemas.openxmlformats.org/drawingml/2006/main">
               <a:ext uri="{FF2B5EF4-FFF2-40B4-BE49-F238E27FC236}">
-                <a16:creationId xmlns:a16="http://schemas.microsoft.com/office/drawing/2014/main" id="{E1032C4B-B9CD-4FB1-B9E4-9E604DF3024C}"/>
+                <a16:creationId xmlns:a16="http://schemas.microsoft.com/office/drawing/2014/main" id="{D50EEBCA-18C3-4640-BC11-7A2A22C31E5F}"/>
               </a:ext>
             </a:extLst>
           </p:cNvPr>
@@ -9568,7 +9568,7 @@
           <p:cNvPr id="8" name="">
             <a:extLst xmlns:a="http://schemas.openxmlformats.org/drawingml/2006/main">
               <a:ext uri="{FF2B5EF4-FFF2-40B4-BE49-F238E27FC236}">
-                <a16:creationId xmlns:a16="http://schemas.microsoft.com/office/drawing/2014/main" id="{B83F6590-4371-4427-86B8-5B3DAA516E7B}"/>
+                <a16:creationId xmlns:a16="http://schemas.microsoft.com/office/drawing/2014/main" id="{64EEA90D-552A-4CB4-B4F9-37394F730CF7}"/>
               </a:ext>
             </a:extLst>
           </p:cNvPr>
@@ -9626,7 +9626,7 @@
           <p:cNvPr id="9" name="">
             <a:extLst xmlns:a="http://schemas.openxmlformats.org/drawingml/2006/main">
               <a:ext uri="{FF2B5EF4-FFF2-40B4-BE49-F238E27FC236}">
-                <a16:creationId xmlns:a16="http://schemas.microsoft.com/office/drawing/2014/main" id="{EC98AF0A-FEB1-47AB-9013-53581D002B01}"/>
+                <a16:creationId xmlns:a16="http://schemas.microsoft.com/office/drawing/2014/main" id="{5727A6E3-388C-47E6-B6A9-147FA098F48E}"/>
               </a:ext>
             </a:extLst>
           </p:cNvPr>
@@ -9657,7 +9657,7 @@
           <p:cNvPr id="10" name="">
             <a:extLst xmlns:a="http://schemas.openxmlformats.org/drawingml/2006/main">
               <a:ext uri="{FF2B5EF4-FFF2-40B4-BE49-F238E27FC236}">
-                <a16:creationId xmlns:a16="http://schemas.microsoft.com/office/drawing/2014/main" id="{7E38CE17-FCFD-40DE-9334-B698ABFC2B00}"/>
+                <a16:creationId xmlns:a16="http://schemas.microsoft.com/office/drawing/2014/main" id="{F187217C-80F1-42B9-8770-B655CF5FBEF8}"/>
               </a:ext>
             </a:extLst>
           </p:cNvPr>
@@ -9719,7 +9719,7 @@
           <p:cNvPr id="11" name="">
             <a:extLst xmlns:a="http://schemas.openxmlformats.org/drawingml/2006/main">
               <a:ext uri="{FF2B5EF4-FFF2-40B4-BE49-F238E27FC236}">
-                <a16:creationId xmlns:a16="http://schemas.microsoft.com/office/drawing/2014/main" id="{D0E01742-EF66-4E34-A3D9-D7DD6E0BD70D}"/>
+                <a16:creationId xmlns:a16="http://schemas.microsoft.com/office/drawing/2014/main" id="{401241D2-5EA1-4E2A-B374-A64A6592FC1B}"/>
               </a:ext>
             </a:extLst>
           </p:cNvPr>
@@ -9777,7 +9777,7 @@
           <p:cNvPr id="12" name="">
             <a:extLst xmlns:a="http://schemas.openxmlformats.org/drawingml/2006/main">
               <a:ext uri="{FF2B5EF4-FFF2-40B4-BE49-F238E27FC236}">
-                <a16:creationId xmlns:a16="http://schemas.microsoft.com/office/drawing/2014/main" id="{4AD88420-9D35-4BB1-8D4B-C96CDF63B387}"/>
+                <a16:creationId xmlns:a16="http://schemas.microsoft.com/office/drawing/2014/main" id="{840EB676-9777-42E4-A40F-B9322ADE7480}"/>
               </a:ext>
             </a:extLst>
           </p:cNvPr>
@@ -9808,7 +9808,7 @@
           <p:cNvPr id="13" name="">
             <a:extLst xmlns:a="http://schemas.openxmlformats.org/drawingml/2006/main">
               <a:ext uri="{FF2B5EF4-FFF2-40B4-BE49-F238E27FC236}">
-                <a16:creationId xmlns:a16="http://schemas.microsoft.com/office/drawing/2014/main" id="{0F073F60-30C1-4D0A-94BE-306F2AA6EF2E}"/>
+                <a16:creationId xmlns:a16="http://schemas.microsoft.com/office/drawing/2014/main" id="{40C9C495-A0C4-41B7-8D8F-957509A26870}"/>
               </a:ext>
             </a:extLst>
           </p:cNvPr>
@@ -9870,7 +9870,7 @@
           <p:cNvPr id="14" name="">
             <a:extLst xmlns:a="http://schemas.openxmlformats.org/drawingml/2006/main">
               <a:ext uri="{FF2B5EF4-FFF2-40B4-BE49-F238E27FC236}">
-                <a16:creationId xmlns:a16="http://schemas.microsoft.com/office/drawing/2014/main" id="{C06C9DD4-73E4-4A1B-B66D-8399CBCE21B6}"/>
+                <a16:creationId xmlns:a16="http://schemas.microsoft.com/office/drawing/2014/main" id="{31D4D7C7-C1EC-4A74-8C0A-C3A2087CAA4E}"/>
               </a:ext>
             </a:extLst>
           </p:cNvPr>
@@ -9928,7 +9928,7 @@
           <p:cNvPr id="15" name="">
             <a:extLst xmlns:a="http://schemas.openxmlformats.org/drawingml/2006/main">
               <a:ext uri="{FF2B5EF4-FFF2-40B4-BE49-F238E27FC236}">
-                <a16:creationId xmlns:a16="http://schemas.microsoft.com/office/drawing/2014/main" id="{36E107C6-D575-4A95-AE4C-FB07E73A9CD0}"/>
+                <a16:creationId xmlns:a16="http://schemas.microsoft.com/office/drawing/2014/main" id="{CDE9B295-D533-496F-BC2E-F335EA069BCC}"/>
               </a:ext>
             </a:extLst>
           </p:cNvPr>
@@ -9959,7 +9959,7 @@
           <p:cNvPr id="16" name="">
             <a:extLst xmlns:a="http://schemas.openxmlformats.org/drawingml/2006/main">
               <a:ext uri="{FF2B5EF4-FFF2-40B4-BE49-F238E27FC236}">
-                <a16:creationId xmlns:a16="http://schemas.microsoft.com/office/drawing/2014/main" id="{2B210C3F-338C-47FD-9144-7F7C1ABE2EB8}"/>
+                <a16:creationId xmlns:a16="http://schemas.microsoft.com/office/drawing/2014/main" id="{0CD0C7DC-38B2-40D8-B0E0-27C365A1EFB0}"/>
               </a:ext>
             </a:extLst>
           </p:cNvPr>
@@ -10021,7 +10021,7 @@
           <p:cNvPr id="17" name="">
             <a:extLst xmlns:a="http://schemas.openxmlformats.org/drawingml/2006/main">
               <a:ext uri="{FF2B5EF4-FFF2-40B4-BE49-F238E27FC236}">
-                <a16:creationId xmlns:a16="http://schemas.microsoft.com/office/drawing/2014/main" id="{A9934D9C-5071-4598-BD06-88B6549A2EB6}"/>
+                <a16:creationId xmlns:a16="http://schemas.microsoft.com/office/drawing/2014/main" id="{C69D7AA6-956E-4988-9068-4B946AEFA039}"/>
               </a:ext>
             </a:extLst>
           </p:cNvPr>
@@ -10079,7 +10079,7 @@
           <p:cNvPr id="18" name="">
             <a:extLst xmlns:a="http://schemas.openxmlformats.org/drawingml/2006/main">
               <a:ext uri="{FF2B5EF4-FFF2-40B4-BE49-F238E27FC236}">
-                <a16:creationId xmlns:a16="http://schemas.microsoft.com/office/drawing/2014/main" id="{C607B43A-41DE-4849-A56C-19FA24E342EA}"/>
+                <a16:creationId xmlns:a16="http://schemas.microsoft.com/office/drawing/2014/main" id="{95CD45BD-582B-4F67-90DD-5BA2DDA384FB}"/>
               </a:ext>
             </a:extLst>
           </p:cNvPr>
@@ -10114,7 +10114,7 @@
           <p:cNvPr id="19" name="">
             <a:extLst xmlns:a="http://schemas.openxmlformats.org/drawingml/2006/main">
               <a:ext uri="{FF2B5EF4-FFF2-40B4-BE49-F238E27FC236}">
-                <a16:creationId xmlns:a16="http://schemas.microsoft.com/office/drawing/2014/main" id="{7859AFEB-DDFF-41B9-9E16-5E24E11DD25A}"/>
+                <a16:creationId xmlns:a16="http://schemas.microsoft.com/office/drawing/2014/main" id="{86EB59E5-E258-4EEB-B3A2-427C2FA895CB}"/>
               </a:ext>
             </a:extLst>
           </p:cNvPr>
@@ -10172,7 +10172,7 @@
           <p:cNvPr id="20" name="code-sample">
             <a:extLst xmlns:a="http://schemas.openxmlformats.org/drawingml/2006/main">
               <a:ext uri="{FF2B5EF4-FFF2-40B4-BE49-F238E27FC236}">
-                <a16:creationId xmlns:a16="http://schemas.microsoft.com/office/drawing/2014/main" id="{F8CBFD02-941F-45B8-8F68-F5373035E0C5}"/>
+                <a16:creationId xmlns:a16="http://schemas.microsoft.com/office/drawing/2014/main" id="{B25BDA36-206B-4736-AFE3-44C5EBED4E27}"/>
               </a:ext>
             </a:extLst>
           </p:cNvPr>
@@ -10465,7 +10465,7 @@
           <p:cNvPr id="21" name="">
             <a:extLst xmlns:a="http://schemas.openxmlformats.org/drawingml/2006/main">
               <a:ext uri="{FF2B5EF4-FFF2-40B4-BE49-F238E27FC236}">
-                <a16:creationId xmlns:a16="http://schemas.microsoft.com/office/drawing/2014/main" id="{5FCE14AA-63AB-454B-817A-1EDB46E24302}"/>
+                <a16:creationId xmlns:a16="http://schemas.microsoft.com/office/drawing/2014/main" id="{9D1BF321-33ED-4247-AC0B-0CEF8D9C0CE7}"/>
               </a:ext>
             </a:extLst>
           </p:cNvPr>
@@ -10523,7 +10523,7 @@
           <p:cNvPr id="22" name="slide-number-6">
             <a:extLst xmlns:a="http://schemas.openxmlformats.org/drawingml/2006/main">
               <a:ext uri="{FF2B5EF4-FFF2-40B4-BE49-F238E27FC236}">
-                <a16:creationId xmlns:a16="http://schemas.microsoft.com/office/drawing/2014/main" id="{689C40B6-B05C-4683-9FBC-146F41412C72}"/>
+                <a16:creationId xmlns:a16="http://schemas.microsoft.com/office/drawing/2014/main" id="{7E1BB72D-EC00-4835-A035-D4CA47E9A0F4}"/>
               </a:ext>
             </a:extLst>
           </p:cNvPr>
@@ -10579,7 +10579,7 @@
     </p:spTree>
     <p:extLst>
       <p:ext uri="{BB962C8B-B14F-4D97-AF65-F5344CB8AC3E}">
-        <p14:creationId xmlns:p14="http://schemas.microsoft.com/office/powerpoint/2010/main" val="982924053"/>
+        <p14:creationId xmlns:p14="http://schemas.microsoft.com/office/powerpoint/2010/main" val="1342738259"/>
       </p:ext>
     </p:extLst>
   </p:cSld>
@@ -10610,7 +10610,7 @@
           <p:cNvPr id="20" name="title-T1">
             <a:extLst xmlns:a="http://schemas.openxmlformats.org/drawingml/2006/main">
               <a:ext uri="{FF2B5EF4-FFF2-40B4-BE49-F238E27FC236}">
-                <a16:creationId xmlns:a16="http://schemas.microsoft.com/office/drawing/2014/main" id="{2C0FE512-4CA8-4977-8D29-5E43ABE71767}"/>
+                <a16:creationId xmlns:a16="http://schemas.microsoft.com/office/drawing/2014/main" id="{03552553-81A1-4CB9-A78E-72FB8C64B8C3}"/>
               </a:ext>
             </a:extLst>
           </p:cNvPr>
@@ -10672,7 +10672,7 @@
           <p:cNvPr id="2" name="subtitle-T1">
             <a:extLst xmlns:a="http://schemas.openxmlformats.org/drawingml/2006/main">
               <a:ext uri="{FF2B5EF4-FFF2-40B4-BE49-F238E27FC236}">
-                <a16:creationId xmlns:a16="http://schemas.microsoft.com/office/drawing/2014/main" id="{93510B22-EB05-4B15-ACD8-7505B61A661B}"/>
+                <a16:creationId xmlns:a16="http://schemas.microsoft.com/office/drawing/2014/main" id="{8F0BA65A-A136-4AB3-A6BF-E96D7C90345F}"/>
               </a:ext>
             </a:extLst>
           </p:cNvPr>
@@ -10734,7 +10734,7 @@
           <p:nvPr/>
         </p:nvPicPr>
         <p:blipFill>
-          <a:blip xmlns:r="http://schemas.openxmlformats.org/officeDocument/2006/relationships" xmlns:a="http://schemas.openxmlformats.org/drawingml/2006/main" r:embed="R890cbf695a694f27"/>
+          <a:blip xmlns:r="http://schemas.openxmlformats.org/officeDocument/2006/relationships" xmlns:a="http://schemas.openxmlformats.org/drawingml/2006/main" r:embed="R8e778c9451984feb"/>
           <a:stretch xmlns:a="http://schemas.openxmlformats.org/drawingml/2006/main"/>
         </p:blipFill>
         <p:spPr>
@@ -10756,7 +10756,7 @@
           <p:nvPr/>
         </p:nvPicPr>
         <p:blipFill>
-          <a:blip xmlns:r="http://schemas.openxmlformats.org/officeDocument/2006/relationships" xmlns:a="http://schemas.openxmlformats.org/drawingml/2006/main" r:embed="R5b3e3a6a1589449a"/>
+          <a:blip xmlns:r="http://schemas.openxmlformats.org/officeDocument/2006/relationships" xmlns:a="http://schemas.openxmlformats.org/drawingml/2006/main" r:embed="R001dabd067764fc1"/>
           <a:stretch xmlns:a="http://schemas.openxmlformats.org/drawingml/2006/main"/>
         </p:blipFill>
         <p:spPr>
@@ -10774,7 +10774,7 @@
           <p:cNvPr id="5" name="">
             <a:extLst xmlns:a="http://schemas.openxmlformats.org/drawingml/2006/main">
               <a:ext uri="{FF2B5EF4-FFF2-40B4-BE49-F238E27FC236}">
-                <a16:creationId xmlns:a16="http://schemas.microsoft.com/office/drawing/2014/main" id="{AD2AE792-E3DC-4B24-96BF-6AEE40EC94F7}"/>
+                <a16:creationId xmlns:a16="http://schemas.microsoft.com/office/drawing/2014/main" id="{BCEBE892-BFCE-4512-B667-29D3293D9D97}"/>
               </a:ext>
             </a:extLst>
           </p:cNvPr>
@@ -10813,7 +10813,7 @@
           <p:nvPr/>
         </p:nvPicPr>
         <p:blipFill>
-          <a:blip xmlns:r="http://schemas.openxmlformats.org/officeDocument/2006/relationships" xmlns:a="http://schemas.openxmlformats.org/drawingml/2006/main" r:embed="R0a104a9a7f184571"/>
+          <a:blip xmlns:r="http://schemas.openxmlformats.org/officeDocument/2006/relationships" xmlns:a="http://schemas.openxmlformats.org/drawingml/2006/main" r:embed="R677c166cd4334059"/>
           <a:stretch xmlns:a="http://schemas.openxmlformats.org/drawingml/2006/main"/>
         </p:blipFill>
         <p:spPr>
@@ -10831,7 +10831,7 @@
           <p:cNvPr id="7" name="">
             <a:extLst xmlns:a="http://schemas.openxmlformats.org/drawingml/2006/main">
               <a:ext uri="{FF2B5EF4-FFF2-40B4-BE49-F238E27FC236}">
-                <a16:creationId xmlns:a16="http://schemas.microsoft.com/office/drawing/2014/main" id="{D1EC1C4F-4125-42C1-8FFE-F057C5B82CFB}"/>
+                <a16:creationId xmlns:a16="http://schemas.microsoft.com/office/drawing/2014/main" id="{DA22AA3C-D669-4DED-9FBD-468EC36AA1F1}"/>
               </a:ext>
             </a:extLst>
           </p:cNvPr>
@@ -10889,7 +10889,7 @@
           <p:cNvPr id="8" name="">
             <a:extLst xmlns:a="http://schemas.openxmlformats.org/drawingml/2006/main">
               <a:ext uri="{FF2B5EF4-FFF2-40B4-BE49-F238E27FC236}">
-                <a16:creationId xmlns:a16="http://schemas.microsoft.com/office/drawing/2014/main" id="{3C05EB37-2639-4A74-AA45-BF1714ADEE20}"/>
+                <a16:creationId xmlns:a16="http://schemas.microsoft.com/office/drawing/2014/main" id="{07D37D97-AB72-49E2-A076-FF2AD6834676}"/>
               </a:ext>
             </a:extLst>
           </p:cNvPr>
@@ -10928,7 +10928,7 @@
           <p:nvPr/>
         </p:nvPicPr>
         <p:blipFill>
-          <a:blip xmlns:r="http://schemas.openxmlformats.org/officeDocument/2006/relationships" xmlns:a="http://schemas.openxmlformats.org/drawingml/2006/main" r:embed="Rd14fef03863d4f12"/>
+          <a:blip xmlns:r="http://schemas.openxmlformats.org/officeDocument/2006/relationships" xmlns:a="http://schemas.openxmlformats.org/drawingml/2006/main" r:embed="R654102ad34644061"/>
           <a:stretch xmlns:a="http://schemas.openxmlformats.org/drawingml/2006/main"/>
         </p:blipFill>
         <p:spPr>
@@ -10946,7 +10946,7 @@
           <p:cNvPr id="10" name="">
             <a:extLst xmlns:a="http://schemas.openxmlformats.org/drawingml/2006/main">
               <a:ext uri="{FF2B5EF4-FFF2-40B4-BE49-F238E27FC236}">
-                <a16:creationId xmlns:a16="http://schemas.microsoft.com/office/drawing/2014/main" id="{5F7BFC65-988A-472F-AF71-02BB5BA233B1}"/>
+                <a16:creationId xmlns:a16="http://schemas.microsoft.com/office/drawing/2014/main" id="{8EE06A77-7343-4E7E-AA8C-9009C33DEF28}"/>
               </a:ext>
             </a:extLst>
           </p:cNvPr>
@@ -11004,7 +11004,7 @@
           <p:cNvPr id="11" name="">
             <a:extLst xmlns:a="http://schemas.openxmlformats.org/drawingml/2006/main">
               <a:ext uri="{FF2B5EF4-FFF2-40B4-BE49-F238E27FC236}">
-                <a16:creationId xmlns:a16="http://schemas.microsoft.com/office/drawing/2014/main" id="{3A6EF6BC-3714-41DD-81A2-C2CA42AD3EA2}"/>
+                <a16:creationId xmlns:a16="http://schemas.microsoft.com/office/drawing/2014/main" id="{6D5D9929-8CE6-4BF7-8109-79DD74D8A32A}"/>
               </a:ext>
             </a:extLst>
           </p:cNvPr>
@@ -11043,7 +11043,7 @@
           <p:nvPr/>
         </p:nvPicPr>
         <p:blipFill>
-          <a:blip xmlns:r="http://schemas.openxmlformats.org/officeDocument/2006/relationships" xmlns:a="http://schemas.openxmlformats.org/drawingml/2006/main" r:embed="Rf7b91d95976545ac"/>
+          <a:blip xmlns:r="http://schemas.openxmlformats.org/officeDocument/2006/relationships" xmlns:a="http://schemas.openxmlformats.org/drawingml/2006/main" r:embed="Re8730780ebc5468a"/>
           <a:stretch xmlns:a="http://schemas.openxmlformats.org/drawingml/2006/main"/>
         </p:blipFill>
         <p:spPr>
@@ -11061,7 +11061,7 @@
           <p:cNvPr id="13" name="">
             <a:extLst xmlns:a="http://schemas.openxmlformats.org/drawingml/2006/main">
               <a:ext uri="{FF2B5EF4-FFF2-40B4-BE49-F238E27FC236}">
-                <a16:creationId xmlns:a16="http://schemas.microsoft.com/office/drawing/2014/main" id="{33AAAC03-9E9C-41E6-9854-7DEB6AB2F69C}"/>
+                <a16:creationId xmlns:a16="http://schemas.microsoft.com/office/drawing/2014/main" id="{CF7F71B1-19ED-4D16-AFF9-F1BC4858E688}"/>
               </a:ext>
             </a:extLst>
           </p:cNvPr>
@@ -11119,7 +11119,7 @@
           <p:cNvPr id="14" name="">
             <a:extLst xmlns:a="http://schemas.openxmlformats.org/drawingml/2006/main">
               <a:ext uri="{FF2B5EF4-FFF2-40B4-BE49-F238E27FC236}">
-                <a16:creationId xmlns:a16="http://schemas.microsoft.com/office/drawing/2014/main" id="{D9DCE808-44DC-404A-9679-D539855D36C2}"/>
+                <a16:creationId xmlns:a16="http://schemas.microsoft.com/office/drawing/2014/main" id="{F3A680E0-631E-4DD1-9BD0-727B1C4D3669}"/>
               </a:ext>
             </a:extLst>
           </p:cNvPr>
@@ -11158,7 +11158,7 @@
           <p:nvPr/>
         </p:nvPicPr>
         <p:blipFill>
-          <a:blip xmlns:r="http://schemas.openxmlformats.org/officeDocument/2006/relationships" xmlns:a="http://schemas.openxmlformats.org/drawingml/2006/main" r:embed="R64320bac1d5f4426"/>
+          <a:blip xmlns:r="http://schemas.openxmlformats.org/officeDocument/2006/relationships" xmlns:a="http://schemas.openxmlformats.org/drawingml/2006/main" r:embed="R732500a285bf48a1"/>
           <a:stretch xmlns:a="http://schemas.openxmlformats.org/drawingml/2006/main"/>
         </p:blipFill>
         <p:spPr>
@@ -11176,7 +11176,7 @@
           <p:cNvPr id="16" name="">
             <a:extLst xmlns:a="http://schemas.openxmlformats.org/drawingml/2006/main">
               <a:ext uri="{FF2B5EF4-FFF2-40B4-BE49-F238E27FC236}">
-                <a16:creationId xmlns:a16="http://schemas.microsoft.com/office/drawing/2014/main" id="{8565D459-9C66-44C3-8302-036F5646EC41}"/>
+                <a16:creationId xmlns:a16="http://schemas.microsoft.com/office/drawing/2014/main" id="{757D14B2-5C2D-465F-8BA7-6359E469A0DB}"/>
               </a:ext>
             </a:extLst>
           </p:cNvPr>
@@ -11234,7 +11234,7 @@
           <p:cNvPr id="17" name="">
             <a:extLst xmlns:a="http://schemas.openxmlformats.org/drawingml/2006/main">
               <a:ext uri="{FF2B5EF4-FFF2-40B4-BE49-F238E27FC236}">
-                <a16:creationId xmlns:a16="http://schemas.microsoft.com/office/drawing/2014/main" id="{01A74A14-22A8-45CF-B707-818E78273F70}"/>
+                <a16:creationId xmlns:a16="http://schemas.microsoft.com/office/drawing/2014/main" id="{94955FE2-B657-400A-9750-033FB6833F2E}"/>
               </a:ext>
             </a:extLst>
           </p:cNvPr>
@@ -11254,11 +11254,11 @@
             </a:avLst>
           </a:prstGeom>
           <a:solidFill xmlns:a="http://schemas.openxmlformats.org/drawingml/2006/main">
-            <a:srgbClr val="F0FAF7"/>
+            <a:srgbClr val="FFF2F2"/>
           </a:solidFill>
           <a:ln xmlns:a="http://schemas.openxmlformats.org/drawingml/2006/main" w="19050">
             <a:solidFill>
-              <a:srgbClr val="2A9D9F"/>
+              <a:srgbClr val="B3262E"/>
             </a:solidFill>
             <a:prstDash val="solid"/>
           </a:ln>
@@ -11269,7 +11269,7 @@
           <p:cNvPr id="18" name="">
             <a:extLst xmlns:a="http://schemas.openxmlformats.org/drawingml/2006/main">
               <a:ext uri="{FF2B5EF4-FFF2-40B4-BE49-F238E27FC236}">
-                <a16:creationId xmlns:a16="http://schemas.microsoft.com/office/drawing/2014/main" id="{C752E27C-5D90-46B5-84DB-DDFD29FD4E09}"/>
+                <a16:creationId xmlns:a16="http://schemas.microsoft.com/office/drawing/2014/main" id="{04EFA7A5-8CC6-4558-9A9C-0AA73BCD1DB7}"/>
               </a:ext>
             </a:extLst>
           </p:cNvPr>
@@ -11301,7 +11301,7 @@
             <a:pPr algn="ctr">
               <a:defRPr sz="2250" b="1">
                 <a:solidFill>
-                  <a:srgbClr val="2A9D9F"/>
+                  <a:srgbClr val="B3262E"/>
                 </a:solidFill>
                 <a:latin typeface="Nunito"/>
                 <a:ea typeface="Nunito"/>
@@ -11311,7 +11311,7 @@
             <a:r>
               <a:rPr sz="2250" b="1">
                 <a:solidFill>
-                  <a:srgbClr val="2A9D9F"/>
+                  <a:srgbClr val="B3262E"/>
                 </a:solidFill>
                 <a:latin typeface="Nunito"/>
                 <a:ea typeface="Nunito"/>
@@ -11327,7 +11327,7 @@
           <p:cNvPr id="19" name="slide-number-7">
             <a:extLst xmlns:a="http://schemas.openxmlformats.org/drawingml/2006/main">
               <a:ext uri="{FF2B5EF4-FFF2-40B4-BE49-F238E27FC236}">
-                <a16:creationId xmlns:a16="http://schemas.microsoft.com/office/drawing/2014/main" id="{7AD6C311-9F7A-4229-BD5C-89CB342DBD1C}"/>
+                <a16:creationId xmlns:a16="http://schemas.microsoft.com/office/drawing/2014/main" id="{D933E66C-55FB-4418-8FFC-E703A2A7F22A}"/>
               </a:ext>
             </a:extLst>
           </p:cNvPr>
@@ -11383,7 +11383,7 @@
     </p:spTree>
     <p:extLst>
       <p:ext uri="{BB962C8B-B14F-4D97-AF65-F5344CB8AC3E}">
-        <p14:creationId xmlns:p14="http://schemas.microsoft.com/office/powerpoint/2010/main" val="536382754"/>
+        <p14:creationId xmlns:p14="http://schemas.microsoft.com/office/powerpoint/2010/main" val="1408870258"/>
       </p:ext>
     </p:extLst>
   </p:cSld>
@@ -11414,7 +11414,7 @@
           <p:cNvPr id="16" name="title-T2">
             <a:extLst xmlns:a="http://schemas.openxmlformats.org/drawingml/2006/main">
               <a:ext uri="{FF2B5EF4-FFF2-40B4-BE49-F238E27FC236}">
-                <a16:creationId xmlns:a16="http://schemas.microsoft.com/office/drawing/2014/main" id="{94EDF3DF-0C6F-4803-AB51-CBE8EB4E7740}"/>
+                <a16:creationId xmlns:a16="http://schemas.microsoft.com/office/drawing/2014/main" id="{9C19115B-C5C3-4617-93DE-A9E4B990DF07}"/>
               </a:ext>
             </a:extLst>
           </p:cNvPr>
@@ -11476,7 +11476,7 @@
           <p:cNvPr id="2" name="subtitle-T2">
             <a:extLst xmlns:a="http://schemas.openxmlformats.org/drawingml/2006/main">
               <a:ext uri="{FF2B5EF4-FFF2-40B4-BE49-F238E27FC236}">
-                <a16:creationId xmlns:a16="http://schemas.microsoft.com/office/drawing/2014/main" id="{3003063E-E41A-4323-8CE4-99B4B180B246}"/>
+                <a16:creationId xmlns:a16="http://schemas.microsoft.com/office/drawing/2014/main" id="{9712B8C4-98F3-4FF5-8AB2-622FF9CE6233}"/>
               </a:ext>
             </a:extLst>
           </p:cNvPr>
@@ -11534,7 +11534,7 @@
           <p:cNvPr id="3" name="">
             <a:extLst xmlns:a="http://schemas.openxmlformats.org/drawingml/2006/main">
               <a:ext uri="{FF2B5EF4-FFF2-40B4-BE49-F238E27FC236}">
-                <a16:creationId xmlns:a16="http://schemas.microsoft.com/office/drawing/2014/main" id="{834186A0-C020-4936-ACBA-E3B32B6D7AAF}"/>
+                <a16:creationId xmlns:a16="http://schemas.microsoft.com/office/drawing/2014/main" id="{BA4846BF-4B63-48A6-817C-3404BB6BC35F}"/>
               </a:ext>
             </a:extLst>
           </p:cNvPr>
@@ -11596,7 +11596,7 @@
           <p:cNvPr id="4" name="">
             <a:extLst xmlns:a="http://schemas.openxmlformats.org/drawingml/2006/main">
               <a:ext uri="{FF2B5EF4-FFF2-40B4-BE49-F238E27FC236}">
-                <a16:creationId xmlns:a16="http://schemas.microsoft.com/office/drawing/2014/main" id="{83989CCF-4C14-447C-A30F-57948447228B}"/>
+                <a16:creationId xmlns:a16="http://schemas.microsoft.com/office/drawing/2014/main" id="{23CDC7CE-AE31-4331-9EAB-3A3BDDB897B9}"/>
               </a:ext>
             </a:extLst>
           </p:cNvPr>
@@ -11631,7 +11631,7 @@
           <p:cNvPr id="5" name="">
             <a:extLst xmlns:a="http://schemas.openxmlformats.org/drawingml/2006/main">
               <a:ext uri="{FF2B5EF4-FFF2-40B4-BE49-F238E27FC236}">
-                <a16:creationId xmlns:a16="http://schemas.microsoft.com/office/drawing/2014/main" id="{79325D25-7322-46B6-A893-FBAEF236F50F}"/>
+                <a16:creationId xmlns:a16="http://schemas.microsoft.com/office/drawing/2014/main" id="{6EF85933-8D90-4042-9CAD-EBF4AD857452}"/>
               </a:ext>
             </a:extLst>
           </p:cNvPr>
@@ -11689,7 +11689,7 @@
           <p:cNvPr id="6" name="">
             <a:extLst xmlns:a="http://schemas.openxmlformats.org/drawingml/2006/main">
               <a:ext uri="{FF2B5EF4-FFF2-40B4-BE49-F238E27FC236}">
-                <a16:creationId xmlns:a16="http://schemas.microsoft.com/office/drawing/2014/main" id="{32FEF8B9-3F84-4B4A-8C40-D4ECAAEE7D76}"/>
+                <a16:creationId xmlns:a16="http://schemas.microsoft.com/office/drawing/2014/main" id="{0E9A8DCD-F8B6-484A-9D73-9477C0D47679}"/>
               </a:ext>
             </a:extLst>
           </p:cNvPr>
@@ -11778,7 +11778,7 @@
           <p:cNvPr id="7" name="">
             <a:extLst xmlns:a="http://schemas.openxmlformats.org/drawingml/2006/main">
               <a:ext uri="{FF2B5EF4-FFF2-40B4-BE49-F238E27FC236}">
-                <a16:creationId xmlns:a16="http://schemas.microsoft.com/office/drawing/2014/main" id="{92DCE0C1-6D91-4D14-BCD5-3548AC74B390}"/>
+                <a16:creationId xmlns:a16="http://schemas.microsoft.com/office/drawing/2014/main" id="{0348DA2F-2C15-4579-B33B-0EBF7426B041}"/>
               </a:ext>
             </a:extLst>
           </p:cNvPr>
@@ -11871,7 +11871,7 @@
           <p:nvPr/>
         </p:nvPicPr>
         <p:blipFill>
-          <a:blip xmlns:r="http://schemas.openxmlformats.org/officeDocument/2006/relationships" xmlns:a="http://schemas.openxmlformats.org/drawingml/2006/main" r:embed="Rec4b4b9c78b24881"/>
+          <a:blip xmlns:r="http://schemas.openxmlformats.org/officeDocument/2006/relationships" xmlns:a="http://schemas.openxmlformats.org/drawingml/2006/main" r:embed="R9cba43a09b96449f"/>
           <a:stretch xmlns:a="http://schemas.openxmlformats.org/drawingml/2006/main"/>
         </p:blipFill>
         <p:spPr>
@@ -11889,7 +11889,7 @@
           <p:cNvPr id="9" name="">
             <a:extLst xmlns:a="http://schemas.openxmlformats.org/drawingml/2006/main">
               <a:ext uri="{FF2B5EF4-FFF2-40B4-BE49-F238E27FC236}">
-                <a16:creationId xmlns:a16="http://schemas.microsoft.com/office/drawing/2014/main" id="{15A4D352-C4D6-40F8-8C77-E3A3FD655087}"/>
+                <a16:creationId xmlns:a16="http://schemas.microsoft.com/office/drawing/2014/main" id="{A22559E2-5A91-48EE-8286-993B3473F2D1}"/>
               </a:ext>
             </a:extLst>
           </p:cNvPr>
@@ -11947,7 +11947,7 @@
           <p:cNvPr id="10" name="">
             <a:extLst xmlns:a="http://schemas.openxmlformats.org/drawingml/2006/main">
               <a:ext uri="{FF2B5EF4-FFF2-40B4-BE49-F238E27FC236}">
-                <a16:creationId xmlns:a16="http://schemas.microsoft.com/office/drawing/2014/main" id="{F044B097-73A6-4162-A58E-FA7F0574AA92}"/>
+                <a16:creationId xmlns:a16="http://schemas.microsoft.com/office/drawing/2014/main" id="{75A99A1C-92AB-430F-9168-6B197F7EF016}"/>
               </a:ext>
             </a:extLst>
           </p:cNvPr>
@@ -12009,7 +12009,7 @@
           <p:nvPr/>
         </p:nvPicPr>
         <p:blipFill>
-          <a:blip xmlns:r="http://schemas.openxmlformats.org/officeDocument/2006/relationships" xmlns:a="http://schemas.openxmlformats.org/drawingml/2006/main" r:embed="R6174091a8f874aa2"/>
+          <a:blip xmlns:r="http://schemas.openxmlformats.org/officeDocument/2006/relationships" xmlns:a="http://schemas.openxmlformats.org/drawingml/2006/main" r:embed="R113ea2ce157b42c0"/>
           <a:stretch xmlns:a="http://schemas.openxmlformats.org/drawingml/2006/main"/>
         </p:blipFill>
         <p:spPr>
@@ -12027,7 +12027,7 @@
           <p:cNvPr id="12" name="">
             <a:extLst xmlns:a="http://schemas.openxmlformats.org/drawingml/2006/main">
               <a:ext uri="{FF2B5EF4-FFF2-40B4-BE49-F238E27FC236}">
-                <a16:creationId xmlns:a16="http://schemas.microsoft.com/office/drawing/2014/main" id="{37228252-9F79-46C0-AAEE-0302D613E1D6}"/>
+                <a16:creationId xmlns:a16="http://schemas.microsoft.com/office/drawing/2014/main" id="{5010764F-F7DC-458C-84CE-A57FD8290115}"/>
               </a:ext>
             </a:extLst>
           </p:cNvPr>
@@ -12089,7 +12089,7 @@
           <p:nvPr/>
         </p:nvPicPr>
         <p:blipFill>
-          <a:blip xmlns:r="http://schemas.openxmlformats.org/officeDocument/2006/relationships" xmlns:a="http://schemas.openxmlformats.org/drawingml/2006/main" r:embed="Rb8d323b342f34cad"/>
+          <a:blip xmlns:r="http://schemas.openxmlformats.org/officeDocument/2006/relationships" xmlns:a="http://schemas.openxmlformats.org/drawingml/2006/main" r:embed="R18c99afa2f524335"/>
           <a:stretch xmlns:a="http://schemas.openxmlformats.org/drawingml/2006/main"/>
         </p:blipFill>
         <p:spPr>
@@ -12107,7 +12107,7 @@
           <p:cNvPr id="14" name="">
             <a:extLst xmlns:a="http://schemas.openxmlformats.org/drawingml/2006/main">
               <a:ext uri="{FF2B5EF4-FFF2-40B4-BE49-F238E27FC236}">
-                <a16:creationId xmlns:a16="http://schemas.microsoft.com/office/drawing/2014/main" id="{0BF9DDA0-F297-439E-90C8-1BFC1EC97BEC}"/>
+                <a16:creationId xmlns:a16="http://schemas.microsoft.com/office/drawing/2014/main" id="{1F7CF5F4-EE80-48C5-ADBA-19EEC5DFEF7E}"/>
               </a:ext>
             </a:extLst>
           </p:cNvPr>
@@ -12165,7 +12165,7 @@
           <p:cNvPr id="15" name="slide-number-8">
             <a:extLst xmlns:a="http://schemas.openxmlformats.org/drawingml/2006/main">
               <a:ext uri="{FF2B5EF4-FFF2-40B4-BE49-F238E27FC236}">
-                <a16:creationId xmlns:a16="http://schemas.microsoft.com/office/drawing/2014/main" id="{1D2A6123-6CAF-4B05-B62B-6D40F0A7B435}"/>
+                <a16:creationId xmlns:a16="http://schemas.microsoft.com/office/drawing/2014/main" id="{60785F8A-3507-41CD-B826-5EC4557708AD}"/>
               </a:ext>
             </a:extLst>
           </p:cNvPr>
@@ -12221,7 +12221,7 @@
     </p:spTree>
     <p:extLst>
       <p:ext uri="{BB962C8B-B14F-4D97-AF65-F5344CB8AC3E}">
-        <p14:creationId xmlns:p14="http://schemas.microsoft.com/office/powerpoint/2010/main" val="1726573446"/>
+        <p14:creationId xmlns:p14="http://schemas.microsoft.com/office/powerpoint/2010/main" val="1259842193"/>
       </p:ext>
     </p:extLst>
   </p:cSld>
@@ -12252,7 +12252,7 @@
           <p:cNvPr id="25" name="title-T2">
             <a:extLst xmlns:a="http://schemas.openxmlformats.org/drawingml/2006/main">
               <a:ext uri="{FF2B5EF4-FFF2-40B4-BE49-F238E27FC236}">
-                <a16:creationId xmlns:a16="http://schemas.microsoft.com/office/drawing/2014/main" id="{8CBBB8C2-9538-48BB-9A92-259F90EB2D0D}"/>
+                <a16:creationId xmlns:a16="http://schemas.microsoft.com/office/drawing/2014/main" id="{EFE6516B-B2BC-4EE5-A7C1-23524AEFFD24}"/>
               </a:ext>
             </a:extLst>
           </p:cNvPr>
@@ -12314,7 +12314,7 @@
           <p:cNvPr id="2" name="subtitle-T2">
             <a:extLst xmlns:a="http://schemas.openxmlformats.org/drawingml/2006/main">
               <a:ext uri="{FF2B5EF4-FFF2-40B4-BE49-F238E27FC236}">
-                <a16:creationId xmlns:a16="http://schemas.microsoft.com/office/drawing/2014/main" id="{9014E539-755F-433A-AA35-844D3DA021F5}"/>
+                <a16:creationId xmlns:a16="http://schemas.microsoft.com/office/drawing/2014/main" id="{BD3BFA6F-77F9-485D-97DA-337005ADD3C2}"/>
               </a:ext>
             </a:extLst>
           </p:cNvPr>
@@ -12372,7 +12372,7 @@
           <p:cNvPr id="3" name="">
             <a:extLst xmlns:a="http://schemas.openxmlformats.org/drawingml/2006/main">
               <a:ext uri="{FF2B5EF4-FFF2-40B4-BE49-F238E27FC236}">
-                <a16:creationId xmlns:a16="http://schemas.microsoft.com/office/drawing/2014/main" id="{BD5EE279-FB40-453E-B283-317415C752A1}"/>
+                <a16:creationId xmlns:a16="http://schemas.microsoft.com/office/drawing/2014/main" id="{ED83A50B-88FF-4FD6-9549-BB8AC6455C13}"/>
               </a:ext>
             </a:extLst>
           </p:cNvPr>
@@ -12403,7 +12403,7 @@
           <p:cNvPr id="4" name="">
             <a:extLst xmlns:a="http://schemas.openxmlformats.org/drawingml/2006/main">
               <a:ext uri="{FF2B5EF4-FFF2-40B4-BE49-F238E27FC236}">
-                <a16:creationId xmlns:a16="http://schemas.microsoft.com/office/drawing/2014/main" id="{D8E2A404-F88A-48E7-94A0-6A7347514490}"/>
+                <a16:creationId xmlns:a16="http://schemas.microsoft.com/office/drawing/2014/main" id="{4B345EDB-7AAE-4FF6-981B-98DA18E618A3}"/>
               </a:ext>
             </a:extLst>
           </p:cNvPr>
@@ -12434,7 +12434,7 @@
           <p:cNvPr id="5" name="">
             <a:extLst xmlns:a="http://schemas.openxmlformats.org/drawingml/2006/main">
               <a:ext uri="{FF2B5EF4-FFF2-40B4-BE49-F238E27FC236}">
-                <a16:creationId xmlns:a16="http://schemas.microsoft.com/office/drawing/2014/main" id="{A8BD90C4-BED7-4893-BFE9-CBF31C573424}"/>
+                <a16:creationId xmlns:a16="http://schemas.microsoft.com/office/drawing/2014/main" id="{07098E4E-6527-4973-A6A9-9AA52FE50D45}"/>
               </a:ext>
             </a:extLst>
           </p:cNvPr>
@@ -12465,7 +12465,7 @@
           <p:cNvPr id="6" name="">
             <a:extLst xmlns:a="http://schemas.openxmlformats.org/drawingml/2006/main">
               <a:ext uri="{FF2B5EF4-FFF2-40B4-BE49-F238E27FC236}">
-                <a16:creationId xmlns:a16="http://schemas.microsoft.com/office/drawing/2014/main" id="{59864D39-30CE-419A-B5FE-E64EEBD654AF}"/>
+                <a16:creationId xmlns:a16="http://schemas.microsoft.com/office/drawing/2014/main" id="{ED54A21B-8754-4385-8054-7D12500D78F2}"/>
               </a:ext>
             </a:extLst>
           </p:cNvPr>
@@ -12500,7 +12500,7 @@
           <p:cNvPr id="7" name="">
             <a:extLst xmlns:a="http://schemas.openxmlformats.org/drawingml/2006/main">
               <a:ext uri="{FF2B5EF4-FFF2-40B4-BE49-F238E27FC236}">
-                <a16:creationId xmlns:a16="http://schemas.microsoft.com/office/drawing/2014/main" id="{3A138C60-BCD8-43D2-BA17-5FDFBEB5DD64}"/>
+                <a16:creationId xmlns:a16="http://schemas.microsoft.com/office/drawing/2014/main" id="{22F15C0F-62AE-4217-95C3-4C87891BEB1A}"/>
               </a:ext>
             </a:extLst>
           </p:cNvPr>
@@ -12562,7 +12562,7 @@
           <p:cNvPr id="8" name="">
             <a:extLst xmlns:a="http://schemas.openxmlformats.org/drawingml/2006/main">
               <a:ext uri="{FF2B5EF4-FFF2-40B4-BE49-F238E27FC236}">
-                <a16:creationId xmlns:a16="http://schemas.microsoft.com/office/drawing/2014/main" id="{BB1095A6-0111-4224-A3B5-6D7927DD89F1}"/>
+                <a16:creationId xmlns:a16="http://schemas.microsoft.com/office/drawing/2014/main" id="{9C4B1DCA-AFBE-4BE4-BE41-BD58BC4E97F4}"/>
               </a:ext>
             </a:extLst>
           </p:cNvPr>
@@ -12620,7 +12620,7 @@
           <p:cNvPr id="9" name="">
             <a:extLst xmlns:a="http://schemas.openxmlformats.org/drawingml/2006/main">
               <a:ext uri="{FF2B5EF4-FFF2-40B4-BE49-F238E27FC236}">
-                <a16:creationId xmlns:a16="http://schemas.microsoft.com/office/drawing/2014/main" id="{566ADACC-1F8E-4A32-83A0-7635CD48EAE7}"/>
+                <a16:creationId xmlns:a16="http://schemas.microsoft.com/office/drawing/2014/main" id="{7B4C4298-B8AD-4CFB-9098-994FC68CBC8A}"/>
               </a:ext>
             </a:extLst>
           </p:cNvPr>
@@ -12709,7 +12709,7 @@
           <p:cNvPr id="10" name="">
             <a:extLst xmlns:a="http://schemas.openxmlformats.org/drawingml/2006/main">
               <a:ext uri="{FF2B5EF4-FFF2-40B4-BE49-F238E27FC236}">
-                <a16:creationId xmlns:a16="http://schemas.microsoft.com/office/drawing/2014/main" id="{8D567DA1-F84F-4BAF-A2BE-99A1152DD77F}"/>
+                <a16:creationId xmlns:a16="http://schemas.microsoft.com/office/drawing/2014/main" id="{74DFA2FA-ED11-49DB-9FFC-E5A2AA3D1FF2}"/>
               </a:ext>
             </a:extLst>
           </p:cNvPr>
@@ -12744,7 +12744,7 @@
           <p:cNvPr id="11" name="">
             <a:extLst xmlns:a="http://schemas.openxmlformats.org/drawingml/2006/main">
               <a:ext uri="{FF2B5EF4-FFF2-40B4-BE49-F238E27FC236}">
-                <a16:creationId xmlns:a16="http://schemas.microsoft.com/office/drawing/2014/main" id="{D92EC939-7F9B-4DA4-A19F-4928EF1C159E}"/>
+                <a16:creationId xmlns:a16="http://schemas.microsoft.com/office/drawing/2014/main" id="{AF7AC6CD-EF28-4482-8432-1852C9A64918}"/>
               </a:ext>
             </a:extLst>
           </p:cNvPr>
@@ -12806,7 +12806,7 @@
           <p:cNvPr id="12" name="">
             <a:extLst xmlns:a="http://schemas.openxmlformats.org/drawingml/2006/main">
               <a:ext uri="{FF2B5EF4-FFF2-40B4-BE49-F238E27FC236}">
-                <a16:creationId xmlns:a16="http://schemas.microsoft.com/office/drawing/2014/main" id="{7ABB5A48-FD2D-4639-A039-BDA0DAC4BE64}"/>
+                <a16:creationId xmlns:a16="http://schemas.microsoft.com/office/drawing/2014/main" id="{2EF7DC72-E8AD-440C-91D8-55A3655854EC}"/>
               </a:ext>
             </a:extLst>
           </p:cNvPr>
@@ -12864,7 +12864,7 @@
           <p:cNvPr id="13" name="">
             <a:extLst xmlns:a="http://schemas.openxmlformats.org/drawingml/2006/main">
               <a:ext uri="{FF2B5EF4-FFF2-40B4-BE49-F238E27FC236}">
-                <a16:creationId xmlns:a16="http://schemas.microsoft.com/office/drawing/2014/main" id="{FBE3D340-4C7A-4763-9197-F14DC08B3ADF}"/>
+                <a16:creationId xmlns:a16="http://schemas.microsoft.com/office/drawing/2014/main" id="{033D4C36-2055-4AA2-93F5-6CD1986707FF}"/>
               </a:ext>
             </a:extLst>
           </p:cNvPr>
@@ -12953,7 +12953,7 @@
           <p:cNvPr id="14" name="">
             <a:extLst xmlns:a="http://schemas.openxmlformats.org/drawingml/2006/main">
               <a:ext uri="{FF2B5EF4-FFF2-40B4-BE49-F238E27FC236}">
-                <a16:creationId xmlns:a16="http://schemas.microsoft.com/office/drawing/2014/main" id="{D005E067-D70B-4083-8870-5F7DBA48AE28}"/>
+                <a16:creationId xmlns:a16="http://schemas.microsoft.com/office/drawing/2014/main" id="{1FF580B5-A168-4DBF-9C63-8D51637ADF96}"/>
               </a:ext>
             </a:extLst>
           </p:cNvPr>
@@ -12988,7 +12988,7 @@
           <p:cNvPr id="15" name="">
             <a:extLst xmlns:a="http://schemas.openxmlformats.org/drawingml/2006/main">
               <a:ext uri="{FF2B5EF4-FFF2-40B4-BE49-F238E27FC236}">
-                <a16:creationId xmlns:a16="http://schemas.microsoft.com/office/drawing/2014/main" id="{EF4FFF3C-B2DE-43A0-9E75-D0C928EE2D8F}"/>
+                <a16:creationId xmlns:a16="http://schemas.microsoft.com/office/drawing/2014/main" id="{B2DACC82-FE40-40A8-8E78-EA79C3AC9D2E}"/>
               </a:ext>
             </a:extLst>
           </p:cNvPr>
@@ -13050,7 +13050,7 @@
           <p:cNvPr id="16" name="">
             <a:extLst xmlns:a="http://schemas.openxmlformats.org/drawingml/2006/main">
               <a:ext uri="{FF2B5EF4-FFF2-40B4-BE49-F238E27FC236}">
-                <a16:creationId xmlns:a16="http://schemas.microsoft.com/office/drawing/2014/main" id="{A75005DC-20A4-4B29-932C-E7E72024AAB3}"/>
+                <a16:creationId xmlns:a16="http://schemas.microsoft.com/office/drawing/2014/main" id="{C9FE2B35-D62E-4872-B43C-5B58FFFCE80E}"/>
               </a:ext>
             </a:extLst>
           </p:cNvPr>
@@ -13108,7 +13108,7 @@
           <p:cNvPr id="17" name="">
             <a:extLst xmlns:a="http://schemas.openxmlformats.org/drawingml/2006/main">
               <a:ext uri="{FF2B5EF4-FFF2-40B4-BE49-F238E27FC236}">
-                <a16:creationId xmlns:a16="http://schemas.microsoft.com/office/drawing/2014/main" id="{881B6DE6-4534-4B28-8629-1E3CD668B50B}"/>
+                <a16:creationId xmlns:a16="http://schemas.microsoft.com/office/drawing/2014/main" id="{3310084C-0E0B-404D-968F-CB64B443EB7A}"/>
               </a:ext>
             </a:extLst>
           </p:cNvPr>
@@ -13197,7 +13197,7 @@
           <p:cNvPr id="18" name="">
             <a:extLst xmlns:a="http://schemas.openxmlformats.org/drawingml/2006/main">
               <a:ext uri="{FF2B5EF4-FFF2-40B4-BE49-F238E27FC236}">
-                <a16:creationId xmlns:a16="http://schemas.microsoft.com/office/drawing/2014/main" id="{AF114AA1-ECB4-4B39-92F4-08342C9D40A4}"/>
+                <a16:creationId xmlns:a16="http://schemas.microsoft.com/office/drawing/2014/main" id="{8527374B-B8DE-4987-89F8-346558C66B1A}"/>
               </a:ext>
             </a:extLst>
           </p:cNvPr>
@@ -13232,7 +13232,7 @@
           <p:cNvPr id="19" name="">
             <a:extLst xmlns:a="http://schemas.openxmlformats.org/drawingml/2006/main">
               <a:ext uri="{FF2B5EF4-FFF2-40B4-BE49-F238E27FC236}">
-                <a16:creationId xmlns:a16="http://schemas.microsoft.com/office/drawing/2014/main" id="{1C9E5078-0CD3-4A58-B894-04B4E2309034}"/>
+                <a16:creationId xmlns:a16="http://schemas.microsoft.com/office/drawing/2014/main" id="{BBBFDD7B-8E97-46B8-BE98-B7729D7130BF}"/>
               </a:ext>
             </a:extLst>
           </p:cNvPr>
@@ -13294,7 +13294,7 @@
           <p:cNvPr id="20" name="">
             <a:extLst xmlns:a="http://schemas.openxmlformats.org/drawingml/2006/main">
               <a:ext uri="{FF2B5EF4-FFF2-40B4-BE49-F238E27FC236}">
-                <a16:creationId xmlns:a16="http://schemas.microsoft.com/office/drawing/2014/main" id="{E68F061B-0FB7-44AD-AF89-9CD22E65A0CD}"/>
+                <a16:creationId xmlns:a16="http://schemas.microsoft.com/office/drawing/2014/main" id="{05222F9D-A868-4019-963A-595D4C73C118}"/>
               </a:ext>
             </a:extLst>
           </p:cNvPr>
@@ -13352,7 +13352,7 @@
           <p:cNvPr id="21" name="">
             <a:extLst xmlns:a="http://schemas.openxmlformats.org/drawingml/2006/main">
               <a:ext uri="{FF2B5EF4-FFF2-40B4-BE49-F238E27FC236}">
-                <a16:creationId xmlns:a16="http://schemas.microsoft.com/office/drawing/2014/main" id="{801A29A0-E17E-43EB-B815-2C0BB07BCCC2}"/>
+                <a16:creationId xmlns:a16="http://schemas.microsoft.com/office/drawing/2014/main" id="{937F3703-AE7E-44B5-A486-E5DEF564B956}"/>
               </a:ext>
             </a:extLst>
           </p:cNvPr>
@@ -13441,7 +13441,7 @@
           <p:cNvPr id="22" name="">
             <a:extLst xmlns:a="http://schemas.openxmlformats.org/drawingml/2006/main">
               <a:ext uri="{FF2B5EF4-FFF2-40B4-BE49-F238E27FC236}">
-                <a16:creationId xmlns:a16="http://schemas.microsoft.com/office/drawing/2014/main" id="{936AECE1-526E-4654-8C09-F885341F62B9}"/>
+                <a16:creationId xmlns:a16="http://schemas.microsoft.com/office/drawing/2014/main" id="{96C27A5C-E3DA-461D-8837-0ED8E3BF1434}"/>
               </a:ext>
             </a:extLst>
           </p:cNvPr>
@@ -13476,7 +13476,7 @@
           <p:cNvPr id="23" name="">
             <a:extLst xmlns:a="http://schemas.openxmlformats.org/drawingml/2006/main">
               <a:ext uri="{FF2B5EF4-FFF2-40B4-BE49-F238E27FC236}">
-                <a16:creationId xmlns:a16="http://schemas.microsoft.com/office/drawing/2014/main" id="{64ED0374-C51B-40F8-B691-A3B465567363}"/>
+                <a16:creationId xmlns:a16="http://schemas.microsoft.com/office/drawing/2014/main" id="{6206DC2E-9D4D-4BEC-990E-781BFAACF130}"/>
               </a:ext>
             </a:extLst>
           </p:cNvPr>
@@ -13534,7 +13534,7 @@
           <p:cNvPr id="24" name="slide-number-9">
             <a:extLst xmlns:a="http://schemas.openxmlformats.org/drawingml/2006/main">
               <a:ext uri="{FF2B5EF4-FFF2-40B4-BE49-F238E27FC236}">
-                <a16:creationId xmlns:a16="http://schemas.microsoft.com/office/drawing/2014/main" id="{F19EC554-2F7F-47C7-B09D-06FE1D04F9F2}"/>
+                <a16:creationId xmlns:a16="http://schemas.microsoft.com/office/drawing/2014/main" id="{9673857F-EEFA-40FA-B9EB-CEDD6082E675}"/>
               </a:ext>
             </a:extLst>
           </p:cNvPr>
@@ -13590,7 +13590,7 @@
     </p:spTree>
     <p:extLst>
       <p:ext uri="{BB962C8B-B14F-4D97-AF65-F5344CB8AC3E}">
-        <p14:creationId xmlns:p14="http://schemas.microsoft.com/office/powerpoint/2010/main" val="1816725033"/>
+        <p14:creationId xmlns:p14="http://schemas.microsoft.com/office/powerpoint/2010/main" val="504528141"/>
       </p:ext>
     </p:extLst>
   </p:cSld>

</xml_diff>